<commit_message>
Update course materials for Azure VM and networking concepts
- Revised the comparison table for Azure VM components to align with Multipass terminology.
- Updated the SSH key reference in the Azure Compute section to reflect the correct assignment.
- Modified the networking problem-solving statement in the Azure Networking section for clarity.
- Adjusted the learning objectives in the Automation section to specify tools used.
- Enhanced the README to include additional topics covered in the virtualization chapter.
- Updated the VM networking diagram to reflect accurate IP addresses and descriptions.
- Revised the diagram generation script to match the updated networking diagram.
- Adjusted presentation content to reflect changes in course structure and objectives.
</commit_message>
<xml_diff>
--- a/praesentationen/input-01-virtualisierung.pptx
+++ b/praesentationen/input-01-virtualisierung.pptx
@@ -19,10 +19,9 @@
     <p:sldId id="267" r:id="rId13"/>
     <p:sldId id="268" r:id="rId14"/>
     <p:sldId id="269" r:id="rId15"/>
-    <p:sldId id="270" r:id="rId16"/>
   </p:sldIdLst>
   <p:notesMasterIdLst>
-    <p:notesMasterId r:id="rId17"/>
+    <p:notesMasterId r:id="rId16"/>
   </p:notesMasterIdLst>
   <p:sldSz cx="12192000" cy="6858000"/>
   <p:notesSz cx="6858000" cy="12192000"/>
@@ -121,7 +120,7 @@
   <p:extLst>
     <p:ext uri="{521415D9-36F7-43E2-AB2F-B90AF26B5E84}">
       <p14:sectionLst xmlns:p14="http://schemas.microsoft.com/office/powerpoint/2010/main">
-        <p14:section name="Virtualisierung" id="{611d5e2b-c4de-cd2f-a0f2-5fafb4f866e9}">
+        <p14:section name="Virtualisierung" id="{add753b8-0544-1c52-25dd-5d5600fd090d}">
           <p14:sldIdLst>
             <p14:sldId id="256"/>
             <p14:sldId id="257"/>
@@ -129,11 +128,11 @@
             <p14:sldId id="259"/>
             <p14:sldId id="260"/>
             <p14:sldId id="261"/>
+            <p14:sldId id="262"/>
           </p14:sldIdLst>
         </p14:section>
-        <p14:section name="VM-Netzwerk" id="{d71462b8-c523-40de-de8c-d76ebfdb9930}">
+        <p14:section name="Multipass und cloud-init" id="{61530268-62e9-8b90-8bde-2058214fd967}">
           <p14:sldIdLst>
-            <p14:sldId id="262"/>
             <p14:sldId id="263"/>
             <p14:sldId id="264"/>
             <p14:sldId id="265"/>
@@ -141,7 +140,6 @@
             <p14:sldId id="267"/>
             <p14:sldId id="268"/>
             <p14:sldId id="269"/>
-            <p14:sldId id="270"/>
           </p14:sldIdLst>
         </p14:section>
       </p14:sectionLst>
@@ -636,7 +634,7 @@
           <a:p>
             <a:r>
               <a:rPr lang="en-US" dirty="0"/>
-              <a:t>Live-Demo: ssh-keygen -t ed25519, dann Login ohne Passwort.</a:t>
+              <a:t>Live-Demo: multipass launch --name auto --cloud-init cloud-init-tag1.yaml. Betonen: läuft nur beim ersten Start. In Azure an Tag 5 genau gleich.</a:t>
             </a:r>
             <a:endParaRPr lang="en-US" dirty="0"/>
           </a:p>
@@ -724,7 +722,7 @@
           <a:p>
             <a:r>
               <a:rPr lang="en-US" dirty="0"/>
-              <a:t/>
+              <a:t>Kurz vor Auftrag 1.5. Live: ssh-keygen -t ed25519.</a:t>
             </a:r>
             <a:endParaRPr lang="en-US" dirty="0"/>
           </a:p>
@@ -812,7 +810,7 @@
           <a:p>
             <a:r>
               <a:rPr lang="en-US" dirty="0"/>
-              <a:t>Image = Vorlage, Container = laufende Instanz. Registries wie Docker Hub. Container sind optional (⭐ Auftrag 1.5).</a:t>
+              <a:t>VirtualBox Typ 2, Hyper-V Typ 1. Nur beim ersten Start. Nein, Container teilen den Kernel.</a:t>
             </a:r>
             <a:endParaRPr lang="en-US" dirty="0"/>
           </a:p>
@@ -900,7 +898,7 @@
           <a:p>
             <a:r>
               <a:rPr lang="en-US" dirty="0"/>
-              <a:t>Nein, Container teilen den Kernel. Zeitscheiben. Gewollt – NAT versteckt die VM.</a:t>
+              <a:t/>
             </a:r>
             <a:endParaRPr lang="en-US" dirty="0"/>
           </a:p>
@@ -1030,94 +1028,6 @@
 </p:notes>
 </file>
 
-<file path=ppt/notesSlides/notesSlide15.xml><?xml version="1.0" encoding="utf-8"?>
-<p:notes xmlns:a="http://schemas.openxmlformats.org/drawingml/2006/main" xmlns:r="http://schemas.openxmlformats.org/officeDocument/2006/relationships" xmlns:p="http://schemas.openxmlformats.org/presentationml/2006/main">
-  <p:cSld>
-    <p:spTree>
-      <p:nvGrpSpPr>
-        <p:cNvPr id="1" name=""/>
-        <p:cNvGrpSpPr/>
-        <p:nvPr/>
-      </p:nvGrpSpPr>
-      <p:grpSpPr>
-        <a:xfrm>
-          <a:off x="0" y="0"/>
-          <a:ext cx="0" cy="0"/>
-          <a:chOff x="0" y="0"/>
-          <a:chExt cx="0" cy="0"/>
-        </a:xfrm>
-      </p:grpSpPr>
-      <p:sp>
-        <p:nvSpPr>
-          <p:cNvPr id="2" name="Slide Image Placeholder 1"/>
-          <p:cNvSpPr>
-            <a:spLocks noGrp="1" noRot="1" noChangeAspect="1"/>
-          </p:cNvSpPr>
-          <p:nvPr>
-            <p:ph type="sldImg"/>
-          </p:nvPr>
-        </p:nvSpPr>
-        <p:spPr/>
-      </p:sp>
-      <p:sp>
-        <p:nvSpPr>
-          <p:cNvPr id="3" name="Notes Placeholder 2"/>
-          <p:cNvSpPr>
-            <a:spLocks noGrp="1"/>
-          </p:cNvSpPr>
-          <p:nvPr>
-            <p:ph type="body" idx="1"/>
-          </p:nvPr>
-        </p:nvSpPr>
-        <p:spPr/>
-        <p:txBody>
-          <a:bodyPr/>
-          <a:lstStyle/>
-          <a:p>
-            <a:r>
-              <a:rPr lang="en-US" dirty="0"/>
-              <a:t/>
-            </a:r>
-            <a:endParaRPr lang="en-US" dirty="0"/>
-          </a:p>
-        </p:txBody>
-      </p:sp>
-      <p:sp>
-        <p:nvSpPr>
-          <p:cNvPr id="4" name="Slide Number Placeholder 3"/>
-          <p:cNvSpPr>
-            <a:spLocks noGrp="1"/>
-          </p:cNvSpPr>
-          <p:nvPr>
-            <p:ph type="sldNum" sz="quarter" idx="10"/>
-          </p:nvPr>
-        </p:nvSpPr>
-        <p:spPr/>
-        <p:txBody>
-          <a:bodyPr/>
-          <a:lstStyle/>
-          <a:p>
-            <a:fld id="{F7021451-1387-4CA6-816F-3879F97B5CBC}" type="slidenum">
-              <a:rPr lang="en-US"/>
-              <a:t>15</a:t>
-            </a:fld>
-            <a:endParaRPr lang="en-US"/>
-          </a:p>
-        </p:txBody>
-      </p:sp>
-    </p:spTree>
-    <p:extLst>
-      <p:ext uri="{BB962C8B-B14F-4D97-AF65-F5344CB8AC3E}">
-        <p14:creationId xmlns:p14="http://schemas.microsoft.com/office/powerpoint/2010/main" val="1024086991"/>
-      </p:ext>
-    </p:extLst>
-  </p:cSld>
-  <p:clrMapOvr>
-    <a:masterClrMapping/>
-  </p:clrMapOvr>
-</p:notes>
-</file>
-
 <file path=ppt/notesSlides/notesSlide2.xml><?xml version="1.0" encoding="utf-8"?>
 <p:notes xmlns:a="http://schemas.openxmlformats.org/drawingml/2006/main" xmlns:r="http://schemas.openxmlformats.org/officeDocument/2006/relationships" xmlns:p="http://schemas.openxmlformats.org/presentationml/2006/main">
   <p:cSld>
@@ -1252,7 +1162,7 @@
           <a:p>
             <a:r>
               <a:rPr lang="en-US" dirty="0"/>
-              <a:t>Live-Demo: VirtualBox öffnen, eine VM zeigen, Einstellungen CPU/RAM/Disk.</a:t>
+              <a:t>Live-Demo: Hyper-V-Manager öffnen und eine laufende Multipass-VM zeigen.</a:t>
             </a:r>
             <a:endParaRPr lang="en-US" dirty="0"/>
           </a:p>
@@ -1516,7 +1426,7 @@
           <a:p>
             <a:r>
               <a:rPr lang="en-US" dirty="0"/>
-              <a:t>Eine einzelne VM bekommt höchstens so viele vCPUs, wie der Host logische Prozessoren hat.</a:t>
+              <a:t>Für ICT-Fachleute reicht diese Ebene. Zeitscheiben und Swap nur auf Nachfrage vertiefen.</a:t>
             </a:r>
             <a:endParaRPr lang="en-US" dirty="0"/>
           </a:p>
@@ -1604,7 +1514,7 @@
           <a:p>
             <a:r>
               <a:rPr lang="en-US" dirty="0"/>
-              <a:t/>
+              <a:t>Container teilen den Kernel, VMs bringen ein ganzes Betriebssystem mit. Container sind optional (⭐ Auftrag 1.6).</a:t>
             </a:r>
             <a:endParaRPr lang="en-US" dirty="0"/>
           </a:p>
@@ -1692,7 +1602,7 @@
           <a:p>
             <a:r>
               <a:rPr lang="en-US" dirty="0"/>
-              <a:t>Live-Demo: Netzwerkadapter in VirtualBox umstellen, ip a in der VM zeigen.</a:t>
+              <a:t/>
             </a:r>
             <a:endParaRPr lang="en-US" dirty="0"/>
           </a:p>
@@ -1780,7 +1690,7 @@
           <a:p>
             <a:r>
               <a:rPr lang="en-US" dirty="0"/>
-              <a:t/>
+              <a:t>Multipass lädt Ubuntu selbst herunter und verwendet im Hintergrund Hyper-V.</a:t>
             </a:r>
             <a:endParaRPr lang="en-US" dirty="0"/>
           </a:p>
@@ -2927,7 +2837,7 @@
                   <a:srgbClr val="DEE2FB"/>
                 </a:solidFill>
               </a:rPr>
-              <a:t>Input 1 und 2 · Tag 1</a:t>
+              <a:t>Inputs Tag 1</a:t>
             </a:r>
             <a:endParaRPr lang="en-US" sz="2000" dirty="0"/>
           </a:p>
@@ -2990,7 +2900,7 @@
                   <a:srgbClr val="27303A"/>
                 </a:solidFill>
               </a:rPr>
-              <a:t>SSH-Schlüssel: Schloss und Schlüssel</a:t>
+              <a:t>cloud-init: die VM richtet sich selbst ein</a:t>
             </a:r>
             <a:endParaRPr lang="en-US" sz="3400" dirty="0"/>
           </a:p>
@@ -2998,250 +2908,19 @@
       </p:sp>
       <p:sp>
         <p:nvSpPr>
-          <p:cNvPr id="3" name="vergleich"/>
+          <p:cNvPr id="3" name="code-box"/>
           <p:cNvSpPr/>
           <p:nvPr/>
         </p:nvSpPr>
         <p:spPr>
           <a:xfrm>
             <a:off x="548640" y="1325880"/>
-            <a:ext cx="5364328" cy="4709160"/>
+            <a:ext cx="7680960" cy="4709160"/>
           </a:xfrm>
           <a:prstGeom prst="roundRect">
             <a:avLst>
-              <a:gd name="adj" fmla="val 2330"/>
+              <a:gd name="adj" fmla="val 1942"/>
             </a:avLst>
-          </a:prstGeom>
-          <a:solidFill>
-            <a:srgbClr val="F7F7F7"/>
-          </a:solidFill>
-          <a:ln w="12700">
-            <a:solidFill>
-              <a:srgbClr val="F7F7F7"/>
-            </a:solidFill>
-            <a:prstDash val="solid"/>
-          </a:ln>
-        </p:spPr>
-      </p:sp>
-      <p:sp>
-        <p:nvSpPr>
-          <p:cNvPr id="4" name="icon-kreis-FaLock"/>
-          <p:cNvSpPr/>
-          <p:nvPr/>
-        </p:nvSpPr>
-        <p:spPr>
-          <a:xfrm>
-            <a:off x="868680" y="1600200"/>
-            <a:ext cx="685800" cy="685800"/>
-          </a:xfrm>
-          <a:prstGeom prst="ellipse">
-            <a:avLst/>
-          </a:prstGeom>
-          <a:solidFill>
-            <a:srgbClr val="006FAD"/>
-          </a:solidFill>
-          <a:ln w="12700">
-            <a:solidFill>
-              <a:srgbClr val="006FAD"/>
-            </a:solidFill>
-            <a:prstDash val="solid"/>
-          </a:ln>
-        </p:spPr>
-      </p:sp>
-      <p:pic>
-        <p:nvPicPr>
-          <p:cNvPr id="5" name="icon-FaLock" descr="C:\Users\Thanam\AppData\Local\Temp\claude\c--Projekt-Trainings-azure-basics-training\a9e0bf4e-0d08-4082-a38a-5b8886538508\scratchpad\pptx\assets\icons\FaLock.png">    </p:cNvPr>
-          <p:cNvPicPr>
-            <a:picLocks noChangeAspect="1"/>
-          </p:cNvPicPr>
-          <p:nvPr/>
-        </p:nvPicPr>
-        <p:blipFill>
-          <a:blip r:embed="rId1"/>
-          <a:stretch>
-            <a:fillRect/>
-          </a:stretch>
-        </p:blipFill>
-        <p:spPr>
-          <a:xfrm>
-            <a:off x="1033272" y="1764792"/>
-            <a:ext cx="356616" cy="356616"/>
-          </a:xfrm>
-          <a:prstGeom prst="rect">
-            <a:avLst/>
-          </a:prstGeom>
-        </p:spPr>
-      </p:pic>
-      <p:sp>
-        <p:nvSpPr>
-          <p:cNvPr id="6" name="Text 3"/>
-          <p:cNvSpPr txBox="1"/>
-          <p:nvPr/>
-        </p:nvSpPr>
-        <p:spPr>
-          <a:xfrm>
-            <a:off x="1737360" y="1600200"/>
-            <a:ext cx="3901288" cy="685800"/>
-          </a:xfrm>
-          <a:prstGeom prst="rect">
-            <a:avLst/>
-          </a:prstGeom>
-          <a:noFill/>
-          <a:ln/>
-        </p:spPr>
-        <p:txBody>
-          <a:bodyPr wrap="square" lIns="0" tIns="0" rIns="0" bIns="0" rtlCol="0" anchor="ctr"/>
-          <a:lstStyle/>
-          <a:p>
-            <a:pPr indent="0" marL="0">
-              <a:buNone/>
-            </a:pPr>
-            <a:r>
-              <a:rPr lang="en-US" sz="2200" b="1" dirty="0">
-                <a:solidFill>
-                  <a:srgbClr val="27303A"/>
-                </a:solidFill>
-              </a:rPr>
-              <a:t>Öffentlicher Schlüssel</a:t>
-            </a:r>
-            <a:endParaRPr lang="en-US" sz="2200" dirty="0"/>
-          </a:p>
-        </p:txBody>
-      </p:sp>
-      <p:sp>
-        <p:nvSpPr>
-          <p:cNvPr id="7" name="Text 4"/>
-          <p:cNvSpPr txBox="1"/>
-          <p:nvPr/>
-        </p:nvSpPr>
-        <p:spPr>
-          <a:xfrm>
-            <a:off x="868680" y="2514600"/>
-            <a:ext cx="4724248" cy="3337560"/>
-          </a:xfrm>
-          <a:prstGeom prst="rect">
-            <a:avLst/>
-          </a:prstGeom>
-          <a:noFill/>
-          <a:ln/>
-        </p:spPr>
-        <p:txBody>
-          <a:bodyPr wrap="square" lIns="0" tIns="0" rIns="0" bIns="0" rtlCol="0" anchor="t"/>
-          <a:lstStyle/>
-          <a:p>
-            <a:pPr marL="342900" indent="-342900">
-              <a:spcAft>
-                <a:spcPts val="800"/>
-              </a:spcAft>
-              <a:buSzPct val="100000"/>
-              <a:buChar char="•"/>
-            </a:pPr>
-            <a:r>
-              <a:rPr lang="en-US" sz="1800" dirty="0">
-                <a:solidFill>
-                  <a:srgbClr val="27303A"/>
-                </a:solidFill>
-              </a:rPr>
-              <a:t>id_ed25519.pub</a:t>
-            </a:r>
-            <a:endParaRPr lang="en-US" sz="1800" dirty="0"/>
-          </a:p>
-          <a:p>
-            <a:pPr marL="342900" indent="-342900">
-              <a:spcAft>
-                <a:spcPts val="800"/>
-              </a:spcAft>
-              <a:buSzPct val="100000"/>
-              <a:buChar char="•"/>
-            </a:pPr>
-            <a:r>
-              <a:rPr lang="en-US" sz="1800" dirty="0">
-                <a:solidFill>
-                  <a:srgbClr val="27303A"/>
-                </a:solidFill>
-              </a:rPr>
-              <a:t>das Schloss – an beliebig viele Türen montieren</a:t>
-            </a:r>
-            <a:endParaRPr lang="en-US" sz="1800" dirty="0"/>
-          </a:p>
-          <a:p>
-            <a:pPr marL="342900" indent="-342900">
-              <a:spcAft>
-                <a:spcPts val="800"/>
-              </a:spcAft>
-              <a:buSzPct val="100000"/>
-              <a:buChar char="•"/>
-            </a:pPr>
-            <a:r>
-              <a:rPr lang="en-US" sz="1800" dirty="0">
-                <a:solidFill>
-                  <a:srgbClr val="27303A"/>
-                </a:solidFill>
-              </a:rPr>
-              <a:t>liegt auf dem Server in ~/.ssh/authorized_keys</a:t>
-            </a:r>
-            <a:endParaRPr lang="en-US" sz="1800" dirty="0"/>
-          </a:p>
-          <a:p>
-            <a:pPr marL="342900" indent="-342900">
-              <a:spcAft>
-                <a:spcPts val="800"/>
-              </a:spcAft>
-              <a:buSzPct val="100000"/>
-              <a:buChar char="•"/>
-            </a:pPr>
-            <a:r>
-              <a:rPr lang="en-US" sz="1800" dirty="0">
-                <a:solidFill>
-                  <a:srgbClr val="27303A"/>
-                </a:solidFill>
-              </a:rPr>
-              <a:t>darf jeder sehen</a:t>
-            </a:r>
-            <a:endParaRPr lang="en-US" sz="1800" dirty="0"/>
-          </a:p>
-        </p:txBody>
-      </p:sp>
-      <p:sp>
-        <p:nvSpPr>
-          <p:cNvPr id="8" name="vergleich"/>
-          <p:cNvSpPr/>
-          <p:nvPr/>
-        </p:nvSpPr>
-        <p:spPr>
-          <a:xfrm>
-            <a:off x="6278728" y="1325880"/>
-            <a:ext cx="5364328" cy="4709160"/>
-          </a:xfrm>
-          <a:prstGeom prst="roundRect">
-            <a:avLst>
-              <a:gd name="adj" fmla="val 2330"/>
-            </a:avLst>
-          </a:prstGeom>
-          <a:solidFill>
-            <a:srgbClr val="DEE2FB"/>
-          </a:solidFill>
-          <a:ln w="12700">
-            <a:solidFill>
-              <a:srgbClr val="DEE2FB"/>
-            </a:solidFill>
-            <a:prstDash val="solid"/>
-          </a:ln>
-        </p:spPr>
-      </p:sp>
-      <p:sp>
-        <p:nvSpPr>
-          <p:cNvPr id="9" name="icon-kreis-FaKey"/>
-          <p:cNvSpPr/>
-          <p:nvPr/>
-        </p:nvSpPr>
-        <p:spPr>
-          <a:xfrm>
-            <a:off x="6598768" y="1600200"/>
-            <a:ext cx="685800" cy="685800"/>
-          </a:xfrm>
-          <a:prstGeom prst="ellipse">
-            <a:avLst/>
           </a:prstGeom>
           <a:solidFill>
             <a:srgbClr val="27303A"/>
@@ -3254,40 +2933,16 @@
           </a:ln>
         </p:spPr>
       </p:sp>
-      <p:pic>
-        <p:nvPicPr>
-          <p:cNvPr id="10" name="icon-FaKey" descr="C:\Users\Thanam\AppData\Local\Temp\claude\c--Projekt-Trainings-azure-basics-training\a9e0bf4e-0d08-4082-a38a-5b8886538508\scratchpad\pptx\assets\icons\FaKey.png">    </p:cNvPr>
-          <p:cNvPicPr>
-            <a:picLocks noChangeAspect="1"/>
-          </p:cNvPicPr>
-          <p:nvPr/>
-        </p:nvPicPr>
-        <p:blipFill>
-          <a:blip r:embed="rId2"/>
-          <a:stretch>
-            <a:fillRect/>
-          </a:stretch>
-        </p:blipFill>
-        <p:spPr>
-          <a:xfrm>
-            <a:off x="6763360" y="1764792"/>
-            <a:ext cx="356616" cy="356616"/>
-          </a:xfrm>
-          <a:prstGeom prst="rect">
-            <a:avLst/>
-          </a:prstGeom>
-        </p:spPr>
-      </p:pic>
-      <p:sp>
-        <p:nvSpPr>
-          <p:cNvPr id="11" name="Text 7"/>
+      <p:sp>
+        <p:nvSpPr>
+          <p:cNvPr id="4" name="Text 2"/>
           <p:cNvSpPr txBox="1"/>
           <p:nvPr/>
         </p:nvSpPr>
         <p:spPr>
           <a:xfrm>
-            <a:off x="7467448" y="1600200"/>
-            <a:ext cx="3901288" cy="685800"/>
+            <a:off x="822960" y="1554480"/>
+            <a:ext cx="7132320" cy="4251960"/>
           </a:xfrm>
           <a:prstGeom prst="rect">
             <a:avLst/>
@@ -3296,34 +2951,207 @@
           <a:ln/>
         </p:spPr>
         <p:txBody>
-          <a:bodyPr wrap="square" lIns="0" tIns="0" rIns="0" bIns="0" rtlCol="0" anchor="ctr"/>
+          <a:bodyPr wrap="square" lIns="0" tIns="0" rIns="0" bIns="0" rtlCol="0" anchor="t"/>
           <a:lstStyle/>
           <a:p>
             <a:pPr indent="0" marL="0">
               <a:buNone/>
             </a:pPr>
             <a:r>
-              <a:rPr lang="en-US" sz="2200" b="1" dirty="0">
-                <a:solidFill>
-                  <a:srgbClr val="27303A"/>
-                </a:solidFill>
-              </a:rPr>
-              <a:t>Privater Schlüssel</a:t>
-            </a:r>
-            <a:endParaRPr lang="en-US" sz="2200" dirty="0"/>
-          </a:p>
-        </p:txBody>
-      </p:sp>
-      <p:sp>
-        <p:nvSpPr>
-          <p:cNvPr id="12" name="Text 8"/>
+              <a:rPr lang="en-US" sz="1600" dirty="0">
+                <a:solidFill>
+                  <a:srgbClr val="F7F7F7"/>
+                </a:solidFill>
+                <a:latin typeface="Courier New" pitchFamily="34" charset="0"/>
+                <a:ea typeface="Courier New" pitchFamily="34" charset="-122"/>
+                <a:cs typeface="Courier New" pitchFamily="34" charset="-120"/>
+              </a:rPr>
+              <a:t>#cloud-config</a:t>
+            </a:r>
+            <a:endParaRPr lang="en-US" sz="1600" dirty="0"/>
+          </a:p>
+          <a:p>
+            <a:pPr indent="0" marL="0">
+              <a:buNone/>
+            </a:pPr>
+            <a:r>
+              <a:rPr lang="en-US" sz="1600" dirty="0">
+                <a:solidFill>
+                  <a:srgbClr val="F7F7F7"/>
+                </a:solidFill>
+                <a:latin typeface="Courier New" pitchFamily="34" charset="0"/>
+                <a:ea typeface="Courier New" pitchFamily="34" charset="-122"/>
+                <a:cs typeface="Courier New" pitchFamily="34" charset="-120"/>
+              </a:rPr>
+              <a:t>package_update: true</a:t>
+            </a:r>
+            <a:endParaRPr lang="en-US" sz="1600" dirty="0"/>
+          </a:p>
+          <a:p>
+            <a:pPr indent="0" marL="0">
+              <a:buNone/>
+            </a:pPr>
+            <a:r>
+              <a:rPr lang="en-US" sz="1600" dirty="0">
+                <a:solidFill>
+                  <a:srgbClr val="F7F7F7"/>
+                </a:solidFill>
+                <a:latin typeface="Courier New" pitchFamily="34" charset="0"/>
+                <a:ea typeface="Courier New" pitchFamily="34" charset="-122"/>
+                <a:cs typeface="Courier New" pitchFamily="34" charset="-120"/>
+              </a:rPr>
+              <a:t>packages:</a:t>
+            </a:r>
+            <a:endParaRPr lang="en-US" sz="1600" dirty="0"/>
+          </a:p>
+          <a:p>
+            <a:pPr indent="0" marL="0">
+              <a:buNone/>
+            </a:pPr>
+            <a:r>
+              <a:rPr lang="en-US" sz="1600" dirty="0">
+                <a:solidFill>
+                  <a:srgbClr val="F7F7F7"/>
+                </a:solidFill>
+                <a:latin typeface="Courier New" pitchFamily="34" charset="0"/>
+                <a:ea typeface="Courier New" pitchFamily="34" charset="-122"/>
+                <a:cs typeface="Courier New" pitchFamily="34" charset="-120"/>
+              </a:rPr>
+              <a:t>  - tree</a:t>
+            </a:r>
+            <a:endParaRPr lang="en-US" sz="1600" dirty="0"/>
+          </a:p>
+          <a:p>
+            <a:pPr indent="0" marL="0">
+              <a:buNone/>
+            </a:pPr>
+            <a:r>
+              <a:rPr lang="en-US" sz="1600" dirty="0">
+                <a:solidFill>
+                  <a:srgbClr val="F7F7F7"/>
+                </a:solidFill>
+                <a:latin typeface="Courier New" pitchFamily="34" charset="0"/>
+                <a:ea typeface="Courier New" pitchFamily="34" charset="-122"/>
+                <a:cs typeface="Courier New" pitchFamily="34" charset="-120"/>
+              </a:rPr>
+              <a:t>  - htop</a:t>
+            </a:r>
+            <a:endParaRPr lang="en-US" sz="1600" dirty="0"/>
+          </a:p>
+          <a:p>
+            <a:pPr indent="0" marL="0">
+              <a:buNone/>
+            </a:pPr>
+            <a:r>
+              <a:rPr lang="en-US" sz="1600" dirty="0">
+                <a:solidFill>
+                  <a:srgbClr val="F7F7F7"/>
+                </a:solidFill>
+                <a:latin typeface="Courier New" pitchFamily="34" charset="0"/>
+                <a:ea typeface="Courier New" pitchFamily="34" charset="-122"/>
+                <a:cs typeface="Courier New" pitchFamily="34" charset="-120"/>
+              </a:rPr>
+              <a:t>write_files:</a:t>
+            </a:r>
+            <a:endParaRPr lang="en-US" sz="1600" dirty="0"/>
+          </a:p>
+          <a:p>
+            <a:pPr indent="0" marL="0">
+              <a:buNone/>
+            </a:pPr>
+            <a:r>
+              <a:rPr lang="en-US" sz="1600" dirty="0">
+                <a:solidFill>
+                  <a:srgbClr val="F7F7F7"/>
+                </a:solidFill>
+                <a:latin typeface="Courier New" pitchFamily="34" charset="0"/>
+                <a:ea typeface="Courier New" pitchFamily="34" charset="-122"/>
+                <a:cs typeface="Courier New" pitchFamily="34" charset="-120"/>
+              </a:rPr>
+              <a:t>  - path: /opt/willkommen.txt</a:t>
+            </a:r>
+            <a:endParaRPr lang="en-US" sz="1600" dirty="0"/>
+          </a:p>
+          <a:p>
+            <a:pPr indent="0" marL="0">
+              <a:buNone/>
+            </a:pPr>
+            <a:r>
+              <a:rPr lang="en-US" sz="1600" dirty="0">
+                <a:solidFill>
+                  <a:srgbClr val="F7F7F7"/>
+                </a:solidFill>
+                <a:latin typeface="Courier New" pitchFamily="34" charset="0"/>
+                <a:ea typeface="Courier New" pitchFamily="34" charset="-122"/>
+                <a:cs typeface="Courier New" pitchFamily="34" charset="-120"/>
+              </a:rPr>
+              <a:t>    content: |</a:t>
+            </a:r>
+            <a:endParaRPr lang="en-US" sz="1600" dirty="0"/>
+          </a:p>
+          <a:p>
+            <a:pPr indent="0" marL="0">
+              <a:buNone/>
+            </a:pPr>
+            <a:r>
+              <a:rPr lang="en-US" sz="1600" dirty="0">
+                <a:solidFill>
+                  <a:srgbClr val="F7F7F7"/>
+                </a:solidFill>
+                <a:latin typeface="Courier New" pitchFamily="34" charset="0"/>
+                <a:ea typeface="Courier New" pitchFamily="34" charset="-122"/>
+                <a:cs typeface="Courier New" pitchFamily="34" charset="-120"/>
+              </a:rPr>
+              <a:t>      Diese Datei hat cloud-init erstellt.</a:t>
+            </a:r>
+            <a:endParaRPr lang="en-US" sz="1600" dirty="0"/>
+          </a:p>
+          <a:p>
+            <a:pPr indent="0" marL="0">
+              <a:buNone/>
+            </a:pPr>
+            <a:r>
+              <a:rPr lang="en-US" sz="1600" dirty="0">
+                <a:solidFill>
+                  <a:srgbClr val="F7F7F7"/>
+                </a:solidFill>
+                <a:latin typeface="Courier New" pitchFamily="34" charset="0"/>
+                <a:ea typeface="Courier New" pitchFamily="34" charset="-122"/>
+                <a:cs typeface="Courier New" pitchFamily="34" charset="-120"/>
+              </a:rPr>
+              <a:t>runcmd:</a:t>
+            </a:r>
+            <a:endParaRPr lang="en-US" sz="1600" dirty="0"/>
+          </a:p>
+          <a:p>
+            <a:pPr indent="0" marL="0">
+              <a:buNone/>
+            </a:pPr>
+            <a:r>
+              <a:rPr lang="en-US" sz="1600" dirty="0">
+                <a:solidFill>
+                  <a:srgbClr val="F7F7F7"/>
+                </a:solidFill>
+                <a:latin typeface="Courier New" pitchFamily="34" charset="0"/>
+                <a:ea typeface="Courier New" pitchFamily="34" charset="-122"/>
+                <a:cs typeface="Courier New" pitchFamily="34" charset="-120"/>
+              </a:rPr>
+              <a:t>  - echo "Fertig am $(date)" &gt;&gt; /opt/willkommen.txt</a:t>
+            </a:r>
+            <a:endParaRPr lang="en-US" sz="1600" dirty="0"/>
+          </a:p>
+        </p:txBody>
+      </p:sp>
+      <p:sp>
+        <p:nvSpPr>
+          <p:cNvPr id="5" name="Text 3"/>
           <p:cNvSpPr txBox="1"/>
           <p:nvPr/>
         </p:nvSpPr>
         <p:spPr>
           <a:xfrm>
-            <a:off x="6598768" y="2514600"/>
-            <a:ext cx="4724248" cy="3337560"/>
+            <a:off x="8595360" y="1325880"/>
+            <a:ext cx="3047695" cy="1143000"/>
           </a:xfrm>
           <a:prstGeom prst="rect">
             <a:avLst/>
@@ -3335,76 +3163,182 @@
           <a:bodyPr wrap="square" lIns="0" tIns="0" rIns="0" bIns="0" rtlCol="0" anchor="t"/>
           <a:lstStyle/>
           <a:p>
-            <a:pPr marL="342900" indent="-342900">
-              <a:spcAft>
-                <a:spcPts val="800"/>
-              </a:spcAft>
-              <a:buSzPct val="100000"/>
-              <a:buChar char="•"/>
-            </a:pPr>
-            <a:r>
-              <a:rPr lang="en-US" sz="1800" dirty="0">
+            <a:pPr indent="0" marL="0">
+              <a:buNone/>
+            </a:pPr>
+            <a:r>
+              <a:rPr lang="en-US" sz="1700" b="1" dirty="0">
+                <a:solidFill>
+                  <a:srgbClr val="006FAD"/>
+                </a:solidFill>
+              </a:rPr>
+              <a:t>#cloud-config</a:t>
+            </a:r>
+            <a:endParaRPr lang="en-US" sz="1700" dirty="0"/>
+          </a:p>
+          <a:p>
+            <a:pPr indent="0" marL="0">
+              <a:buNone/>
+            </a:pPr>
+            <a:r>
+              <a:rPr lang="en-US" sz="1700" dirty="0">
                 <a:solidFill>
                   <a:srgbClr val="27303A"/>
                 </a:solidFill>
               </a:rPr>
-              <a:t>id_ed25519</a:t>
-            </a:r>
-            <a:endParaRPr lang="en-US" sz="1800" dirty="0"/>
-          </a:p>
-          <a:p>
-            <a:pPr marL="342900" indent="-342900">
-              <a:spcAft>
-                <a:spcPts val="800"/>
-              </a:spcAft>
-              <a:buSzPct val="100000"/>
-              <a:buChar char="•"/>
-            </a:pPr>
-            <a:r>
-              <a:rPr lang="en-US" sz="1800" dirty="0">
+              <a:t>muss die erste Zeile sein</a:t>
+            </a:r>
+            <a:endParaRPr lang="en-US" sz="1700" dirty="0"/>
+          </a:p>
+        </p:txBody>
+      </p:sp>
+      <p:sp>
+        <p:nvSpPr>
+          <p:cNvPr id="6" name="Text 4"/>
+          <p:cNvSpPr txBox="1"/>
+          <p:nvPr/>
+        </p:nvSpPr>
+        <p:spPr>
+          <a:xfrm>
+            <a:off x="8595360" y="2468880"/>
+            <a:ext cx="3047695" cy="1143000"/>
+          </a:xfrm>
+          <a:prstGeom prst="rect">
+            <a:avLst/>
+          </a:prstGeom>
+          <a:noFill/>
+          <a:ln/>
+        </p:spPr>
+        <p:txBody>
+          <a:bodyPr wrap="square" lIns="0" tIns="0" rIns="0" bIns="0" rtlCol="0" anchor="t"/>
+          <a:lstStyle/>
+          <a:p>
+            <a:pPr indent="0" marL="0">
+              <a:buNone/>
+            </a:pPr>
+            <a:r>
+              <a:rPr lang="en-US" sz="1700" b="1" dirty="0">
+                <a:solidFill>
+                  <a:srgbClr val="006FAD"/>
+                </a:solidFill>
+              </a:rPr>
+              <a:t>packages</a:t>
+            </a:r>
+            <a:endParaRPr lang="en-US" sz="1700" dirty="0"/>
+          </a:p>
+          <a:p>
+            <a:pPr indent="0" marL="0">
+              <a:buNone/>
+            </a:pPr>
+            <a:r>
+              <a:rPr lang="en-US" sz="1700" dirty="0">
                 <a:solidFill>
                   <a:srgbClr val="27303A"/>
                 </a:solidFill>
               </a:rPr>
-              <a:t>der einzige Schlüssel zum Schloss</a:t>
-            </a:r>
-            <a:endParaRPr lang="en-US" sz="1800" dirty="0"/>
-          </a:p>
-          <a:p>
-            <a:pPr marL="342900" indent="-342900">
-              <a:spcAft>
-                <a:spcPts val="800"/>
-              </a:spcAft>
-              <a:buSzPct val="100000"/>
-              <a:buChar char="•"/>
-            </a:pPr>
-            <a:r>
-              <a:rPr lang="en-US" sz="1800" dirty="0">
+              <a:t>Programme installieren</a:t>
+            </a:r>
+            <a:endParaRPr lang="en-US" sz="1700" dirty="0"/>
+          </a:p>
+        </p:txBody>
+      </p:sp>
+      <p:sp>
+        <p:nvSpPr>
+          <p:cNvPr id="7" name="Text 5"/>
+          <p:cNvSpPr txBox="1"/>
+          <p:nvPr/>
+        </p:nvSpPr>
+        <p:spPr>
+          <a:xfrm>
+            <a:off x="8595360" y="3611880"/>
+            <a:ext cx="3047695" cy="1143000"/>
+          </a:xfrm>
+          <a:prstGeom prst="rect">
+            <a:avLst/>
+          </a:prstGeom>
+          <a:noFill/>
+          <a:ln/>
+        </p:spPr>
+        <p:txBody>
+          <a:bodyPr wrap="square" lIns="0" tIns="0" rIns="0" bIns="0" rtlCol="0" anchor="t"/>
+          <a:lstStyle/>
+          <a:p>
+            <a:pPr indent="0" marL="0">
+              <a:buNone/>
+            </a:pPr>
+            <a:r>
+              <a:rPr lang="en-US" sz="1700" b="1" dirty="0">
+                <a:solidFill>
+                  <a:srgbClr val="006FAD"/>
+                </a:solidFill>
+              </a:rPr>
+              <a:t>write_files</a:t>
+            </a:r>
+            <a:endParaRPr lang="en-US" sz="1700" dirty="0"/>
+          </a:p>
+          <a:p>
+            <a:pPr indent="0" marL="0">
+              <a:buNone/>
+            </a:pPr>
+            <a:r>
+              <a:rPr lang="en-US" sz="1700" dirty="0">
                 <a:solidFill>
                   <a:srgbClr val="27303A"/>
                 </a:solidFill>
               </a:rPr>
-              <a:t>bleibt auf deinem Laptop in ~/.ssh/</a:t>
-            </a:r>
-            <a:endParaRPr lang="en-US" sz="1800" dirty="0"/>
-          </a:p>
-          <a:p>
-            <a:pPr marL="342900" indent="-342900">
-              <a:spcAft>
-                <a:spcPts val="800"/>
-              </a:spcAft>
-              <a:buSzPct val="100000"/>
-              <a:buChar char="•"/>
-            </a:pPr>
-            <a:r>
-              <a:rPr lang="en-US" sz="1800" dirty="0">
+              <a:t>Dateien anlegen</a:t>
+            </a:r>
+            <a:endParaRPr lang="en-US" sz="1700" dirty="0"/>
+          </a:p>
+        </p:txBody>
+      </p:sp>
+      <p:sp>
+        <p:nvSpPr>
+          <p:cNvPr id="8" name="Text 6"/>
+          <p:cNvSpPr txBox="1"/>
+          <p:nvPr/>
+        </p:nvSpPr>
+        <p:spPr>
+          <a:xfrm>
+            <a:off x="8595360" y="4754880"/>
+            <a:ext cx="3047695" cy="1143000"/>
+          </a:xfrm>
+          <a:prstGeom prst="rect">
+            <a:avLst/>
+          </a:prstGeom>
+          <a:noFill/>
+          <a:ln/>
+        </p:spPr>
+        <p:txBody>
+          <a:bodyPr wrap="square" lIns="0" tIns="0" rIns="0" bIns="0" rtlCol="0" anchor="t"/>
+          <a:lstStyle/>
+          <a:p>
+            <a:pPr indent="0" marL="0">
+              <a:buNone/>
+            </a:pPr>
+            <a:r>
+              <a:rPr lang="en-US" sz="1700" b="1" dirty="0">
+                <a:solidFill>
+                  <a:srgbClr val="006FAD"/>
+                </a:solidFill>
+              </a:rPr>
+              <a:t>runcmd</a:t>
+            </a:r>
+            <a:endParaRPr lang="en-US" sz="1700" dirty="0"/>
+          </a:p>
+          <a:p>
+            <a:pPr indent="0" marL="0">
+              <a:buNone/>
+            </a:pPr>
+            <a:r>
+              <a:rPr lang="en-US" sz="1700" dirty="0">
                 <a:solidFill>
                   <a:srgbClr val="27303A"/>
                 </a:solidFill>
               </a:rPr>
-              <a:t>nie teilen, nie in Git, nie per Chat</a:t>
-            </a:r>
-            <a:endParaRPr lang="en-US" sz="1800" dirty="0"/>
+              <a:t>Befehle ausführen</a:t>
+            </a:r>
+            <a:endParaRPr lang="en-US" sz="1700" dirty="0"/>
           </a:p>
         </p:txBody>
       </p:sp>
@@ -3510,7 +3444,7 @@
                   <a:srgbClr val="27303A"/>
                 </a:solidFill>
               </a:rPr>
-              <a:t>Snapshot und Klon</a:t>
+              <a:t>SSH-Schlüssel: Schloss und Schlüssel</a:t>
             </a:r>
             <a:endParaRPr lang="en-US" sz="3400" dirty="0"/>
           </a:p>
@@ -3545,7 +3479,7 @@
       </p:sp>
       <p:sp>
         <p:nvSpPr>
-          <p:cNvPr id="4" name="icon-kreis-FaCamera"/>
+          <p:cNvPr id="4" name="icon-kreis-FaLock"/>
           <p:cNvSpPr/>
           <p:nvPr/>
         </p:nvSpPr>
@@ -3570,7 +3504,7 @@
       </p:sp>
       <p:pic>
         <p:nvPicPr>
-          <p:cNvPr id="5" name="icon-FaCamera" descr="C:\Users\Thanam\AppData\Local\Temp\claude\c--Projekt-Trainings-azure-basics-training\a9e0bf4e-0d08-4082-a38a-5b8886538508\scratchpad\pptx\assets\icons\FaCamera.png">    </p:cNvPr>
+          <p:cNvPr id="5" name="icon-FaLock" descr="C:\Users\Thanam\AppData\Local\Temp\claude\c--Projekt-Trainings-azure-basics-training\a9e0bf4e-0d08-4082-a38a-5b8886538508\scratchpad\pptx\assets\icons\FaLock.png">    </p:cNvPr>
           <p:cNvPicPr>
             <a:picLocks noChangeAspect="1"/>
           </p:cNvPicPr>
@@ -3622,7 +3556,7 @@
                   <a:srgbClr val="27303A"/>
                 </a:solidFill>
               </a:rPr>
-              <a:t>Snapshot</a:t>
+              <a:t>Öffentlicher Schlüssel</a:t>
             </a:r>
             <a:endParaRPr lang="en-US" sz="2200" dirty="0"/>
           </a:p>
@@ -3662,7 +3596,7 @@
                   <a:srgbClr val="27303A"/>
                 </a:solidFill>
               </a:rPr>
-              <a:t>speichert den Zustand der Disk</a:t>
+              <a:t>id_ed25519.pub</a:t>
             </a:r>
             <a:endParaRPr lang="en-US" sz="1800" dirty="0"/>
           </a:p>
@@ -3680,7 +3614,7 @@
                   <a:srgbClr val="27303A"/>
                 </a:solidFill>
               </a:rPr>
-              <a:t>Wiederherstellen: alles danach ist weg – auch Gewolltes</a:t>
+              <a:t>das Schloss – kommt auf den Server</a:t>
             </a:r>
             <a:endParaRPr lang="en-US" sz="1800" dirty="0"/>
           </a:p>
@@ -3698,25 +3632,7 @@
                   <a:srgbClr val="27303A"/>
                 </a:solidFill>
               </a:rPr>
-              <a:t>vor riskanten Änderungen machen</a:t>
-            </a:r>
-            <a:endParaRPr lang="en-US" sz="1800" dirty="0"/>
-          </a:p>
-          <a:p>
-            <a:pPr marL="342900" indent="-342900">
-              <a:spcAft>
-                <a:spcPts val="800"/>
-              </a:spcAft>
-              <a:buSzPct val="100000"/>
-              <a:buChar char="•"/>
-            </a:pPr>
-            <a:r>
-              <a:rPr lang="en-US" sz="1800" dirty="0">
-                <a:solidFill>
-                  <a:srgbClr val="27303A"/>
-                </a:solidFill>
-              </a:rPr>
-              <a:t>Ersetzt er ein Backup? → Auftrag 1.4</a:t>
+              <a:t>darf jeder sehen</a:t>
             </a:r>
             <a:endParaRPr lang="en-US" sz="1800" dirty="0"/>
           </a:p>
@@ -3751,7 +3667,7 @@
       </p:sp>
       <p:sp>
         <p:nvSpPr>
-          <p:cNvPr id="9" name="icon-kreis-FaClone"/>
+          <p:cNvPr id="9" name="icon-kreis-FaKey"/>
           <p:cNvSpPr/>
           <p:nvPr/>
         </p:nvSpPr>
@@ -3776,7 +3692,7 @@
       </p:sp>
       <p:pic>
         <p:nvPicPr>
-          <p:cNvPr id="10" name="icon-FaClone" descr="C:\Users\Thanam\AppData\Local\Temp\claude\c--Projekt-Trainings-azure-basics-training\a9e0bf4e-0d08-4082-a38a-5b8886538508\scratchpad\pptx\assets\icons\FaClone.png">    </p:cNvPr>
+          <p:cNvPr id="10" name="icon-FaKey" descr="C:\Users\Thanam\AppData\Local\Temp\claude\c--Projekt-Trainings-azure-basics-training\a9e0bf4e-0d08-4082-a38a-5b8886538508\scratchpad\pptx\assets\icons\FaKey.png">    </p:cNvPr>
           <p:cNvPicPr>
             <a:picLocks noChangeAspect="1"/>
           </p:cNvPicPr>
@@ -3828,7 +3744,7 @@
                   <a:srgbClr val="27303A"/>
                 </a:solidFill>
               </a:rPr>
-              <a:t>Klon</a:t>
+              <a:t>Privater Schlüssel</a:t>
             </a:r>
             <a:endParaRPr lang="en-US" sz="2200" dirty="0"/>
           </a:p>
@@ -3868,7 +3784,7 @@
                   <a:srgbClr val="27303A"/>
                 </a:solidFill>
               </a:rPr>
-              <a:t>Kopie der ganzen VM</a:t>
+              <a:t>id_ed25519</a:t>
             </a:r>
             <a:endParaRPr lang="en-US" sz="1800" dirty="0"/>
           </a:p>
@@ -3886,7 +3802,7 @@
                   <a:srgbClr val="27303A"/>
                 </a:solidFill>
               </a:rPr>
-              <a:t>verknüpfter Klon: nur Unterschiede, wenig Platz</a:t>
+              <a:t>der einzige Schlüssel zum Schloss</a:t>
             </a:r>
             <a:endParaRPr lang="en-US" sz="1800" dirty="0"/>
           </a:p>
@@ -3904,7 +3820,7 @@
                   <a:srgbClr val="27303A"/>
                 </a:solidFill>
               </a:rPr>
-              <a:t>Achtung: gleicher Hostname, gleiche SSH-Schlüssel</a:t>
+              <a:t>bleibt auf deinem Laptop – nie weitergeben</a:t>
             </a:r>
             <a:endParaRPr lang="en-US" sz="1800" dirty="0"/>
           </a:p>
@@ -4012,15 +3928,103 @@
                   <a:srgbClr val="27303A"/>
                 </a:solidFill>
               </a:rPr>
-              <a:t>VM und Container</a:t>
+              <a:t>Selbsttest</a:t>
             </a:r>
             <a:endParaRPr lang="en-US" sz="3400" dirty="0"/>
           </a:p>
         </p:txBody>
+      </p:sp>
+      <p:sp>
+        <p:nvSpPr>
+          <p:cNvPr id="3" name="Text 1"/>
+          <p:cNvSpPr txBox="1"/>
+          <p:nvPr/>
+        </p:nvSpPr>
+        <p:spPr>
+          <a:xfrm>
+            <a:off x="548640" y="1325880"/>
+            <a:ext cx="11094415" cy="457200"/>
+          </a:xfrm>
+          <a:prstGeom prst="rect">
+            <a:avLst/>
+          </a:prstGeom>
+          <a:noFill/>
+          <a:ln/>
+        </p:spPr>
+        <p:txBody>
+          <a:bodyPr wrap="square" lIns="0" tIns="0" rIns="0" bIns="0" rtlCol="0" anchor="ctr"/>
+          <a:lstStyle/>
+          <a:p>
+            <a:pPr indent="0" marL="0">
+              <a:buNone/>
+            </a:pPr>
+            <a:r>
+              <a:rPr lang="en-US" sz="1600" dirty="0">
+                <a:solidFill>
+                  <a:srgbClr val="6F6F6F"/>
+                </a:solidFill>
+              </a:rPr>
+              <a:t>Erst selbst überlegen, dann mit dem Nachbarn vergleichen.</a:t>
+            </a:r>
+            <a:endParaRPr lang="en-US" sz="1600" dirty="0"/>
+          </a:p>
+        </p:txBody>
+      </p:sp>
+      <p:sp>
+        <p:nvSpPr>
+          <p:cNvPr id="4" name="karte"/>
+          <p:cNvSpPr/>
+          <p:nvPr/>
+        </p:nvSpPr>
+        <p:spPr>
+          <a:xfrm>
+            <a:off x="548640" y="2743200"/>
+            <a:ext cx="3515258" cy="2468880"/>
+          </a:xfrm>
+          <a:prstGeom prst="roundRect">
+            <a:avLst>
+              <a:gd name="adj" fmla="val 4444"/>
+            </a:avLst>
+          </a:prstGeom>
+          <a:solidFill>
+            <a:srgbClr val="F7F7F7"/>
+          </a:solidFill>
+          <a:ln w="12700">
+            <a:solidFill>
+              <a:srgbClr val="F7F7F7"/>
+            </a:solidFill>
+            <a:prstDash val="solid"/>
+          </a:ln>
+        </p:spPr>
+      </p:sp>
+      <p:sp>
+        <p:nvSpPr>
+          <p:cNvPr id="5" name="icon-kreis-FaQuestionCircle"/>
+          <p:cNvSpPr/>
+          <p:nvPr/>
+        </p:nvSpPr>
+        <p:spPr>
+          <a:xfrm>
+            <a:off x="822960" y="3017520"/>
+            <a:ext cx="640080" cy="640080"/>
+          </a:xfrm>
+          <a:prstGeom prst="ellipse">
+            <a:avLst/>
+          </a:prstGeom>
+          <a:solidFill>
+            <a:srgbClr val="006FAD"/>
+          </a:solidFill>
+          <a:ln w="12700">
+            <a:solidFill>
+              <a:srgbClr val="006FAD"/>
+            </a:solidFill>
+            <a:prstDash val="solid"/>
+          </a:ln>
+        </p:spPr>
       </p:sp>
       <p:pic>
         <p:nvPicPr>
-          <p:cNvPr id="3" name="diagramm" descr="VM und Container">    </p:cNvPr>
+          <p:cNvPr id="6" name="icon-FaQuestionCircle" descr="C:\Users\Thanam\AppData\Local\Temp\claude\c--Projekt-Trainings-azure-basics-training\a9e0bf4e-0d08-4082-a38a-5b8886538508\scratchpad\pptx\assets\icons\FaQuestionCircle.png">    </p:cNvPr>
           <p:cNvPicPr>
             <a:picLocks noChangeAspect="1"/>
           </p:cNvPicPr>
@@ -4034,14 +4038,397 @@
         </p:blipFill>
         <p:spPr>
           <a:xfrm>
-            <a:off x="548640" y="1694560"/>
-            <a:ext cx="11094415" cy="3971801"/>
+            <a:off x="976579" y="3171139"/>
+            <a:ext cx="332842" cy="332842"/>
           </a:xfrm>
           <a:prstGeom prst="rect">
             <a:avLst/>
           </a:prstGeom>
         </p:spPr>
       </p:pic>
+      <p:sp>
+        <p:nvSpPr>
+          <p:cNvPr id="7" name="Text 4"/>
+          <p:cNvSpPr txBox="1"/>
+          <p:nvPr/>
+        </p:nvSpPr>
+        <p:spPr>
+          <a:xfrm>
+            <a:off x="1645920" y="3017520"/>
+            <a:ext cx="2189378" cy="640080"/>
+          </a:xfrm>
+          <a:prstGeom prst="rect">
+            <a:avLst/>
+          </a:prstGeom>
+          <a:noFill/>
+          <a:ln/>
+        </p:spPr>
+        <p:txBody>
+          <a:bodyPr wrap="square" lIns="0" tIns="0" rIns="0" bIns="0" rtlCol="0" anchor="ctr">
+            <a:normAutofit/>
+          </a:bodyPr>
+          <a:lstStyle/>
+          <a:p>
+            <a:pPr indent="0" marL="0">
+              <a:buNone/>
+            </a:pPr>
+            <a:r>
+              <a:rPr lang="en-US" sz="2000" b="1" dirty="0">
+                <a:solidFill>
+                  <a:srgbClr val="27303A"/>
+                </a:solidFill>
+              </a:rPr>
+              <a:t>Hypervisor</a:t>
+            </a:r>
+            <a:endParaRPr lang="en-US" sz="2000" dirty="0"/>
+          </a:p>
+        </p:txBody>
+      </p:sp>
+      <p:sp>
+        <p:nvSpPr>
+          <p:cNvPr id="8" name="Text 5"/>
+          <p:cNvSpPr txBox="1"/>
+          <p:nvPr/>
+        </p:nvSpPr>
+        <p:spPr>
+          <a:xfrm>
+            <a:off x="822960" y="3840480"/>
+            <a:ext cx="2966618" cy="1234440"/>
+          </a:xfrm>
+          <a:prstGeom prst="rect">
+            <a:avLst/>
+          </a:prstGeom>
+          <a:noFill/>
+          <a:ln/>
+        </p:spPr>
+        <p:txBody>
+          <a:bodyPr wrap="square" lIns="0" tIns="0" rIns="0" bIns="0" rtlCol="0" anchor="t"/>
+          <a:lstStyle/>
+          <a:p>
+            <a:pPr indent="0" marL="0">
+              <a:spcAft>
+                <a:spcPts val="400"/>
+              </a:spcAft>
+              <a:buNone/>
+            </a:pPr>
+            <a:r>
+              <a:rPr lang="en-US" sz="1600" dirty="0">
+                <a:solidFill>
+                  <a:srgbClr val="27303A"/>
+                </a:solidFill>
+              </a:rPr>
+              <a:t>Typ 1 oder Typ 2: VirtualBox, Hyper-V?</a:t>
+            </a:r>
+            <a:endParaRPr lang="en-US" sz="1600" dirty="0"/>
+          </a:p>
+        </p:txBody>
+      </p:sp>
+      <p:sp>
+        <p:nvSpPr>
+          <p:cNvPr id="9" name="karte"/>
+          <p:cNvSpPr/>
+          <p:nvPr/>
+        </p:nvSpPr>
+        <p:spPr>
+          <a:xfrm>
+            <a:off x="4338218" y="2743200"/>
+            <a:ext cx="3515258" cy="2468880"/>
+          </a:xfrm>
+          <a:prstGeom prst="roundRect">
+            <a:avLst>
+              <a:gd name="adj" fmla="val 4444"/>
+            </a:avLst>
+          </a:prstGeom>
+          <a:solidFill>
+            <a:srgbClr val="F7F7F7"/>
+          </a:solidFill>
+          <a:ln w="12700">
+            <a:solidFill>
+              <a:srgbClr val="F7F7F7"/>
+            </a:solidFill>
+            <a:prstDash val="solid"/>
+          </a:ln>
+        </p:spPr>
+      </p:sp>
+      <p:sp>
+        <p:nvSpPr>
+          <p:cNvPr id="10" name="icon-kreis-FaQuestionCircle"/>
+          <p:cNvSpPr/>
+          <p:nvPr/>
+        </p:nvSpPr>
+        <p:spPr>
+          <a:xfrm>
+            <a:off x="4612538" y="3017520"/>
+            <a:ext cx="640080" cy="640080"/>
+          </a:xfrm>
+          <a:prstGeom prst="ellipse">
+            <a:avLst/>
+          </a:prstGeom>
+          <a:solidFill>
+            <a:srgbClr val="006FAD"/>
+          </a:solidFill>
+          <a:ln w="12700">
+            <a:solidFill>
+              <a:srgbClr val="006FAD"/>
+            </a:solidFill>
+            <a:prstDash val="solid"/>
+          </a:ln>
+        </p:spPr>
+      </p:sp>
+      <p:pic>
+        <p:nvPicPr>
+          <p:cNvPr id="11" name="icon-FaQuestionCircle" descr="C:\Users\Thanam\AppData\Local\Temp\claude\c--Projekt-Trainings-azure-basics-training\a9e0bf4e-0d08-4082-a38a-5b8886538508\scratchpad\pptx\assets\icons\FaQuestionCircle.png">    </p:cNvPr>
+          <p:cNvPicPr>
+            <a:picLocks noChangeAspect="1"/>
+          </p:cNvPicPr>
+          <p:nvPr/>
+        </p:nvPicPr>
+        <p:blipFill>
+          <a:blip r:embed="rId2"/>
+          <a:stretch>
+            <a:fillRect/>
+          </a:stretch>
+        </p:blipFill>
+        <p:spPr>
+          <a:xfrm>
+            <a:off x="4766158" y="3171139"/>
+            <a:ext cx="332842" cy="332842"/>
+          </a:xfrm>
+          <a:prstGeom prst="rect">
+            <a:avLst/>
+          </a:prstGeom>
+        </p:spPr>
+      </p:pic>
+      <p:sp>
+        <p:nvSpPr>
+          <p:cNvPr id="12" name="Text 8"/>
+          <p:cNvSpPr txBox="1"/>
+          <p:nvPr/>
+        </p:nvSpPr>
+        <p:spPr>
+          <a:xfrm>
+            <a:off x="5435498" y="3017520"/>
+            <a:ext cx="2189378" cy="640080"/>
+          </a:xfrm>
+          <a:prstGeom prst="rect">
+            <a:avLst/>
+          </a:prstGeom>
+          <a:noFill/>
+          <a:ln/>
+        </p:spPr>
+        <p:txBody>
+          <a:bodyPr wrap="square" lIns="0" tIns="0" rIns="0" bIns="0" rtlCol="0" anchor="ctr">
+            <a:normAutofit/>
+          </a:bodyPr>
+          <a:lstStyle/>
+          <a:p>
+            <a:pPr indent="0" marL="0">
+              <a:buNone/>
+            </a:pPr>
+            <a:r>
+              <a:rPr lang="en-US" sz="2000" b="1" dirty="0">
+                <a:solidFill>
+                  <a:srgbClr val="27303A"/>
+                </a:solidFill>
+              </a:rPr>
+              <a:t>cloud-init</a:t>
+            </a:r>
+            <a:endParaRPr lang="en-US" sz="2000" dirty="0"/>
+          </a:p>
+        </p:txBody>
+      </p:sp>
+      <p:sp>
+        <p:nvSpPr>
+          <p:cNvPr id="13" name="Text 9"/>
+          <p:cNvSpPr txBox="1"/>
+          <p:nvPr/>
+        </p:nvSpPr>
+        <p:spPr>
+          <a:xfrm>
+            <a:off x="4612538" y="3840480"/>
+            <a:ext cx="2966618" cy="1234440"/>
+          </a:xfrm>
+          <a:prstGeom prst="rect">
+            <a:avLst/>
+          </a:prstGeom>
+          <a:noFill/>
+          <a:ln/>
+        </p:spPr>
+        <p:txBody>
+          <a:bodyPr wrap="square" lIns="0" tIns="0" rIns="0" bIns="0" rtlCol="0" anchor="t"/>
+          <a:lstStyle/>
+          <a:p>
+            <a:pPr indent="0" marL="0">
+              <a:spcAft>
+                <a:spcPts val="400"/>
+              </a:spcAft>
+              <a:buNone/>
+            </a:pPr>
+            <a:r>
+              <a:rPr lang="en-US" sz="1600" dirty="0">
+                <a:solidFill>
+                  <a:srgbClr val="27303A"/>
+                </a:solidFill>
+              </a:rPr>
+              <a:t>Wann arbeitet cloud-init die Datei ab?</a:t>
+            </a:r>
+            <a:endParaRPr lang="en-US" sz="1600" dirty="0"/>
+          </a:p>
+        </p:txBody>
+      </p:sp>
+      <p:sp>
+        <p:nvSpPr>
+          <p:cNvPr id="14" name="karte"/>
+          <p:cNvSpPr/>
+          <p:nvPr/>
+        </p:nvSpPr>
+        <p:spPr>
+          <a:xfrm>
+            <a:off x="8127797" y="2743200"/>
+            <a:ext cx="3515258" cy="2468880"/>
+          </a:xfrm>
+          <a:prstGeom prst="roundRect">
+            <a:avLst>
+              <a:gd name="adj" fmla="val 4444"/>
+            </a:avLst>
+          </a:prstGeom>
+          <a:solidFill>
+            <a:srgbClr val="F7F7F7"/>
+          </a:solidFill>
+          <a:ln w="12700">
+            <a:solidFill>
+              <a:srgbClr val="F7F7F7"/>
+            </a:solidFill>
+            <a:prstDash val="solid"/>
+          </a:ln>
+        </p:spPr>
+      </p:sp>
+      <p:sp>
+        <p:nvSpPr>
+          <p:cNvPr id="15" name="icon-kreis-FaQuestionCircle"/>
+          <p:cNvSpPr/>
+          <p:nvPr/>
+        </p:nvSpPr>
+        <p:spPr>
+          <a:xfrm>
+            <a:off x="8402117" y="3017520"/>
+            <a:ext cx="640080" cy="640080"/>
+          </a:xfrm>
+          <a:prstGeom prst="ellipse">
+            <a:avLst/>
+          </a:prstGeom>
+          <a:solidFill>
+            <a:srgbClr val="006FAD"/>
+          </a:solidFill>
+          <a:ln w="12700">
+            <a:solidFill>
+              <a:srgbClr val="006FAD"/>
+            </a:solidFill>
+            <a:prstDash val="solid"/>
+          </a:ln>
+        </p:spPr>
+      </p:sp>
+      <p:pic>
+        <p:nvPicPr>
+          <p:cNvPr id="16" name="icon-FaQuestionCircle" descr="C:\Users\Thanam\AppData\Local\Temp\claude\c--Projekt-Trainings-azure-basics-training\a9e0bf4e-0d08-4082-a38a-5b8886538508\scratchpad\pptx\assets\icons\FaQuestionCircle.png">    </p:cNvPr>
+          <p:cNvPicPr>
+            <a:picLocks noChangeAspect="1"/>
+          </p:cNvPicPr>
+          <p:nvPr/>
+        </p:nvPicPr>
+        <p:blipFill>
+          <a:blip r:embed="rId3"/>
+          <a:stretch>
+            <a:fillRect/>
+          </a:stretch>
+        </p:blipFill>
+        <p:spPr>
+          <a:xfrm>
+            <a:off x="8555736" y="3171139"/>
+            <a:ext cx="332842" cy="332842"/>
+          </a:xfrm>
+          <a:prstGeom prst="rect">
+            <a:avLst/>
+          </a:prstGeom>
+        </p:spPr>
+      </p:pic>
+      <p:sp>
+        <p:nvSpPr>
+          <p:cNvPr id="17" name="Text 12"/>
+          <p:cNvSpPr txBox="1"/>
+          <p:nvPr/>
+        </p:nvSpPr>
+        <p:spPr>
+          <a:xfrm>
+            <a:off x="9225077" y="3017520"/>
+            <a:ext cx="2189378" cy="640080"/>
+          </a:xfrm>
+          <a:prstGeom prst="rect">
+            <a:avLst/>
+          </a:prstGeom>
+          <a:noFill/>
+          <a:ln/>
+        </p:spPr>
+        <p:txBody>
+          <a:bodyPr wrap="square" lIns="0" tIns="0" rIns="0" bIns="0" rtlCol="0" anchor="ctr">
+            <a:normAutofit/>
+          </a:bodyPr>
+          <a:lstStyle/>
+          <a:p>
+            <a:pPr indent="0" marL="0">
+              <a:buNone/>
+            </a:pPr>
+            <a:r>
+              <a:rPr lang="en-US" sz="2000" b="1" dirty="0">
+                <a:solidFill>
+                  <a:srgbClr val="27303A"/>
+                </a:solidFill>
+              </a:rPr>
+              <a:t>Docker</a:t>
+            </a:r>
+            <a:endParaRPr lang="en-US" sz="2000" dirty="0"/>
+          </a:p>
+        </p:txBody>
+      </p:sp>
+      <p:sp>
+        <p:nvSpPr>
+          <p:cNvPr id="18" name="Text 13"/>
+          <p:cNvSpPr txBox="1"/>
+          <p:nvPr/>
+        </p:nvSpPr>
+        <p:spPr>
+          <a:xfrm>
+            <a:off x="8402117" y="3840480"/>
+            <a:ext cx="2966618" cy="1234440"/>
+          </a:xfrm>
+          <a:prstGeom prst="rect">
+            <a:avLst/>
+          </a:prstGeom>
+          <a:noFill/>
+          <a:ln/>
+        </p:spPr>
+        <p:txBody>
+          <a:bodyPr wrap="square" lIns="0" tIns="0" rIns="0" bIns="0" rtlCol="0" anchor="t"/>
+          <a:lstStyle/>
+          <a:p>
+            <a:pPr indent="0" marL="0">
+              <a:spcAft>
+                <a:spcPts val="400"/>
+              </a:spcAft>
+              <a:buNone/>
+            </a:pPr>
+            <a:r>
+              <a:rPr lang="en-US" sz="1600" dirty="0">
+                <a:solidFill>
+                  <a:srgbClr val="27303A"/>
+                </a:solidFill>
+              </a:rPr>
+              <a:t>Ein Kollege sagt: «Docker ist auch ein Hypervisor.» Stimmt das?</a:t>
+            </a:r>
+            <a:endParaRPr lang="en-US" sz="1600" dirty="0"/>
+          </a:p>
+        </p:txBody>
+      </p:sp>
       <p:sp>
         <p:nvSpPr>
           <p:cNvPr id="25" name="Slide Number Placeholder 0"/>
@@ -4144,7 +4531,7 @@
                   <a:srgbClr val="27303A"/>
                 </a:solidFill>
               </a:rPr>
-              <a:t>Selbsttest</a:t>
+              <a:t>Zum Nachlesen</a:t>
             </a:r>
             <a:endParaRPr lang="en-US" sz="3400" dirty="0"/>
           </a:p>
@@ -4152,77 +4539,14 @@
       </p:sp>
       <p:sp>
         <p:nvSpPr>
-          <p:cNvPr id="3" name="Text 1"/>
-          <p:cNvSpPr txBox="1"/>
-          <p:nvPr/>
-        </p:nvSpPr>
-        <p:spPr>
-          <a:xfrm>
-            <a:off x="548640" y="1325880"/>
-            <a:ext cx="11094415" cy="457200"/>
-          </a:xfrm>
-          <a:prstGeom prst="rect">
-            <a:avLst/>
-          </a:prstGeom>
-          <a:noFill/>
-          <a:ln/>
-        </p:spPr>
-        <p:txBody>
-          <a:bodyPr wrap="square" lIns="0" tIns="0" rIns="0" bIns="0" rtlCol="0" anchor="ctr"/>
-          <a:lstStyle/>
-          <a:p>
-            <a:pPr indent="0" marL="0">
-              <a:buNone/>
-            </a:pPr>
-            <a:r>
-              <a:rPr lang="en-US" sz="1600" dirty="0">
-                <a:solidFill>
-                  <a:srgbClr val="6F6F6F"/>
-                </a:solidFill>
-              </a:rPr>
-              <a:t>Erst selbst überlegen, dann mit dem Nachbarn vergleichen.</a:t>
-            </a:r>
-            <a:endParaRPr lang="en-US" sz="1600" dirty="0"/>
-          </a:p>
-        </p:txBody>
-      </p:sp>
-      <p:sp>
-        <p:nvSpPr>
-          <p:cNvPr id="4" name="karte"/>
+          <p:cNvPr id="3" name="icon-kreis-FaBook"/>
           <p:cNvSpPr/>
           <p:nvPr/>
         </p:nvSpPr>
         <p:spPr>
           <a:xfrm>
-            <a:off x="548640" y="2743200"/>
-            <a:ext cx="3515258" cy="2468880"/>
-          </a:xfrm>
-          <a:prstGeom prst="roundRect">
-            <a:avLst>
-              <a:gd name="adj" fmla="val 4444"/>
-            </a:avLst>
-          </a:prstGeom>
-          <a:solidFill>
-            <a:srgbClr val="F7F7F7"/>
-          </a:solidFill>
-          <a:ln w="12700">
-            <a:solidFill>
-              <a:srgbClr val="F7F7F7"/>
-            </a:solidFill>
-            <a:prstDash val="solid"/>
-          </a:ln>
-        </p:spPr>
-      </p:sp>
-      <p:sp>
-        <p:nvSpPr>
-          <p:cNvPr id="5" name="icon-kreis-FaQuestionCircle"/>
-          <p:cNvSpPr/>
-          <p:nvPr/>
-        </p:nvSpPr>
-        <p:spPr>
-          <a:xfrm>
-            <a:off x="822960" y="3017520"/>
-            <a:ext cx="640080" cy="640080"/>
+            <a:off x="548640" y="2446020"/>
+            <a:ext cx="548640" cy="548640"/>
           </a:xfrm>
           <a:prstGeom prst="ellipse">
             <a:avLst/>
@@ -4240,7 +4564,7 @@
       </p:sp>
       <p:pic>
         <p:nvPicPr>
-          <p:cNvPr id="6" name="icon-FaQuestionCircle" descr="C:\Users\Thanam\AppData\Local\Temp\claude\c--Projekt-Trainings-azure-basics-training\a9e0bf4e-0d08-4082-a38a-5b8886538508\scratchpad\pptx\assets\icons\FaQuestionCircle.png">    </p:cNvPr>
+          <p:cNvPr id="4" name="icon-FaBook" descr="C:\Users\Thanam\AppData\Local\Temp\claude\c--Projekt-Trainings-azure-basics-training\a9e0bf4e-0d08-4082-a38a-5b8886538508\scratchpad\pptx\assets\icons\FaBook.png">    </p:cNvPr>
           <p:cNvPicPr>
             <a:picLocks noChangeAspect="1"/>
           </p:cNvPicPr>
@@ -4254,8 +4578,8 @@
         </p:blipFill>
         <p:spPr>
           <a:xfrm>
-            <a:off x="976579" y="3171139"/>
-            <a:ext cx="332842" cy="332842"/>
+            <a:off x="680314" y="2577694"/>
+            <a:ext cx="285293" cy="285293"/>
           </a:xfrm>
           <a:prstGeom prst="rect">
             <a:avLst/>
@@ -4264,14 +4588,14 @@
       </p:pic>
       <p:sp>
         <p:nvSpPr>
-          <p:cNvPr id="7" name="Text 4"/>
+          <p:cNvPr id="5" name="Text 2"/>
           <p:cNvSpPr txBox="1"/>
           <p:nvPr/>
         </p:nvSpPr>
         <p:spPr>
           <a:xfrm>
-            <a:off x="1645920" y="3017520"/>
-            <a:ext cx="2189378" cy="640080"/>
+            <a:off x="1325880" y="2240280"/>
+            <a:ext cx="10317175" cy="960120"/>
           </a:xfrm>
           <a:prstGeom prst="rect">
             <a:avLst/>
@@ -4280,102 +4604,48 @@
           <a:ln/>
         </p:spPr>
         <p:txBody>
-          <a:bodyPr wrap="square" lIns="0" tIns="0" rIns="0" bIns="0" rtlCol="0" anchor="ctr">
-            <a:normAutofit/>
-          </a:bodyPr>
+          <a:bodyPr wrap="square" lIns="0" tIns="0" rIns="0" bIns="0" rtlCol="0" anchor="ctr"/>
           <a:lstStyle/>
           <a:p>
             <a:pPr indent="0" marL="0">
               <a:buNone/>
             </a:pPr>
             <a:r>
-              <a:rPr lang="en-US" sz="2000" b="1" dirty="0">
+              <a:rPr lang="en-US" sz="1800" b="1" dirty="0">
                 <a:solidFill>
                   <a:srgbClr val="27303A"/>
                 </a:solidFill>
               </a:rPr>
-              <a:t>Docker</a:t>
-            </a:r>
-            <a:endParaRPr lang="en-US" sz="2000" dirty="0"/>
-          </a:p>
-        </p:txBody>
-      </p:sp>
-      <p:sp>
-        <p:nvSpPr>
-          <p:cNvPr id="8" name="Text 5"/>
-          <p:cNvSpPr txBox="1"/>
-          <p:nvPr/>
-        </p:nvSpPr>
-        <p:spPr>
-          <a:xfrm>
-            <a:off x="822960" y="3840480"/>
-            <a:ext cx="2966618" cy="1234440"/>
-          </a:xfrm>
-          <a:prstGeom prst="rect">
-            <a:avLst/>
-          </a:prstGeom>
-          <a:noFill/>
-          <a:ln/>
-        </p:spPr>
-        <p:txBody>
-          <a:bodyPr wrap="square" lIns="0" tIns="0" rIns="0" bIns="0" rtlCol="0" anchor="t"/>
-          <a:lstStyle/>
+              <a:t>Theorie</a:t>
+            </a:r>
+            <a:endParaRPr lang="en-US" sz="1800" dirty="0"/>
+          </a:p>
           <a:p>
             <a:pPr indent="0" marL="0">
-              <a:spcAft>
-                <a:spcPts val="400"/>
-              </a:spcAft>
-              <a:buNone/>
-            </a:pPr>
-            <a:r>
-              <a:rPr lang="en-US" sz="1600" dirty="0">
-                <a:solidFill>
-                  <a:srgbClr val="27303A"/>
-                </a:solidFill>
-              </a:rPr>
-              <a:t>Ein Kollege sagt: «Docker ist auch ein Hypervisor.» Stimmt das?</a:t>
-            </a:r>
-            <a:endParaRPr lang="en-US" sz="1600" dirty="0"/>
-          </a:p>
-        </p:txBody>
-      </p:sp>
-      <p:sp>
-        <p:nvSpPr>
-          <p:cNvPr id="9" name="karte"/>
+              <a:buNone/>
+            </a:pPr>
+            <a:r>
+              <a:rPr lang="en-US" sz="1800" dirty="0">
+                <a:solidFill>
+                  <a:srgbClr val="6F6F6F"/>
+                </a:solidFill>
+              </a:rPr>
+              <a:t>theorie/01-virtualisierung.md</a:t>
+            </a:r>
+            <a:endParaRPr lang="en-US" sz="1800" dirty="0"/>
+          </a:p>
+        </p:txBody>
+      </p:sp>
+      <p:sp>
+        <p:nvSpPr>
+          <p:cNvPr id="6" name="icon-kreis-FaGraduationCap"/>
           <p:cNvSpPr/>
           <p:nvPr/>
         </p:nvSpPr>
         <p:spPr>
           <a:xfrm>
-            <a:off x="4338218" y="2743200"/>
-            <a:ext cx="3515258" cy="2468880"/>
-          </a:xfrm>
-          <a:prstGeom prst="roundRect">
-            <a:avLst>
-              <a:gd name="adj" fmla="val 4444"/>
-            </a:avLst>
-          </a:prstGeom>
-          <a:solidFill>
-            <a:srgbClr val="F7F7F7"/>
-          </a:solidFill>
-          <a:ln w="12700">
-            <a:solidFill>
-              <a:srgbClr val="F7F7F7"/>
-            </a:solidFill>
-            <a:prstDash val="solid"/>
-          </a:ln>
-        </p:spPr>
-      </p:sp>
-      <p:sp>
-        <p:nvSpPr>
-          <p:cNvPr id="10" name="icon-kreis-FaQuestionCircle"/>
-          <p:cNvSpPr/>
-          <p:nvPr/>
-        </p:nvSpPr>
-        <p:spPr>
-          <a:xfrm>
-            <a:off x="4612538" y="3017520"/>
-            <a:ext cx="640080" cy="640080"/>
+            <a:off x="548640" y="3406140"/>
+            <a:ext cx="548640" cy="548640"/>
           </a:xfrm>
           <a:prstGeom prst="ellipse">
             <a:avLst/>
@@ -4393,7 +4663,7 @@
       </p:sp>
       <p:pic>
         <p:nvPicPr>
-          <p:cNvPr id="11" name="icon-FaQuestionCircle" descr="C:\Users\Thanam\AppData\Local\Temp\claude\c--Projekt-Trainings-azure-basics-training\a9e0bf4e-0d08-4082-a38a-5b8886538508\scratchpad\pptx\assets\icons\FaQuestionCircle.png">    </p:cNvPr>
+          <p:cNvPr id="7" name="icon-FaGraduationCap" descr="C:\Users\Thanam\AppData\Local\Temp\claude\c--Projekt-Trainings-azure-basics-training\a9e0bf4e-0d08-4082-a38a-5b8886538508\scratchpad\pptx\assets\icons\FaGraduationCap.png">    </p:cNvPr>
           <p:cNvPicPr>
             <a:picLocks noChangeAspect="1"/>
           </p:cNvPicPr>
@@ -4407,8 +4677,8 @@
         </p:blipFill>
         <p:spPr>
           <a:xfrm>
-            <a:off x="4766158" y="3171139"/>
-            <a:ext cx="332842" cy="332842"/>
+            <a:off x="680314" y="3537814"/>
+            <a:ext cx="285293" cy="285293"/>
           </a:xfrm>
           <a:prstGeom prst="rect">
             <a:avLst/>
@@ -4417,14 +4687,14 @@
       </p:pic>
       <p:sp>
         <p:nvSpPr>
-          <p:cNvPr id="12" name="Text 8"/>
+          <p:cNvPr id="8" name="Text 4"/>
           <p:cNvSpPr txBox="1"/>
           <p:nvPr/>
         </p:nvSpPr>
         <p:spPr>
           <a:xfrm>
-            <a:off x="5435498" y="3017520"/>
-            <a:ext cx="2189378" cy="640080"/>
+            <a:off x="1325880" y="3200400"/>
+            <a:ext cx="10317175" cy="960120"/>
           </a:xfrm>
           <a:prstGeom prst="rect">
             <a:avLst/>
@@ -4433,102 +4703,48 @@
           <a:ln/>
         </p:spPr>
         <p:txBody>
-          <a:bodyPr wrap="square" lIns="0" tIns="0" rIns="0" bIns="0" rtlCol="0" anchor="ctr">
-            <a:normAutofit/>
-          </a:bodyPr>
+          <a:bodyPr wrap="square" lIns="0" tIns="0" rIns="0" bIns="0" rtlCol="0" anchor="ctr"/>
           <a:lstStyle/>
           <a:p>
             <a:pPr indent="0" marL="0">
               <a:buNone/>
             </a:pPr>
             <a:r>
-              <a:rPr lang="en-US" sz="2000" b="1" dirty="0">
+              <a:rPr lang="en-US" sz="1800" b="1" dirty="0">
                 <a:solidFill>
                   <a:srgbClr val="27303A"/>
                 </a:solidFill>
               </a:rPr>
-              <a:t>Overcommitment</a:t>
-            </a:r>
-            <a:endParaRPr lang="en-US" sz="2000" dirty="0"/>
-          </a:p>
-        </p:txBody>
-      </p:sp>
-      <p:sp>
-        <p:nvSpPr>
-          <p:cNvPr id="13" name="Text 9"/>
-          <p:cNvSpPr txBox="1"/>
-          <p:nvPr/>
-        </p:nvSpPr>
-        <p:spPr>
-          <a:xfrm>
-            <a:off x="4612538" y="3840480"/>
-            <a:ext cx="2966618" cy="1234440"/>
-          </a:xfrm>
-          <a:prstGeom prst="rect">
-            <a:avLst/>
-          </a:prstGeom>
-          <a:noFill/>
-          <a:ln/>
-        </p:spPr>
-        <p:txBody>
-          <a:bodyPr wrap="square" lIns="0" tIns="0" rIns="0" bIns="0" rtlCol="0" anchor="t"/>
-          <a:lstStyle/>
+              <a:t>Microsoft und Canonical</a:t>
+            </a:r>
+            <a:endParaRPr lang="en-US" sz="1800" dirty="0"/>
+          </a:p>
           <a:p>
             <a:pPr indent="0" marL="0">
-              <a:spcAft>
-                <a:spcPts val="400"/>
-              </a:spcAft>
-              <a:buNone/>
-            </a:pPr>
-            <a:r>
-              <a:rPr lang="en-US" sz="1600" dirty="0">
-                <a:solidFill>
-                  <a:srgbClr val="27303A"/>
-                </a:solidFill>
-              </a:rPr>
-              <a:t>8 logische Prozessoren, drei VMs mit je 4 vCPUs – wie geht das?</a:t>
-            </a:r>
-            <a:endParaRPr lang="en-US" sz="1600" dirty="0"/>
-          </a:p>
-        </p:txBody>
-      </p:sp>
-      <p:sp>
-        <p:nvSpPr>
-          <p:cNvPr id="14" name="karte"/>
+              <a:buNone/>
+            </a:pPr>
+            <a:r>
+              <a:rPr lang="en-US" sz="1800" dirty="0">
+                <a:solidFill>
+                  <a:srgbClr val="6F6F6F"/>
+                </a:solidFill>
+              </a:rPr>
+              <a:t>Was ist Virtualisierung? · Multipass-Dokumentation</a:t>
+            </a:r>
+            <a:endParaRPr lang="en-US" sz="1800" dirty="0"/>
+          </a:p>
+        </p:txBody>
+      </p:sp>
+      <p:sp>
+        <p:nvSpPr>
+          <p:cNvPr id="9" name="icon-kreis-FaBook"/>
           <p:cNvSpPr/>
           <p:nvPr/>
         </p:nvSpPr>
         <p:spPr>
           <a:xfrm>
-            <a:off x="8127797" y="2743200"/>
-            <a:ext cx="3515258" cy="2468880"/>
-          </a:xfrm>
-          <a:prstGeom prst="roundRect">
-            <a:avLst>
-              <a:gd name="adj" fmla="val 4444"/>
-            </a:avLst>
-          </a:prstGeom>
-          <a:solidFill>
-            <a:srgbClr val="F7F7F7"/>
-          </a:solidFill>
-          <a:ln w="12700">
-            <a:solidFill>
-              <a:srgbClr val="F7F7F7"/>
-            </a:solidFill>
-            <a:prstDash val="solid"/>
-          </a:ln>
-        </p:spPr>
-      </p:sp>
-      <p:sp>
-        <p:nvSpPr>
-          <p:cNvPr id="15" name="icon-kreis-FaQuestionCircle"/>
-          <p:cNvSpPr/>
-          <p:nvPr/>
-        </p:nvSpPr>
-        <p:spPr>
-          <a:xfrm>
-            <a:off x="8402117" y="3017520"/>
-            <a:ext cx="640080" cy="640080"/>
+            <a:off x="548640" y="4366260"/>
+            <a:ext cx="548640" cy="548640"/>
           </a:xfrm>
           <a:prstGeom prst="ellipse">
             <a:avLst/>
@@ -4546,7 +4762,7 @@
       </p:sp>
       <p:pic>
         <p:nvPicPr>
-          <p:cNvPr id="16" name="icon-FaQuestionCircle" descr="C:\Users\Thanam\AppData\Local\Temp\claude\c--Projekt-Trainings-azure-basics-training\a9e0bf4e-0d08-4082-a38a-5b8886538508\scratchpad\pptx\assets\icons\FaQuestionCircle.png">    </p:cNvPr>
+          <p:cNvPr id="10" name="icon-FaBook" descr="C:\Users\Thanam\AppData\Local\Temp\claude\c--Projekt-Trainings-azure-basics-training\a9e0bf4e-0d08-4082-a38a-5b8886538508\scratchpad\pptx\assets\icons\FaBook.png">    </p:cNvPr>
           <p:cNvPicPr>
             <a:picLocks noChangeAspect="1"/>
           </p:cNvPicPr>
@@ -4560,8 +4776,8 @@
         </p:blipFill>
         <p:spPr>
           <a:xfrm>
-            <a:off x="8555736" y="3171139"/>
-            <a:ext cx="332842" cy="332842"/>
+            <a:off x="680314" y="4497934"/>
+            <a:ext cx="285293" cy="285293"/>
           </a:xfrm>
           <a:prstGeom prst="rect">
             <a:avLst/>
@@ -4570,14 +4786,14 @@
       </p:pic>
       <p:sp>
         <p:nvSpPr>
-          <p:cNvPr id="17" name="Text 12"/>
+          <p:cNvPr id="11" name="Text 6"/>
           <p:cNvSpPr txBox="1"/>
           <p:nvPr/>
         </p:nvSpPr>
         <p:spPr>
           <a:xfrm>
-            <a:off x="9225077" y="3017520"/>
-            <a:ext cx="2189378" cy="640080"/>
+            <a:off x="1325880" y="4160520"/>
+            <a:ext cx="10317175" cy="960120"/>
           </a:xfrm>
           <a:prstGeom prst="rect">
             <a:avLst/>
@@ -4586,62 +4802,35 @@
           <a:ln/>
         </p:spPr>
         <p:txBody>
-          <a:bodyPr wrap="square" lIns="0" tIns="0" rIns="0" bIns="0" rtlCol="0" anchor="ctr">
-            <a:normAutofit/>
-          </a:bodyPr>
+          <a:bodyPr wrap="square" lIns="0" tIns="0" rIns="0" bIns="0" rtlCol="0" anchor="ctr"/>
           <a:lstStyle/>
           <a:p>
             <a:pPr indent="0" marL="0">
               <a:buNone/>
             </a:pPr>
             <a:r>
-              <a:rPr lang="en-US" sz="2000" b="1" dirty="0">
+              <a:rPr lang="en-US" sz="1800" b="1" dirty="0">
                 <a:solidFill>
                   <a:srgbClr val="27303A"/>
                 </a:solidFill>
               </a:rPr>
-              <a:t>NAT</a:t>
-            </a:r>
-            <a:endParaRPr lang="en-US" sz="2000" dirty="0"/>
-          </a:p>
-        </p:txBody>
-      </p:sp>
-      <p:sp>
-        <p:nvSpPr>
-          <p:cNvPr id="18" name="Text 13"/>
-          <p:cNvSpPr txBox="1"/>
-          <p:nvPr/>
-        </p:nvSpPr>
-        <p:spPr>
-          <a:xfrm>
-            <a:off x="8402117" y="3840480"/>
-            <a:ext cx="2966618" cy="1234440"/>
-          </a:xfrm>
-          <a:prstGeom prst="rect">
-            <a:avLst/>
-          </a:prstGeom>
-          <a:noFill/>
-          <a:ln/>
-        </p:spPr>
-        <p:txBody>
-          <a:bodyPr wrap="square" lIns="0" tIns="0" rIns="0" bIns="0" rtlCol="0" anchor="t"/>
-          <a:lstStyle/>
+              <a:t>TBZ M346</a:t>
+            </a:r>
+            <a:endParaRPr lang="en-US" sz="1800" dirty="0"/>
+          </a:p>
           <a:p>
             <a:pPr indent="0" marL="0">
-              <a:spcAft>
-                <a:spcPts val="400"/>
-              </a:spcAft>
-              <a:buNone/>
-            </a:pPr>
-            <a:r>
-              <a:rPr lang="en-US" sz="1600" dirty="0">
-                <a:solidFill>
-                  <a:srgbClr val="27303A"/>
-                </a:solidFill>
-              </a:rPr>
-              <a:t>Dein Partner erreicht deine VM nicht. Fehler oder gewollt?</a:t>
-            </a:r>
-            <a:endParaRPr lang="en-US" sz="1600" dirty="0"/>
+              <a:buNone/>
+            </a:pPr>
+            <a:r>
+              <a:rPr lang="en-US" sz="1800" dirty="0">
+                <a:solidFill>
+                  <a:srgbClr val="6F6F6F"/>
+                </a:solidFill>
+              </a:rPr>
+              <a:t>Virtualisierung, Multipass, KN01 (übernommen und vereinfacht)</a:t>
+            </a:r>
+            <a:endParaRPr lang="en-US" sz="1800" dirty="0"/>
           </a:p>
         </p:txBody>
       </p:sp>
@@ -4717,16 +4906,16 @@
       </p:grpSpPr>
       <p:sp>
         <p:nvSpPr>
-          <p:cNvPr id="2" name="Text 1"/>
+          <p:cNvPr id="2" name="Text 0"/>
           <p:cNvSpPr/>
           <p:nvPr>
-            <p:ph idx="102" type="title" hasCustomPrompt="1"/>
-          </p:nvPr>
-        </p:nvSpPr>
-        <p:spPr>
-          <a:xfrm>
-            <a:off x="548640" y="320040"/>
-            <a:ext cx="11094415" cy="822960"/>
+            <p:ph idx="101" type="title" hasCustomPrompt="1"/>
+          </p:nvPr>
+        </p:nvSpPr>
+        <p:spPr>
+          <a:xfrm>
+            <a:off x="548640" y="1554480"/>
+            <a:ext cx="11094415" cy="914400"/>
           </a:xfrm>
           <a:prstGeom prst="rect">
             <a:avLst/>
@@ -4742,76 +4931,29 @@
               <a:buNone/>
             </a:pPr>
             <a:r>
-              <a:rPr lang="en-US" sz="3400" b="1" dirty="0">
-                <a:solidFill>
-                  <a:srgbClr val="27303A"/>
-                </a:solidFill>
-              </a:rPr>
-              <a:t>Zum Nachlesen</a:t>
-            </a:r>
-            <a:endParaRPr lang="en-US" sz="3400" dirty="0"/>
-          </a:p>
-        </p:txBody>
-      </p:sp>
-      <p:sp>
-        <p:nvSpPr>
-          <p:cNvPr id="3" name="icon-kreis-FaBook"/>
+              <a:rPr lang="en-US" sz="4000" b="1" dirty="0">
+                <a:solidFill>
+                  <a:srgbClr val="FFFFFF"/>
+                </a:solidFill>
+              </a:rPr>
+              <a:t>Jetzt du</a:t>
+            </a:r>
+            <a:endParaRPr lang="en-US" sz="4000" dirty="0"/>
+          </a:p>
+        </p:txBody>
+      </p:sp>
+      <p:sp>
+        <p:nvSpPr>
+          <p:cNvPr id="3" name="Text 0"/>
           <p:cNvSpPr/>
-          <p:nvPr/>
-        </p:nvSpPr>
-        <p:spPr>
-          <a:xfrm>
-            <a:off x="548640" y="2446020"/>
-            <a:ext cx="548640" cy="548640"/>
-          </a:xfrm>
-          <a:prstGeom prst="ellipse">
-            <a:avLst/>
-          </a:prstGeom>
-          <a:solidFill>
-            <a:srgbClr val="006FAD"/>
-          </a:solidFill>
-          <a:ln w="12700">
-            <a:solidFill>
-              <a:srgbClr val="006FAD"/>
-            </a:solidFill>
-            <a:prstDash val="solid"/>
-          </a:ln>
-        </p:spPr>
-      </p:sp>
-      <p:pic>
-        <p:nvPicPr>
-          <p:cNvPr id="4" name="icon-FaBook" descr="C:\Users\Thanam\AppData\Local\Temp\claude\c--Projekt-Trainings-azure-basics-training\a9e0bf4e-0d08-4082-a38a-5b8886538508\scratchpad\pptx\assets\icons\FaBook.png">    </p:cNvPr>
-          <p:cNvPicPr>
-            <a:picLocks noChangeAspect="1"/>
-          </p:cNvPicPr>
-          <p:nvPr/>
-        </p:nvPicPr>
-        <p:blipFill>
-          <a:blip r:embed="rId1"/>
-          <a:stretch>
-            <a:fillRect/>
-          </a:stretch>
-        </p:blipFill>
-        <p:spPr>
-          <a:xfrm>
-            <a:off x="680314" y="2577694"/>
-            <a:ext cx="285293" cy="285293"/>
-          </a:xfrm>
-          <a:prstGeom prst="rect">
-            <a:avLst/>
-          </a:prstGeom>
-        </p:spPr>
-      </p:pic>
-      <p:sp>
-        <p:nvSpPr>
-          <p:cNvPr id="5" name="Text 2"/>
-          <p:cNvSpPr txBox="1"/>
-          <p:nvPr/>
-        </p:nvSpPr>
-        <p:spPr>
-          <a:xfrm>
-            <a:off x="1325880" y="2240280"/>
-            <a:ext cx="10317175" cy="960120"/>
+          <p:nvPr>
+            <p:ph idx="102" type="body" hasCustomPrompt="1"/>
+          </p:nvPr>
+        </p:nvSpPr>
+        <p:spPr>
+          <a:xfrm>
+            <a:off x="548640" y="2560320"/>
+            <a:ext cx="11094415" cy="640080"/>
           </a:xfrm>
           <a:prstGeom prst="rect">
             <a:avLst/>
@@ -4820,377 +4962,19 @@
           <a:ln/>
         </p:spPr>
         <p:txBody>
-          <a:bodyPr wrap="square" lIns="0" tIns="0" rIns="0" bIns="0" rtlCol="0" anchor="ctr"/>
-          <a:lstStyle/>
-          <a:p>
-            <a:pPr indent="0" marL="0">
-              <a:buNone/>
-            </a:pPr>
-            <a:r>
-              <a:rPr lang="en-US" sz="1800" b="1" dirty="0">
-                <a:solidFill>
-                  <a:srgbClr val="27303A"/>
-                </a:solidFill>
-              </a:rPr>
-              <a:t>Theorie im Repository</a:t>
-            </a:r>
-            <a:endParaRPr lang="en-US" sz="1800" dirty="0"/>
-          </a:p>
-          <a:p>
-            <a:pPr indent="0" marL="0">
-              <a:buNone/>
-            </a:pPr>
-            <a:r>
-              <a:rPr lang="en-US" sz="1800" dirty="0">
-                <a:solidFill>
-                  <a:srgbClr val="6F6F6F"/>
-                </a:solidFill>
-              </a:rPr>
-              <a:t>theorie/01-virtualisierung.md</a:t>
-            </a:r>
-            <a:endParaRPr lang="en-US" sz="1800" dirty="0"/>
-          </a:p>
-        </p:txBody>
-      </p:sp>
-      <p:sp>
-        <p:nvSpPr>
-          <p:cNvPr id="6" name="icon-kreis-FaGraduationCap"/>
-          <p:cNvSpPr/>
-          <p:nvPr/>
-        </p:nvSpPr>
-        <p:spPr>
-          <a:xfrm>
-            <a:off x="548640" y="3406140"/>
-            <a:ext cx="548640" cy="548640"/>
-          </a:xfrm>
-          <a:prstGeom prst="ellipse">
-            <a:avLst/>
-          </a:prstGeom>
-          <a:solidFill>
-            <a:srgbClr val="006FAD"/>
-          </a:solidFill>
-          <a:ln w="12700">
-            <a:solidFill>
-              <a:srgbClr val="006FAD"/>
-            </a:solidFill>
-            <a:prstDash val="solid"/>
-          </a:ln>
-        </p:spPr>
-      </p:sp>
-      <p:pic>
-        <p:nvPicPr>
-          <p:cNvPr id="7" name="icon-FaGraduationCap" descr="C:\Users\Thanam\AppData\Local\Temp\claude\c--Projekt-Trainings-azure-basics-training\a9e0bf4e-0d08-4082-a38a-5b8886538508\scratchpad\pptx\assets\icons\FaGraduationCap.png">    </p:cNvPr>
-          <p:cNvPicPr>
-            <a:picLocks noChangeAspect="1"/>
-          </p:cNvPicPr>
-          <p:nvPr/>
-        </p:nvPicPr>
-        <p:blipFill>
-          <a:blip r:embed="rId2"/>
-          <a:stretch>
-            <a:fillRect/>
-          </a:stretch>
-        </p:blipFill>
-        <p:spPr>
-          <a:xfrm>
-            <a:off x="680314" y="3537814"/>
-            <a:ext cx="285293" cy="285293"/>
-          </a:xfrm>
-          <a:prstGeom prst="rect">
-            <a:avLst/>
-          </a:prstGeom>
-        </p:spPr>
-      </p:pic>
-      <p:sp>
-        <p:nvSpPr>
-          <p:cNvPr id="8" name="Text 4"/>
-          <p:cNvSpPr txBox="1"/>
-          <p:nvPr/>
-        </p:nvSpPr>
-        <p:spPr>
-          <a:xfrm>
-            <a:off x="1325880" y="3200400"/>
-            <a:ext cx="10317175" cy="960120"/>
-          </a:xfrm>
-          <a:prstGeom prst="rect">
-            <a:avLst/>
-          </a:prstGeom>
-          <a:noFill/>
-          <a:ln/>
-        </p:spPr>
-        <p:txBody>
-          <a:bodyPr wrap="square" lIns="0" tIns="0" rIns="0" bIns="0" rtlCol="0" anchor="ctr"/>
-          <a:lstStyle/>
-          <a:p>
-            <a:pPr indent="0" marL="0">
-              <a:buNone/>
-            </a:pPr>
-            <a:r>
-              <a:rPr lang="en-US" sz="1800" b="1" dirty="0">
-                <a:solidFill>
-                  <a:srgbClr val="27303A"/>
-                </a:solidFill>
-              </a:rPr>
-              <a:t>Microsoft</a:t>
-            </a:r>
-            <a:endParaRPr lang="en-US" sz="1800" dirty="0"/>
-          </a:p>
-          <a:p>
-            <a:pPr indent="0" marL="0">
-              <a:buNone/>
-            </a:pPr>
-            <a:r>
-              <a:rPr lang="en-US" sz="1800" dirty="0">
-                <a:solidFill>
-                  <a:srgbClr val="6F6F6F"/>
-                </a:solidFill>
-              </a:rPr>
-              <a:t>Was ist Virtualisierung? · Container im Vergleich zu virtuellen Computern</a:t>
-            </a:r>
-            <a:endParaRPr lang="en-US" sz="1800" dirty="0"/>
-          </a:p>
-        </p:txBody>
-      </p:sp>
-      <p:sp>
-        <p:nvSpPr>
-          <p:cNvPr id="9" name="icon-kreis-FaBook"/>
-          <p:cNvSpPr/>
-          <p:nvPr/>
-        </p:nvSpPr>
-        <p:spPr>
-          <a:xfrm>
-            <a:off x="548640" y="4366260"/>
-            <a:ext cx="548640" cy="548640"/>
-          </a:xfrm>
-          <a:prstGeom prst="ellipse">
-            <a:avLst/>
-          </a:prstGeom>
-          <a:solidFill>
-            <a:srgbClr val="006FAD"/>
-          </a:solidFill>
-          <a:ln w="12700">
-            <a:solidFill>
-              <a:srgbClr val="006FAD"/>
-            </a:solidFill>
-            <a:prstDash val="solid"/>
-          </a:ln>
-        </p:spPr>
-      </p:sp>
-      <p:pic>
-        <p:nvPicPr>
-          <p:cNvPr id="10" name="icon-FaBook" descr="C:\Users\Thanam\AppData\Local\Temp\claude\c--Projekt-Trainings-azure-basics-training\a9e0bf4e-0d08-4082-a38a-5b8886538508\scratchpad\pptx\assets\icons\FaBook.png">    </p:cNvPr>
-          <p:cNvPicPr>
-            <a:picLocks noChangeAspect="1"/>
-          </p:cNvPicPr>
-          <p:nvPr/>
-        </p:nvPicPr>
-        <p:blipFill>
-          <a:blip r:embed="rId3"/>
-          <a:stretch>
-            <a:fillRect/>
-          </a:stretch>
-        </p:blipFill>
-        <p:spPr>
-          <a:xfrm>
-            <a:off x="680314" y="4497934"/>
-            <a:ext cx="285293" cy="285293"/>
-          </a:xfrm>
-          <a:prstGeom prst="rect">
-            <a:avLst/>
-          </a:prstGeom>
-        </p:spPr>
-      </p:pic>
-      <p:sp>
-        <p:nvSpPr>
-          <p:cNvPr id="11" name="Text 6"/>
-          <p:cNvSpPr txBox="1"/>
-          <p:nvPr/>
-        </p:nvSpPr>
-        <p:spPr>
-          <a:xfrm>
-            <a:off x="1325880" y="4160520"/>
-            <a:ext cx="10317175" cy="960120"/>
-          </a:xfrm>
-          <a:prstGeom prst="rect">
-            <a:avLst/>
-          </a:prstGeom>
-          <a:noFill/>
-          <a:ln/>
-        </p:spPr>
-        <p:txBody>
-          <a:bodyPr wrap="square" lIns="0" tIns="0" rIns="0" bIns="0" rtlCol="0" anchor="ctr"/>
-          <a:lstStyle/>
-          <a:p>
-            <a:pPr indent="0" marL="0">
-              <a:buNone/>
-            </a:pPr>
-            <a:r>
-              <a:rPr lang="en-US" sz="1800" b="1" dirty="0">
-                <a:solidFill>
-                  <a:srgbClr val="27303A"/>
-                </a:solidFill>
-              </a:rPr>
-              <a:t>TBZ M346</a:t>
-            </a:r>
-            <a:endParaRPr lang="en-US" sz="1800" dirty="0"/>
-          </a:p>
-          <a:p>
-            <a:pPr indent="0" marL="0">
-              <a:buNone/>
-            </a:pPr>
-            <a:r>
-              <a:rPr lang="en-US" sz="1800" dirty="0">
-                <a:solidFill>
-                  <a:srgbClr val="6F6F6F"/>
-                </a:solidFill>
-              </a:rPr>
-              <a:t>Virtualisierung &amp; Hypervisor (Texte und Grafik übernommen)</a:t>
-            </a:r>
-            <a:endParaRPr lang="en-US" sz="1800" dirty="0"/>
-          </a:p>
-        </p:txBody>
-      </p:sp>
-      <p:sp>
-        <p:nvSpPr>
-          <p:cNvPr id="25" name="Slide Number Placeholder 0"/>
-          <p:cNvSpPr>
-            <a:spLocks noGrp="1"/>
-          </p:cNvSpPr>
-          <p:nvPr>
-            <p:ph type="sldNum" sz="quarter" idx="4294967295"/>
-          </p:nvPr>
-        </p:nvSpPr>
-        <p:spPr>
-          <a:xfrm>
-            <a:off x="11183112" y="6336792"/>
-            <a:ext cx="457200" cy="365760"/>
-          </a:xfrm>
-          <a:prstGeom prst="rect">
-            <a:avLst/>
-          </a:prstGeom>
-          <a:extLst>
-            <a:ext uri="{C572A759-6A51-4108-AA02-DFA0A04FC94B}">
-              <ma14:wrappingTextBoxFlag xmlns:ma14="http://schemas.microsoft.com/office/mac/drawingml/2011/main" val="0"/>
-            </a:ext>
-          </a:extLst>
-        </p:spPr>
-        <p:txBody>
-          <a:bodyPr/>
-          <a:lstStyle>
-            <a:lvl1pPr>
-              <a:defRPr sz="1000">
-                <a:solidFill>
-                  <a:srgbClr val="6F6F6F"/>
-                </a:solidFill>
-              </a:defRPr>
-            </a:lvl1pPr>
-          </a:lstStyle>
-          <a:p>
-            <a:pPr algn="r"/>
-            <a:fld id="{F7021451-1387-4CA6-816F-3879F97B5CBC}" type="slidenum">
-              <a:rPr b="0" lang="en-US"/>
-              <a:t>14</a:t>
-            </a:fld>
-            <a:endParaRPr lang="en-US"/>
-          </a:p>
-        </p:txBody>
-      </p:sp>
-    </p:spTree>
-  </p:cSld>
-  <p:clrMapOvr>
-    <a:masterClrMapping/>
-  </p:clrMapOvr>
-</p:sld>
-</file>
-
-<file path=ppt/slides/slide15.xml><?xml version="1.0" encoding="utf-8"?>
-<p:sld xmlns:a="http://schemas.openxmlformats.org/drawingml/2006/main" xmlns:r="http://schemas.openxmlformats.org/officeDocument/2006/relationships" xmlns:p="http://schemas.openxmlformats.org/presentationml/2006/main">
-  <p:cSld name="Slide 15">
-    <p:spTree>
-      <p:nvGrpSpPr>
-        <p:cNvPr id="1" name=""/>
-        <p:cNvGrpSpPr/>
-        <p:nvPr/>
-      </p:nvGrpSpPr>
-      <p:grpSpPr>
-        <a:xfrm>
-          <a:off x="0" y="0"/>
-          <a:ext cx="0" cy="0"/>
-          <a:chOff x="0" y="0"/>
-          <a:chExt cx="0" cy="0"/>
-        </a:xfrm>
-      </p:grpSpPr>
-      <p:sp>
-        <p:nvSpPr>
-          <p:cNvPr id="2" name="Text 0"/>
-          <p:cNvSpPr/>
-          <p:nvPr>
-            <p:ph idx="101" type="title" hasCustomPrompt="1"/>
-          </p:nvPr>
-        </p:nvSpPr>
-        <p:spPr>
-          <a:xfrm>
-            <a:off x="548640" y="1554480"/>
-            <a:ext cx="11094415" cy="914400"/>
-          </a:xfrm>
-          <a:prstGeom prst="rect">
-            <a:avLst/>
-          </a:prstGeom>
-          <a:noFill/>
-          <a:ln/>
-        </p:spPr>
-        <p:txBody>
-          <a:bodyPr wrap="square" lIns="0" tIns="0" rIns="0" bIns="0" rtlCol="0" anchor="ctr"/>
+          <a:bodyPr wrap="square" lIns="0" tIns="0" rIns="0" bIns="0" rtlCol="0" anchor="t"/>
           <a:lstStyle/>
           <a:p>
             <a:pPr algn="l" indent="0" marL="0">
               <a:buNone/>
             </a:pPr>
             <a:r>
-              <a:rPr lang="en-US" sz="4000" b="1" dirty="0">
-                <a:solidFill>
-                  <a:srgbClr val="FFFFFF"/>
-                </a:solidFill>
-              </a:rPr>
-              <a:t>Jetzt du</a:t>
-            </a:r>
-            <a:endParaRPr lang="en-US" sz="4000" dirty="0"/>
-          </a:p>
-        </p:txBody>
-      </p:sp>
-      <p:sp>
-        <p:nvSpPr>
-          <p:cNvPr id="3" name="Text 0"/>
-          <p:cNvSpPr/>
-          <p:nvPr>
-            <p:ph idx="102" type="body" hasCustomPrompt="1"/>
-          </p:nvPr>
-        </p:nvSpPr>
-        <p:spPr>
-          <a:xfrm>
-            <a:off x="548640" y="2560320"/>
-            <a:ext cx="11094415" cy="640080"/>
-          </a:xfrm>
-          <a:prstGeom prst="rect">
-            <a:avLst/>
-          </a:prstGeom>
-          <a:noFill/>
-          <a:ln/>
-        </p:spPr>
-        <p:txBody>
-          <a:bodyPr wrap="square" lIns="0" tIns="0" rIns="0" bIns="0" rtlCol="0" anchor="t"/>
-          <a:lstStyle/>
-          <a:p>
-            <a:pPr algn="l" indent="0" marL="0">
-              <a:buNone/>
-            </a:pPr>
-            <a:r>
               <a:rPr lang="en-US" sz="2000" dirty="0">
                 <a:solidFill>
                   <a:srgbClr val="DEE2FB"/>
                 </a:solidFill>
               </a:rPr>
-              <a:t>Auftrag 1.1: Hypervisor und dein Laptop · Auftrag 1.3: Netzwerk und SSH</a:t>
+              <a:t>Auftrag 1.1–1.5 · ⭐ 1.6</a:t>
             </a:r>
             <a:endParaRPr lang="en-US" sz="2000" dirty="0"/>
           </a:p>
@@ -5520,7 +5304,7 @@
                   <a:srgbClr val="27303A"/>
                 </a:solidFill>
               </a:rPr>
-              <a:t>Overcommitment</a:t>
+              <a:t>Hardware teilen</a:t>
             </a:r>
             <a:endParaRPr lang="en-US" sz="2000" dirty="0"/>
           </a:p>
@@ -5559,7 +5343,7 @@
                   <a:srgbClr val="27303A"/>
                 </a:solidFill>
               </a:rPr>
-              <a:t>Warum man mehr zuweisen kann, als da ist</a:t>
+              <a:t>CPU, RAM und Festplatte für jede VM</a:t>
             </a:r>
             <a:endParaRPr lang="en-US" sz="1600" dirty="0"/>
           </a:p>
@@ -5594,7 +5378,7 @@
       </p:sp>
       <p:sp>
         <p:nvSpPr>
-          <p:cNvPr id="14" name="icon-kreis-FaNetworkWired"/>
+          <p:cNvPr id="14" name="icon-kreis-FaRocket"/>
           <p:cNvSpPr/>
           <p:nvPr/>
         </p:nvSpPr>
@@ -5619,7 +5403,7 @@
       </p:sp>
       <p:pic>
         <p:nvPicPr>
-          <p:cNvPr id="15" name="icon-FaNetworkWired" descr="C:\Users\Thanam\AppData\Local\Temp\claude\c--Projekt-Trainings-azure-basics-training\a9e0bf4e-0d08-4082-a38a-5b8886538508\scratchpad\pptx\assets\icons\FaNetworkWired.png">    </p:cNvPr>
+          <p:cNvPr id="15" name="icon-FaRocket" descr="C:\Users\Thanam\AppData\Local\Temp\claude\c--Projekt-Trainings-azure-basics-training\a9e0bf4e-0d08-4082-a38a-5b8886538508\scratchpad\pptx\assets\icons\FaRocket.png">    </p:cNvPr>
           <p:cNvPicPr>
             <a:picLocks noChangeAspect="1"/>
           </p:cNvPicPr>
@@ -5673,7 +5457,7 @@
                   <a:srgbClr val="27303A"/>
                 </a:solidFill>
               </a:rPr>
-              <a:t>VM-Netzwerk</a:t>
+              <a:t>Multipass und cloud-init</a:t>
             </a:r>
             <a:endParaRPr lang="en-US" sz="2000" dirty="0"/>
           </a:p>
@@ -5712,7 +5496,7 @@
                   <a:srgbClr val="27303A"/>
                 </a:solidFill>
               </a:rPr>
-              <a:t>NAT, Netzwerkbrücke, Portweiterleitung</a:t>
+              <a:t>Eine VM mit einem Befehl – und automatisch eingerichtet</a:t>
             </a:r>
             <a:endParaRPr lang="en-US" sz="1600" dirty="0"/>
           </a:p>
@@ -5747,7 +5531,7 @@
       </p:sp>
       <p:sp>
         <p:nvSpPr>
-          <p:cNvPr id="19" name="icon-kreis-FaCopy"/>
+          <p:cNvPr id="19" name="icon-kreis-FaKey"/>
           <p:cNvSpPr/>
           <p:nvPr/>
         </p:nvSpPr>
@@ -5772,7 +5556,7 @@
       </p:sp>
       <p:pic>
         <p:nvPicPr>
-          <p:cNvPr id="20" name="icon-FaCopy" descr="C:\Users\Thanam\AppData\Local\Temp\claude\c--Projekt-Trainings-azure-basics-training\a9e0bf4e-0d08-4082-a38a-5b8886538508\scratchpad\pptx\assets\icons\FaCopy.png">    </p:cNvPr>
+          <p:cNvPr id="20" name="icon-FaKey" descr="C:\Users\Thanam\AppData\Local\Temp\claude\c--Projekt-Trainings-azure-basics-training\a9e0bf4e-0d08-4082-a38a-5b8886538508\scratchpad\pptx\assets\icons\FaKey.png">    </p:cNvPr>
           <p:cNvPicPr>
             <a:picLocks noChangeAspect="1"/>
           </p:cNvPicPr>
@@ -5826,7 +5610,7 @@
                   <a:srgbClr val="27303A"/>
                 </a:solidFill>
               </a:rPr>
-              <a:t>Snapshots und Container</a:t>
+              <a:t>SSH-Schlüssel</a:t>
             </a:r>
             <a:endParaRPr lang="en-US" sz="2000" dirty="0"/>
           </a:p>
@@ -5865,7 +5649,7 @@
                   <a:srgbClr val="27303A"/>
                 </a:solidFill>
               </a:rPr>
-              <a:t>Zustände sichern – und die leichte Alternative zur VM</a:t>
+              <a:t>Dein Zugang zu Servern in der Cloud</a:t>
             </a:r>
             <a:endParaRPr lang="en-US" sz="1600" dirty="0"/>
           </a:p>
@@ -6975,7 +6759,7 @@
                   <a:srgbClr val="27303A"/>
                 </a:solidFill>
               </a:rPr>
-              <a:t>Overcommitment: mehr zuweisen, als da ist</a:t>
+              <a:t>VMs teilen sich die Hardware</a:t>
             </a:r>
             <a:endParaRPr lang="en-US" sz="3400" dirty="0"/>
           </a:p>
@@ -7074,7 +6858,7 @@
                   <a:srgbClr val="27303A"/>
                 </a:solidFill>
               </a:rPr>
-              <a:t>logische Prozessoren im Laptop</a:t>
+              <a:t>Prozessoren im Laptop</a:t>
             </a:r>
             <a:endParaRPr lang="en-US" sz="1500" dirty="0"/>
           </a:p>
@@ -7272,7 +7056,7 @@
                   <a:srgbClr val="FFFFFF"/>
                 </a:solidFill>
               </a:rPr>
-              <a:t>vCPUs zugewiesen</a:t>
+              <a:t>vCPUs zusammen</a:t>
             </a:r>
             <a:endParaRPr lang="en-US" sz="1500" dirty="0"/>
           </a:p>
@@ -7312,7 +7096,7 @@
                   <a:srgbClr val="27303A"/>
                 </a:solidFill>
               </a:rPr>
-              <a:t>CPU: vCPUs teilen sich die echten Kerne in Zeitscheiben – gut, solange nicht alle gleichzeitig Volllast haben.</a:t>
+              <a:t>Die VMs teilen sich die echten Prozessoren abwechselnd. Das heisst Überbuchung (Overcommitment).</a:t>
             </a:r>
             <a:endParaRPr lang="en-US" sz="1800" dirty="0"/>
           </a:p>
@@ -7330,7 +7114,7 @@
                   <a:srgbClr val="27303A"/>
                 </a:solidFill>
               </a:rPr>
-              <a:t>RAM: Reicht der Speicher nicht, lagert der Host auf die Disk aus – dann wird alles sehr langsam.</a:t>
+              <a:t>Solange nicht alle gleichzeitig voll arbeiten, merkt man nichts. Sonst wird es langsam.</a:t>
             </a:r>
             <a:endParaRPr lang="en-US" sz="1800" dirty="0"/>
           </a:p>
@@ -7408,7 +7192,7 @@
       </p:grpSpPr>
       <p:sp>
         <p:nvSpPr>
-          <p:cNvPr id="2" name="Text 0"/>
+          <p:cNvPr id="2" name="Text 1"/>
           <p:cNvSpPr/>
           <p:nvPr>
             <p:ph idx="102" type="title" hasCustomPrompt="1"/>
@@ -7416,8 +7200,8 @@
         </p:nvSpPr>
         <p:spPr>
           <a:xfrm>
-            <a:off x="548640" y="2194560"/>
-            <a:ext cx="7863840" cy="1371600"/>
+            <a:off x="548640" y="320040"/>
+            <a:ext cx="11094415" cy="822960"/>
           </a:xfrm>
           <a:prstGeom prst="rect">
             <a:avLst/>
@@ -7426,59 +7210,90 @@
           <a:ln/>
         </p:spPr>
         <p:txBody>
-          <a:bodyPr wrap="square" lIns="0" tIns="0" rIns="0" bIns="0" rtlCol="0" anchor="b"/>
+          <a:bodyPr wrap="square" lIns="0" tIns="0" rIns="0" bIns="0" rtlCol="0" anchor="ctr"/>
           <a:lstStyle/>
           <a:p>
             <a:pPr algn="l" indent="0" marL="0">
               <a:buNone/>
             </a:pPr>
             <a:r>
-              <a:rPr lang="en-US" sz="4000" b="1" dirty="0">
-                <a:solidFill>
-                  <a:srgbClr val="FFFFFF"/>
-                </a:solidFill>
-              </a:rPr>
-              <a:t>VM-Netzwerk</a:t>
-            </a:r>
-            <a:endParaRPr lang="en-US" sz="4000" dirty="0"/>
-          </a:p>
-        </p:txBody>
-      </p:sp>
-      <p:sp>
-        <p:nvSpPr>
-          <p:cNvPr id="3" name="Text 0"/>
-          <p:cNvSpPr/>
-          <p:nvPr>
-            <p:ph idx="103" type="body" hasCustomPrompt="1"/>
-          </p:nvPr>
-        </p:nvSpPr>
-        <p:spPr>
-          <a:xfrm>
-            <a:off x="548640" y="3703320"/>
-            <a:ext cx="7863840" cy="1097280"/>
-          </a:xfrm>
-          <a:prstGeom prst="rect">
-            <a:avLst/>
-          </a:prstGeom>
-          <a:noFill/>
-          <a:ln/>
-        </p:spPr>
-        <p:txBody>
-          <a:bodyPr wrap="square" lIns="0" tIns="0" rIns="0" bIns="0" rtlCol="0" anchor="t"/>
-          <a:lstStyle/>
-          <a:p>
-            <a:pPr algn="l" indent="0" marL="0">
-              <a:buNone/>
-            </a:pPr>
-            <a:r>
-              <a:rPr lang="en-US" sz="2000" dirty="0">
-                <a:solidFill>
-                  <a:srgbClr val="DEE2FB"/>
-                </a:solidFill>
-              </a:rPr>
-              <a:t>Input 2 · NAT, Netzwerkbrücke und SSH</a:t>
-            </a:r>
-            <a:endParaRPr lang="en-US" sz="2000" dirty="0"/>
+              <a:rPr lang="en-US" sz="3400" b="1" dirty="0">
+                <a:solidFill>
+                  <a:srgbClr val="27303A"/>
+                </a:solidFill>
+              </a:rPr>
+              <a:t>VM und Container</a:t>
+            </a:r>
+            <a:endParaRPr lang="en-US" sz="3400" dirty="0"/>
+          </a:p>
+        </p:txBody>
+      </p:sp>
+      <p:pic>
+        <p:nvPicPr>
+          <p:cNvPr id="3" name="diagramm" descr="VM und Container">    </p:cNvPr>
+          <p:cNvPicPr>
+            <a:picLocks noChangeAspect="1"/>
+          </p:cNvPicPr>
+          <p:nvPr/>
+        </p:nvPicPr>
+        <p:blipFill>
+          <a:blip r:embed="rId1"/>
+          <a:stretch>
+            <a:fillRect/>
+          </a:stretch>
+        </p:blipFill>
+        <p:spPr>
+          <a:xfrm>
+            <a:off x="548640" y="1694560"/>
+            <a:ext cx="11094415" cy="3971801"/>
+          </a:xfrm>
+          <a:prstGeom prst="rect">
+            <a:avLst/>
+          </a:prstGeom>
+        </p:spPr>
+      </p:pic>
+      <p:sp>
+        <p:nvSpPr>
+          <p:cNvPr id="25" name="Slide Number Placeholder 0"/>
+          <p:cNvSpPr>
+            <a:spLocks noGrp="1"/>
+          </p:cNvSpPr>
+          <p:nvPr>
+            <p:ph type="sldNum" sz="quarter" idx="4294967295"/>
+          </p:nvPr>
+        </p:nvSpPr>
+        <p:spPr>
+          <a:xfrm>
+            <a:off x="11183112" y="6336792"/>
+            <a:ext cx="457200" cy="365760"/>
+          </a:xfrm>
+          <a:prstGeom prst="rect">
+            <a:avLst/>
+          </a:prstGeom>
+          <a:extLst>
+            <a:ext uri="{C572A759-6A51-4108-AA02-DFA0A04FC94B}">
+              <ma14:wrappingTextBoxFlag xmlns:ma14="http://schemas.microsoft.com/office/mac/drawingml/2011/main" val="0"/>
+            </a:ext>
+          </a:extLst>
+        </p:spPr>
+        <p:txBody>
+          <a:bodyPr/>
+          <a:lstStyle>
+            <a:lvl1pPr>
+              <a:defRPr sz="1000">
+                <a:solidFill>
+                  <a:srgbClr val="6F6F6F"/>
+                </a:solidFill>
+              </a:defRPr>
+            </a:lvl1pPr>
+          </a:lstStyle>
+          <a:p>
+            <a:pPr algn="r"/>
+            <a:fld id="{F7021451-1387-4CA6-816F-3879F97B5CBC}" type="slidenum">
+              <a:rPr b="0" lang="en-US"/>
+              <a:t>7</a:t>
+            </a:fld>
+            <a:endParaRPr lang="en-US"/>
           </a:p>
         </p:txBody>
       </p:sp>
@@ -7509,7 +7324,7 @@
       </p:grpSpPr>
       <p:sp>
         <p:nvSpPr>
-          <p:cNvPr id="2" name="Text 1"/>
+          <p:cNvPr id="2" name="Text 0"/>
           <p:cNvSpPr/>
           <p:nvPr>
             <p:ph idx="102" type="title" hasCustomPrompt="1"/>
@@ -7517,8 +7332,8 @@
         </p:nvSpPr>
         <p:spPr>
           <a:xfrm>
-            <a:off x="548640" y="320040"/>
-            <a:ext cx="11094415" cy="822960"/>
+            <a:off x="548640" y="2194560"/>
+            <a:ext cx="7863840" cy="1371600"/>
           </a:xfrm>
           <a:prstGeom prst="rect">
             <a:avLst/>
@@ -7527,90 +7342,59 @@
           <a:ln/>
         </p:spPr>
         <p:txBody>
-          <a:bodyPr wrap="square" lIns="0" tIns="0" rIns="0" bIns="0" rtlCol="0" anchor="ctr"/>
+          <a:bodyPr wrap="square" lIns="0" tIns="0" rIns="0" bIns="0" rtlCol="0" anchor="b"/>
           <a:lstStyle/>
           <a:p>
             <a:pPr algn="l" indent="0" marL="0">
               <a:buNone/>
             </a:pPr>
             <a:r>
-              <a:rPr lang="en-US" sz="3400" b="1" dirty="0">
-                <a:solidFill>
-                  <a:srgbClr val="27303A"/>
-                </a:solidFill>
-              </a:rPr>
-              <a:t>NAT und Netzwerkbrücke</a:t>
-            </a:r>
-            <a:endParaRPr lang="en-US" sz="3400" dirty="0"/>
-          </a:p>
-        </p:txBody>
-      </p:sp>
-      <p:pic>
-        <p:nvPicPr>
-          <p:cNvPr id="3" name="diagramm" descr="NAT und Netzwerkbrücke">    </p:cNvPr>
-          <p:cNvPicPr>
-            <a:picLocks noChangeAspect="1"/>
-          </p:cNvPicPr>
-          <p:nvPr/>
-        </p:nvPicPr>
-        <p:blipFill>
-          <a:blip r:embed="rId1"/>
-          <a:stretch>
-            <a:fillRect/>
-          </a:stretch>
-        </p:blipFill>
-        <p:spPr>
-          <a:xfrm>
-            <a:off x="594492" y="1325880"/>
-            <a:ext cx="11002710" cy="4709160"/>
-          </a:xfrm>
-          <a:prstGeom prst="rect">
-            <a:avLst/>
-          </a:prstGeom>
-        </p:spPr>
-      </p:pic>
-      <p:sp>
-        <p:nvSpPr>
-          <p:cNvPr id="25" name="Slide Number Placeholder 0"/>
-          <p:cNvSpPr>
-            <a:spLocks noGrp="1"/>
-          </p:cNvSpPr>
-          <p:nvPr>
-            <p:ph type="sldNum" sz="quarter" idx="4294967295"/>
-          </p:nvPr>
-        </p:nvSpPr>
-        <p:spPr>
-          <a:xfrm>
-            <a:off x="11183112" y="6336792"/>
-            <a:ext cx="457200" cy="365760"/>
-          </a:xfrm>
-          <a:prstGeom prst="rect">
-            <a:avLst/>
-          </a:prstGeom>
-          <a:extLst>
-            <a:ext uri="{C572A759-6A51-4108-AA02-DFA0A04FC94B}">
-              <ma14:wrappingTextBoxFlag xmlns:ma14="http://schemas.microsoft.com/office/mac/drawingml/2011/main" val="0"/>
-            </a:ext>
-          </a:extLst>
-        </p:spPr>
-        <p:txBody>
-          <a:bodyPr/>
-          <a:lstStyle>
-            <a:lvl1pPr>
-              <a:defRPr sz="1000">
-                <a:solidFill>
-                  <a:srgbClr val="6F6F6F"/>
-                </a:solidFill>
-              </a:defRPr>
-            </a:lvl1pPr>
-          </a:lstStyle>
-          <a:p>
-            <a:pPr algn="r"/>
-            <a:fld id="{F7021451-1387-4CA6-816F-3879F97B5CBC}" type="slidenum">
-              <a:rPr b="0" lang="en-US"/>
-              <a:t>8</a:t>
-            </a:fld>
-            <a:endParaRPr lang="en-US"/>
+              <a:rPr lang="en-US" sz="4000" b="1" dirty="0">
+                <a:solidFill>
+                  <a:srgbClr val="FFFFFF"/>
+                </a:solidFill>
+              </a:rPr>
+              <a:t>Automatisch statt von Hand</a:t>
+            </a:r>
+            <a:endParaRPr lang="en-US" sz="4000" dirty="0"/>
+          </a:p>
+        </p:txBody>
+      </p:sp>
+      <p:sp>
+        <p:nvSpPr>
+          <p:cNvPr id="3" name="Text 0"/>
+          <p:cNvSpPr/>
+          <p:nvPr>
+            <p:ph idx="103" type="body" hasCustomPrompt="1"/>
+          </p:nvPr>
+        </p:nvSpPr>
+        <p:spPr>
+          <a:xfrm>
+            <a:off x="548640" y="3703320"/>
+            <a:ext cx="7863840" cy="1097280"/>
+          </a:xfrm>
+          <a:prstGeom prst="rect">
+            <a:avLst/>
+          </a:prstGeom>
+          <a:noFill/>
+          <a:ln/>
+        </p:spPr>
+        <p:txBody>
+          <a:bodyPr wrap="square" lIns="0" tIns="0" rIns="0" bIns="0" rtlCol="0" anchor="t"/>
+          <a:lstStyle/>
+          <a:p>
+            <a:pPr algn="l" indent="0" marL="0">
+              <a:buNone/>
+            </a:pPr>
+            <a:r>
+              <a:rPr lang="en-US" sz="2000" dirty="0">
+                <a:solidFill>
+                  <a:srgbClr val="DEE2FB"/>
+                </a:solidFill>
+              </a:rPr>
+              <a:t>Multipass und cloud-init</a:t>
+            </a:r>
+            <a:endParaRPr lang="en-US" sz="2000" dirty="0"/>
           </a:p>
         </p:txBody>
       </p:sp>
@@ -7671,978 +7455,49 @@
                   <a:srgbClr val="27303A"/>
                 </a:solidFill>
               </a:rPr>
-              <a:t>Drei Netzwerkmodi</a:t>
+              <a:t>Multipass: eine VM mit einem Befehl</a:t>
             </a:r>
             <a:endParaRPr lang="en-US" sz="3400" dirty="0"/>
           </a:p>
         </p:txBody>
       </p:sp>
-      <p:graphicFrame>
-        <p:nvGraphicFramePr>
-          <p:cNvPr id="10" name="Table 0"/>
-          <p:cNvGraphicFramePr>
-            <a:graphicFrameLocks noGrp="1"/>
-          </p:cNvGraphicFramePr>
-          <p:nvPr>
-            <p:extLst>
-              <p:ext uri="{D42A27DB-BD31-4B8C-83A1-F6EECF244321}">
-                <p14:modId xmlns:p14="http://schemas.microsoft.com/office/powerpoint/2010/main" val="1579011935"/>
-              </p:ext>
-            </p:extLst>
-          </p:nvPr>
-        </p:nvGraphicFramePr>
-        <p:xfrm>
-          <a:off x="548640" y="1325880"/>
-          <a:ext cx="11094415" cy="914400"/>
-        </p:xfrm>
-        <a:graphic>
-          <a:graphicData uri="http://schemas.openxmlformats.org/drawingml/2006/table">
-            <a:tbl>
-              <a:tblPr/>
-              <a:tblGrid>
-                <a:gridCol w="1929464"/>
-                <a:gridCol w="6270756"/>
-                <a:gridCol w="2894195"/>
-              </a:tblGrid>
-              <a:tr h="0">
-                <a:tc>
-                  <a:txBody>
-                    <a:bodyPr/>
-                    <a:lstStyle/>
-                    <a:p>
-                      <a:pPr indent="0" marL="0">
-                        <a:buNone/>
-                      </a:pPr>
-                      <a:r>
-                        <a:rPr lang="en-US" sz="1700" b="1" dirty="0">
-                          <a:solidFill>
-                            <a:srgbClr val="FFFFFF"/>
-                          </a:solidFill>
-                        </a:rPr>
-                        <a:t>Modus</a:t>
-                      </a:r>
-                      <a:endParaRPr lang="en-US" sz="1700" dirty="0"/>
-                    </a:p>
-                  </a:txBody>
-                  <a:tcPr marL="127000" marR="127000" marT="88900" marB="88900" anchor="ctr">
-                    <a:lnL w="9525" cap="flat" cmpd="sng" algn="ctr">
-                      <a:solidFill>
-                        <a:srgbClr val="D5D8F4"/>
-                      </a:solidFill>
-                      <a:prstDash val="solid"/>
-                      <a:round/>
-                      <a:headEnd type="none" w="med" len="med"/>
-                      <a:tailEnd type="none" w="med" len="med"/>
-                    </a:lnL>
-                    <a:lnR w="9525" cap="flat" cmpd="sng" algn="ctr">
-                      <a:solidFill>
-                        <a:srgbClr val="D5D8F4"/>
-                      </a:solidFill>
-                      <a:prstDash val="solid"/>
-                      <a:round/>
-                      <a:headEnd type="none" w="med" len="med"/>
-                      <a:tailEnd type="none" w="med" len="med"/>
-                    </a:lnR>
-                    <a:lnT w="9525" cap="flat" cmpd="sng" algn="ctr">
-                      <a:solidFill>
-                        <a:srgbClr val="D5D8F4"/>
-                      </a:solidFill>
-                      <a:prstDash val="solid"/>
-                      <a:round/>
-                      <a:headEnd type="none" w="med" len="med"/>
-                      <a:tailEnd type="none" w="med" len="med"/>
-                    </a:lnT>
-                    <a:lnB w="9525" cap="flat" cmpd="sng" algn="ctr">
-                      <a:solidFill>
-                        <a:srgbClr val="D5D8F4"/>
-                      </a:solidFill>
-                      <a:prstDash val="solid"/>
-                      <a:round/>
-                      <a:headEnd type="none" w="med" len="med"/>
-                      <a:tailEnd type="none" w="med" len="med"/>
-                    </a:lnB>
-                    <a:solidFill>
-                      <a:srgbClr val="27303A"/>
-                    </a:solidFill>
-                  </a:tcPr>
-                </a:tc>
-                <a:tc>
-                  <a:txBody>
-                    <a:bodyPr/>
-                    <a:lstStyle/>
-                    <a:p>
-                      <a:pPr indent="0" marL="0">
-                        <a:buNone/>
-                      </a:pPr>
-                      <a:r>
-                        <a:rPr lang="en-US" sz="1700" b="1" dirty="0">
-                          <a:solidFill>
-                            <a:srgbClr val="FFFFFF"/>
-                          </a:solidFill>
-                        </a:rPr>
-                        <a:t>Was passiert</a:t>
-                      </a:r>
-                      <a:endParaRPr lang="en-US" sz="1700" dirty="0"/>
-                    </a:p>
-                  </a:txBody>
-                  <a:tcPr marL="127000" marR="127000" marT="88900" marB="88900" anchor="ctr">
-                    <a:lnL w="9525" cap="flat" cmpd="sng" algn="ctr">
-                      <a:solidFill>
-                        <a:srgbClr val="D5D8F4"/>
-                      </a:solidFill>
-                      <a:prstDash val="solid"/>
-                      <a:round/>
-                      <a:headEnd type="none" w="med" len="med"/>
-                      <a:tailEnd type="none" w="med" len="med"/>
-                    </a:lnL>
-                    <a:lnR w="9525" cap="flat" cmpd="sng" algn="ctr">
-                      <a:solidFill>
-                        <a:srgbClr val="D5D8F4"/>
-                      </a:solidFill>
-                      <a:prstDash val="solid"/>
-                      <a:round/>
-                      <a:headEnd type="none" w="med" len="med"/>
-                      <a:tailEnd type="none" w="med" len="med"/>
-                    </a:lnR>
-                    <a:lnT w="9525" cap="flat" cmpd="sng" algn="ctr">
-                      <a:solidFill>
-                        <a:srgbClr val="D5D8F4"/>
-                      </a:solidFill>
-                      <a:prstDash val="solid"/>
-                      <a:round/>
-                      <a:headEnd type="none" w="med" len="med"/>
-                      <a:tailEnd type="none" w="med" len="med"/>
-                    </a:lnT>
-                    <a:lnB w="9525" cap="flat" cmpd="sng" algn="ctr">
-                      <a:solidFill>
-                        <a:srgbClr val="D5D8F4"/>
-                      </a:solidFill>
-                      <a:prstDash val="solid"/>
-                      <a:round/>
-                      <a:headEnd type="none" w="med" len="med"/>
-                      <a:tailEnd type="none" w="med" len="med"/>
-                    </a:lnB>
-                    <a:solidFill>
-                      <a:srgbClr val="27303A"/>
-                    </a:solidFill>
-                  </a:tcPr>
-                </a:tc>
-                <a:tc>
-                  <a:txBody>
-                    <a:bodyPr/>
-                    <a:lstStyle/>
-                    <a:p>
-                      <a:pPr indent="0" marL="0">
-                        <a:buNone/>
-                      </a:pPr>
-                      <a:r>
-                        <a:rPr lang="en-US" sz="1700" b="1" dirty="0">
-                          <a:solidFill>
-                            <a:srgbClr val="FFFFFF"/>
-                          </a:solidFill>
-                        </a:rPr>
-                        <a:t>Wann verwenden</a:t>
-                      </a:r>
-                      <a:endParaRPr lang="en-US" sz="1700" dirty="0"/>
-                    </a:p>
-                  </a:txBody>
-                  <a:tcPr marL="127000" marR="127000" marT="88900" marB="88900" anchor="ctr">
-                    <a:lnL w="9525" cap="flat" cmpd="sng" algn="ctr">
-                      <a:solidFill>
-                        <a:srgbClr val="D5D8F4"/>
-                      </a:solidFill>
-                      <a:prstDash val="solid"/>
-                      <a:round/>
-                      <a:headEnd type="none" w="med" len="med"/>
-                      <a:tailEnd type="none" w="med" len="med"/>
-                    </a:lnL>
-                    <a:lnR w="9525" cap="flat" cmpd="sng" algn="ctr">
-                      <a:solidFill>
-                        <a:srgbClr val="D5D8F4"/>
-                      </a:solidFill>
-                      <a:prstDash val="solid"/>
-                      <a:round/>
-                      <a:headEnd type="none" w="med" len="med"/>
-                      <a:tailEnd type="none" w="med" len="med"/>
-                    </a:lnR>
-                    <a:lnT w="9525" cap="flat" cmpd="sng" algn="ctr">
-                      <a:solidFill>
-                        <a:srgbClr val="D5D8F4"/>
-                      </a:solidFill>
-                      <a:prstDash val="solid"/>
-                      <a:round/>
-                      <a:headEnd type="none" w="med" len="med"/>
-                      <a:tailEnd type="none" w="med" len="med"/>
-                    </a:lnT>
-                    <a:lnB w="9525" cap="flat" cmpd="sng" algn="ctr">
-                      <a:solidFill>
-                        <a:srgbClr val="D5D8F4"/>
-                      </a:solidFill>
-                      <a:prstDash val="solid"/>
-                      <a:round/>
-                      <a:headEnd type="none" w="med" len="med"/>
-                      <a:tailEnd type="none" w="med" len="med"/>
-                    </a:lnB>
-                    <a:solidFill>
-                      <a:srgbClr val="27303A"/>
-                    </a:solidFill>
-                  </a:tcPr>
-                </a:tc>
-              </a:tr>
-              <a:tr h="0">
-                <a:tc>
-                  <a:txBody>
-                    <a:bodyPr/>
-                    <a:lstStyle/>
-                    <a:p>
-                      <a:pPr indent="0" marL="0">
-                        <a:buNone/>
-                      </a:pPr>
-                      <a:r>
-                        <a:rPr lang="en-US" sz="1700" dirty="0">
-                          <a:solidFill>
-                            <a:srgbClr val="27303A"/>
-                          </a:solidFill>
-                        </a:rPr>
-                        <a:t>NAT</a:t>
-                      </a:r>
-                      <a:endParaRPr lang="en-US" sz="1700" dirty="0"/>
-                    </a:p>
-                  </a:txBody>
-                  <a:tcPr marL="127000" marR="127000" marT="88900" marB="88900" anchor="ctr">
-                    <a:lnL w="9525" cap="flat" cmpd="sng" algn="ctr">
-                      <a:solidFill>
-                        <a:srgbClr val="D5D8F4"/>
-                      </a:solidFill>
-                      <a:prstDash val="solid"/>
-                      <a:round/>
-                      <a:headEnd type="none" w="med" len="med"/>
-                      <a:tailEnd type="none" w="med" len="med"/>
-                    </a:lnL>
-                    <a:lnR w="9525" cap="flat" cmpd="sng" algn="ctr">
-                      <a:solidFill>
-                        <a:srgbClr val="D5D8F4"/>
-                      </a:solidFill>
-                      <a:prstDash val="solid"/>
-                      <a:round/>
-                      <a:headEnd type="none" w="med" len="med"/>
-                      <a:tailEnd type="none" w="med" len="med"/>
-                    </a:lnR>
-                    <a:lnT w="9525" cap="flat" cmpd="sng" algn="ctr">
-                      <a:solidFill>
-                        <a:srgbClr val="D5D8F4"/>
-                      </a:solidFill>
-                      <a:prstDash val="solid"/>
-                      <a:round/>
-                      <a:headEnd type="none" w="med" len="med"/>
-                      <a:tailEnd type="none" w="med" len="med"/>
-                    </a:lnT>
-                    <a:lnB w="9525" cap="flat" cmpd="sng" algn="ctr">
-                      <a:solidFill>
-                        <a:srgbClr val="D5D8F4"/>
-                      </a:solidFill>
-                      <a:prstDash val="solid"/>
-                      <a:round/>
-                      <a:headEnd type="none" w="med" len="med"/>
-                      <a:tailEnd type="none" w="med" len="med"/>
-                    </a:lnB>
-                    <a:solidFill>
-                      <a:srgbClr val="F7F7F7"/>
-                    </a:solidFill>
-                  </a:tcPr>
-                </a:tc>
-                <a:tc>
-                  <a:txBody>
-                    <a:bodyPr/>
-                    <a:lstStyle/>
-                    <a:p>
-                      <a:pPr indent="0" marL="0">
-                        <a:buNone/>
-                      </a:pPr>
-                      <a:r>
-                        <a:rPr lang="en-US" sz="1700" dirty="0">
-                          <a:solidFill>
-                            <a:srgbClr val="27303A"/>
-                          </a:solidFill>
-                        </a:rPr>
-                        <a:t>VM in eigenem privatem Netz (10.0.2.x), erreicht das Internet, von aussen unsichtbar</a:t>
-                      </a:r>
-                      <a:endParaRPr lang="en-US" sz="1700" dirty="0"/>
-                    </a:p>
-                  </a:txBody>
-                  <a:tcPr marL="127000" marR="127000" marT="88900" marB="88900" anchor="ctr">
-                    <a:lnL w="9525" cap="flat" cmpd="sng" algn="ctr">
-                      <a:solidFill>
-                        <a:srgbClr val="D5D8F4"/>
-                      </a:solidFill>
-                      <a:prstDash val="solid"/>
-                      <a:round/>
-                      <a:headEnd type="none" w="med" len="med"/>
-                      <a:tailEnd type="none" w="med" len="med"/>
-                    </a:lnL>
-                    <a:lnR w="9525" cap="flat" cmpd="sng" algn="ctr">
-                      <a:solidFill>
-                        <a:srgbClr val="D5D8F4"/>
-                      </a:solidFill>
-                      <a:prstDash val="solid"/>
-                      <a:round/>
-                      <a:headEnd type="none" w="med" len="med"/>
-                      <a:tailEnd type="none" w="med" len="med"/>
-                    </a:lnR>
-                    <a:lnT w="9525" cap="flat" cmpd="sng" algn="ctr">
-                      <a:solidFill>
-                        <a:srgbClr val="D5D8F4"/>
-                      </a:solidFill>
-                      <a:prstDash val="solid"/>
-                      <a:round/>
-                      <a:headEnd type="none" w="med" len="med"/>
-                      <a:tailEnd type="none" w="med" len="med"/>
-                    </a:lnT>
-                    <a:lnB w="9525" cap="flat" cmpd="sng" algn="ctr">
-                      <a:solidFill>
-                        <a:srgbClr val="D5D8F4"/>
-                      </a:solidFill>
-                      <a:prstDash val="solid"/>
-                      <a:round/>
-                      <a:headEnd type="none" w="med" len="med"/>
-                      <a:tailEnd type="none" w="med" len="med"/>
-                    </a:lnB>
-                    <a:solidFill>
-                      <a:srgbClr val="F7F7F7"/>
-                    </a:solidFill>
-                  </a:tcPr>
-                </a:tc>
-                <a:tc>
-                  <a:txBody>
-                    <a:bodyPr/>
-                    <a:lstStyle/>
-                    <a:p>
-                      <a:pPr indent="0" marL="0">
-                        <a:buNone/>
-                      </a:pPr>
-                      <a:r>
-                        <a:rPr lang="en-US" sz="1700" dirty="0">
-                          <a:solidFill>
-                            <a:srgbClr val="27303A"/>
-                          </a:solidFill>
-                        </a:rPr>
-                        <a:t>Standard, sicher in fremden Netzen</a:t>
-                      </a:r>
-                      <a:endParaRPr lang="en-US" sz="1700" dirty="0"/>
-                    </a:p>
-                  </a:txBody>
-                  <a:tcPr marL="127000" marR="127000" marT="88900" marB="88900" anchor="ctr">
-                    <a:lnL w="9525" cap="flat" cmpd="sng" algn="ctr">
-                      <a:solidFill>
-                        <a:srgbClr val="D5D8F4"/>
-                      </a:solidFill>
-                      <a:prstDash val="solid"/>
-                      <a:round/>
-                      <a:headEnd type="none" w="med" len="med"/>
-                      <a:tailEnd type="none" w="med" len="med"/>
-                    </a:lnL>
-                    <a:lnR w="9525" cap="flat" cmpd="sng" algn="ctr">
-                      <a:solidFill>
-                        <a:srgbClr val="D5D8F4"/>
-                      </a:solidFill>
-                      <a:prstDash val="solid"/>
-                      <a:round/>
-                      <a:headEnd type="none" w="med" len="med"/>
-                      <a:tailEnd type="none" w="med" len="med"/>
-                    </a:lnR>
-                    <a:lnT w="9525" cap="flat" cmpd="sng" algn="ctr">
-                      <a:solidFill>
-                        <a:srgbClr val="D5D8F4"/>
-                      </a:solidFill>
-                      <a:prstDash val="solid"/>
-                      <a:round/>
-                      <a:headEnd type="none" w="med" len="med"/>
-                      <a:tailEnd type="none" w="med" len="med"/>
-                    </a:lnT>
-                    <a:lnB w="9525" cap="flat" cmpd="sng" algn="ctr">
-                      <a:solidFill>
-                        <a:srgbClr val="D5D8F4"/>
-                      </a:solidFill>
-                      <a:prstDash val="solid"/>
-                      <a:round/>
-                      <a:headEnd type="none" w="med" len="med"/>
-                      <a:tailEnd type="none" w="med" len="med"/>
-                    </a:lnB>
-                    <a:solidFill>
-                      <a:srgbClr val="F7F7F7"/>
-                    </a:solidFill>
-                  </a:tcPr>
-                </a:tc>
-              </a:tr>
-              <a:tr h="0">
-                <a:tc>
-                  <a:txBody>
-                    <a:bodyPr/>
-                    <a:lstStyle/>
-                    <a:p>
-                      <a:pPr indent="0" marL="0">
-                        <a:buNone/>
-                      </a:pPr>
-                      <a:r>
-                        <a:rPr lang="en-US" sz="1700" dirty="0">
-                          <a:solidFill>
-                            <a:srgbClr val="27303A"/>
-                          </a:solidFill>
-                        </a:rPr>
-                        <a:t>NAT + Portweiterleitung</a:t>
-                      </a:r>
-                      <a:endParaRPr lang="en-US" sz="1700" dirty="0"/>
-                    </a:p>
-                  </a:txBody>
-                  <a:tcPr marL="127000" marR="127000" marT="88900" marB="88900" anchor="ctr">
-                    <a:lnL w="9525" cap="flat" cmpd="sng" algn="ctr">
-                      <a:solidFill>
-                        <a:srgbClr val="D5D8F4"/>
-                      </a:solidFill>
-                      <a:prstDash val="solid"/>
-                      <a:round/>
-                      <a:headEnd type="none" w="med" len="med"/>
-                      <a:tailEnd type="none" w="med" len="med"/>
-                    </a:lnL>
-                    <a:lnR w="9525" cap="flat" cmpd="sng" algn="ctr">
-                      <a:solidFill>
-                        <a:srgbClr val="D5D8F4"/>
-                      </a:solidFill>
-                      <a:prstDash val="solid"/>
-                      <a:round/>
-                      <a:headEnd type="none" w="med" len="med"/>
-                      <a:tailEnd type="none" w="med" len="med"/>
-                    </a:lnR>
-                    <a:lnT w="9525" cap="flat" cmpd="sng" algn="ctr">
-                      <a:solidFill>
-                        <a:srgbClr val="D5D8F4"/>
-                      </a:solidFill>
-                      <a:prstDash val="solid"/>
-                      <a:round/>
-                      <a:headEnd type="none" w="med" len="med"/>
-                      <a:tailEnd type="none" w="med" len="med"/>
-                    </a:lnT>
-                    <a:lnB w="9525" cap="flat" cmpd="sng" algn="ctr">
-                      <a:solidFill>
-                        <a:srgbClr val="D5D8F4"/>
-                      </a:solidFill>
-                      <a:prstDash val="solid"/>
-                      <a:round/>
-                      <a:headEnd type="none" w="med" len="med"/>
-                      <a:tailEnd type="none" w="med" len="med"/>
-                    </a:lnB>
-                    <a:solidFill>
-                      <a:srgbClr val="FFFFFF"/>
-                    </a:solidFill>
-                  </a:tcPr>
-                </a:tc>
-                <a:tc>
-                  <a:txBody>
-                    <a:bodyPr/>
-                    <a:lstStyle/>
-                    <a:p>
-                      <a:pPr indent="0" marL="0">
-                        <a:buNone/>
-                      </a:pPr>
-                      <a:r>
-                        <a:rPr lang="en-US" sz="1700" dirty="0">
-                          <a:solidFill>
-                            <a:srgbClr val="27303A"/>
-                          </a:solidFill>
-                        </a:rPr>
-                        <a:t>Einzelne Ports gezielt weiterleiten, z. B. 127.0.0.1:2222 → VM:22</a:t>
-                      </a:r>
-                      <a:endParaRPr lang="en-US" sz="1700" dirty="0"/>
-                    </a:p>
-                  </a:txBody>
-                  <a:tcPr marL="127000" marR="127000" marT="88900" marB="88900" anchor="ctr">
-                    <a:lnL w="9525" cap="flat" cmpd="sng" algn="ctr">
-                      <a:solidFill>
-                        <a:srgbClr val="D5D8F4"/>
-                      </a:solidFill>
-                      <a:prstDash val="solid"/>
-                      <a:round/>
-                      <a:headEnd type="none" w="med" len="med"/>
-                      <a:tailEnd type="none" w="med" len="med"/>
-                    </a:lnL>
-                    <a:lnR w="9525" cap="flat" cmpd="sng" algn="ctr">
-                      <a:solidFill>
-                        <a:srgbClr val="D5D8F4"/>
-                      </a:solidFill>
-                      <a:prstDash val="solid"/>
-                      <a:round/>
-                      <a:headEnd type="none" w="med" len="med"/>
-                      <a:tailEnd type="none" w="med" len="med"/>
-                    </a:lnR>
-                    <a:lnT w="9525" cap="flat" cmpd="sng" algn="ctr">
-                      <a:solidFill>
-                        <a:srgbClr val="D5D8F4"/>
-                      </a:solidFill>
-                      <a:prstDash val="solid"/>
-                      <a:round/>
-                      <a:headEnd type="none" w="med" len="med"/>
-                      <a:tailEnd type="none" w="med" len="med"/>
-                    </a:lnT>
-                    <a:lnB w="9525" cap="flat" cmpd="sng" algn="ctr">
-                      <a:solidFill>
-                        <a:srgbClr val="D5D8F4"/>
-                      </a:solidFill>
-                      <a:prstDash val="solid"/>
-                      <a:round/>
-                      <a:headEnd type="none" w="med" len="med"/>
-                      <a:tailEnd type="none" w="med" len="med"/>
-                    </a:lnB>
-                    <a:solidFill>
-                      <a:srgbClr val="FFFFFF"/>
-                    </a:solidFill>
-                  </a:tcPr>
-                </a:tc>
-                <a:tc>
-                  <a:txBody>
-                    <a:bodyPr/>
-                    <a:lstStyle/>
-                    <a:p>
-                      <a:pPr indent="0" marL="0">
-                        <a:buNone/>
-                      </a:pPr>
-                      <a:r>
-                        <a:rPr lang="en-US" sz="1700" dirty="0">
-                          <a:solidFill>
-                            <a:srgbClr val="27303A"/>
-                          </a:solidFill>
-                        </a:rPr>
-                        <a:t>SSH vom eigenen Laptop</a:t>
-                      </a:r>
-                      <a:endParaRPr lang="en-US" sz="1700" dirty="0"/>
-                    </a:p>
-                  </a:txBody>
-                  <a:tcPr marL="127000" marR="127000" marT="88900" marB="88900" anchor="ctr">
-                    <a:lnL w="9525" cap="flat" cmpd="sng" algn="ctr">
-                      <a:solidFill>
-                        <a:srgbClr val="D5D8F4"/>
-                      </a:solidFill>
-                      <a:prstDash val="solid"/>
-                      <a:round/>
-                      <a:headEnd type="none" w="med" len="med"/>
-                      <a:tailEnd type="none" w="med" len="med"/>
-                    </a:lnL>
-                    <a:lnR w="9525" cap="flat" cmpd="sng" algn="ctr">
-                      <a:solidFill>
-                        <a:srgbClr val="D5D8F4"/>
-                      </a:solidFill>
-                      <a:prstDash val="solid"/>
-                      <a:round/>
-                      <a:headEnd type="none" w="med" len="med"/>
-                      <a:tailEnd type="none" w="med" len="med"/>
-                    </a:lnR>
-                    <a:lnT w="9525" cap="flat" cmpd="sng" algn="ctr">
-                      <a:solidFill>
-                        <a:srgbClr val="D5D8F4"/>
-                      </a:solidFill>
-                      <a:prstDash val="solid"/>
-                      <a:round/>
-                      <a:headEnd type="none" w="med" len="med"/>
-                      <a:tailEnd type="none" w="med" len="med"/>
-                    </a:lnT>
-                    <a:lnB w="9525" cap="flat" cmpd="sng" algn="ctr">
-                      <a:solidFill>
-                        <a:srgbClr val="D5D8F4"/>
-                      </a:solidFill>
-                      <a:prstDash val="solid"/>
-                      <a:round/>
-                      <a:headEnd type="none" w="med" len="med"/>
-                      <a:tailEnd type="none" w="med" len="med"/>
-                    </a:lnB>
-                    <a:solidFill>
-                      <a:srgbClr val="FFFFFF"/>
-                    </a:solidFill>
-                  </a:tcPr>
-                </a:tc>
-              </a:tr>
-              <a:tr h="0">
-                <a:tc>
-                  <a:txBody>
-                    <a:bodyPr/>
-                    <a:lstStyle/>
-                    <a:p>
-                      <a:pPr indent="0" marL="0">
-                        <a:buNone/>
-                      </a:pPr>
-                      <a:r>
-                        <a:rPr lang="en-US" sz="1700" dirty="0">
-                          <a:solidFill>
-                            <a:srgbClr val="27303A"/>
-                          </a:solidFill>
-                        </a:rPr>
-                        <a:t>Netzwerkbrücke</a:t>
-                      </a:r>
-                      <a:endParaRPr lang="en-US" sz="1700" dirty="0"/>
-                    </a:p>
-                  </a:txBody>
-                  <a:tcPr marL="127000" marR="127000" marT="88900" marB="88900" anchor="ctr">
-                    <a:lnL w="9525" cap="flat" cmpd="sng" algn="ctr">
-                      <a:solidFill>
-                        <a:srgbClr val="D5D8F4"/>
-                      </a:solidFill>
-                      <a:prstDash val="solid"/>
-                      <a:round/>
-                      <a:headEnd type="none" w="med" len="med"/>
-                      <a:tailEnd type="none" w="med" len="med"/>
-                    </a:lnL>
-                    <a:lnR w="9525" cap="flat" cmpd="sng" algn="ctr">
-                      <a:solidFill>
-                        <a:srgbClr val="D5D8F4"/>
-                      </a:solidFill>
-                      <a:prstDash val="solid"/>
-                      <a:round/>
-                      <a:headEnd type="none" w="med" len="med"/>
-                      <a:tailEnd type="none" w="med" len="med"/>
-                    </a:lnR>
-                    <a:lnT w="9525" cap="flat" cmpd="sng" algn="ctr">
-                      <a:solidFill>
-                        <a:srgbClr val="D5D8F4"/>
-                      </a:solidFill>
-                      <a:prstDash val="solid"/>
-                      <a:round/>
-                      <a:headEnd type="none" w="med" len="med"/>
-                      <a:tailEnd type="none" w="med" len="med"/>
-                    </a:lnT>
-                    <a:lnB w="9525" cap="flat" cmpd="sng" algn="ctr">
-                      <a:solidFill>
-                        <a:srgbClr val="D5D8F4"/>
-                      </a:solidFill>
-                      <a:prstDash val="solid"/>
-                      <a:round/>
-                      <a:headEnd type="none" w="med" len="med"/>
-                      <a:tailEnd type="none" w="med" len="med"/>
-                    </a:lnB>
-                    <a:solidFill>
-                      <a:srgbClr val="F7F7F7"/>
-                    </a:solidFill>
-                  </a:tcPr>
-                </a:tc>
-                <a:tc>
-                  <a:txBody>
-                    <a:bodyPr/>
-                    <a:lstStyle/>
-                    <a:p>
-                      <a:pPr indent="0" marL="0">
-                        <a:buNone/>
-                      </a:pPr>
-                      <a:r>
-                        <a:rPr lang="en-US" sz="1700" dirty="0">
-                          <a:solidFill>
-                            <a:srgbClr val="27303A"/>
-                          </a:solidFill>
-                        </a:rPr>
-                        <a:t>VM hängt direkt im WLAN und bekommt eine eigene IP</a:t>
-                      </a:r>
-                      <a:endParaRPr lang="en-US" sz="1700" dirty="0"/>
-                    </a:p>
-                  </a:txBody>
-                  <a:tcPr marL="127000" marR="127000" marT="88900" marB="88900" anchor="ctr">
-                    <a:lnL w="9525" cap="flat" cmpd="sng" algn="ctr">
-                      <a:solidFill>
-                        <a:srgbClr val="D5D8F4"/>
-                      </a:solidFill>
-                      <a:prstDash val="solid"/>
-                      <a:round/>
-                      <a:headEnd type="none" w="med" len="med"/>
-                      <a:tailEnd type="none" w="med" len="med"/>
-                    </a:lnL>
-                    <a:lnR w="9525" cap="flat" cmpd="sng" algn="ctr">
-                      <a:solidFill>
-                        <a:srgbClr val="D5D8F4"/>
-                      </a:solidFill>
-                      <a:prstDash val="solid"/>
-                      <a:round/>
-                      <a:headEnd type="none" w="med" len="med"/>
-                      <a:tailEnd type="none" w="med" len="med"/>
-                    </a:lnR>
-                    <a:lnT w="9525" cap="flat" cmpd="sng" algn="ctr">
-                      <a:solidFill>
-                        <a:srgbClr val="D5D8F4"/>
-                      </a:solidFill>
-                      <a:prstDash val="solid"/>
-                      <a:round/>
-                      <a:headEnd type="none" w="med" len="med"/>
-                      <a:tailEnd type="none" w="med" len="med"/>
-                    </a:lnT>
-                    <a:lnB w="9525" cap="flat" cmpd="sng" algn="ctr">
-                      <a:solidFill>
-                        <a:srgbClr val="D5D8F4"/>
-                      </a:solidFill>
-                      <a:prstDash val="solid"/>
-                      <a:round/>
-                      <a:headEnd type="none" w="med" len="med"/>
-                      <a:tailEnd type="none" w="med" len="med"/>
-                    </a:lnB>
-                    <a:solidFill>
-                      <a:srgbClr val="F7F7F7"/>
-                    </a:solidFill>
-                  </a:tcPr>
-                </a:tc>
-                <a:tc>
-                  <a:txBody>
-                    <a:bodyPr/>
-                    <a:lstStyle/>
-                    <a:p>
-                      <a:pPr indent="0" marL="0">
-                        <a:buNone/>
-                      </a:pPr>
-                      <a:r>
-                        <a:rPr lang="en-US" sz="1700" dirty="0">
-                          <a:solidFill>
-                            <a:srgbClr val="27303A"/>
-                          </a:solidFill>
-                        </a:rPr>
-                        <a:t>andere Geräte sollen die VM erreichen</a:t>
-                      </a:r>
-                      <a:endParaRPr lang="en-US" sz="1700" dirty="0"/>
-                    </a:p>
-                  </a:txBody>
-                  <a:tcPr marL="127000" marR="127000" marT="88900" marB="88900" anchor="ctr">
-                    <a:lnL w="9525" cap="flat" cmpd="sng" algn="ctr">
-                      <a:solidFill>
-                        <a:srgbClr val="D5D8F4"/>
-                      </a:solidFill>
-                      <a:prstDash val="solid"/>
-                      <a:round/>
-                      <a:headEnd type="none" w="med" len="med"/>
-                      <a:tailEnd type="none" w="med" len="med"/>
-                    </a:lnL>
-                    <a:lnR w="9525" cap="flat" cmpd="sng" algn="ctr">
-                      <a:solidFill>
-                        <a:srgbClr val="D5D8F4"/>
-                      </a:solidFill>
-                      <a:prstDash val="solid"/>
-                      <a:round/>
-                      <a:headEnd type="none" w="med" len="med"/>
-                      <a:tailEnd type="none" w="med" len="med"/>
-                    </a:lnR>
-                    <a:lnT w="9525" cap="flat" cmpd="sng" algn="ctr">
-                      <a:solidFill>
-                        <a:srgbClr val="D5D8F4"/>
-                      </a:solidFill>
-                      <a:prstDash val="solid"/>
-                      <a:round/>
-                      <a:headEnd type="none" w="med" len="med"/>
-                      <a:tailEnd type="none" w="med" len="med"/>
-                    </a:lnT>
-                    <a:lnB w="9525" cap="flat" cmpd="sng" algn="ctr">
-                      <a:solidFill>
-                        <a:srgbClr val="D5D8F4"/>
-                      </a:solidFill>
-                      <a:prstDash val="solid"/>
-                      <a:round/>
-                      <a:headEnd type="none" w="med" len="med"/>
-                      <a:tailEnd type="none" w="med" len="med"/>
-                    </a:lnB>
-                    <a:solidFill>
-                      <a:srgbClr val="F7F7F7"/>
-                    </a:solidFill>
-                  </a:tcPr>
-                </a:tc>
-              </a:tr>
-              <a:tr h="0">
-                <a:tc>
-                  <a:txBody>
-                    <a:bodyPr/>
-                    <a:lstStyle/>
-                    <a:p>
-                      <a:pPr indent="0" marL="0">
-                        <a:buNone/>
-                      </a:pPr>
-                      <a:r>
-                        <a:rPr lang="en-US" sz="1700" dirty="0">
-                          <a:solidFill>
-                            <a:srgbClr val="27303A"/>
-                          </a:solidFill>
-                        </a:rPr>
-                        <a:t>Host-only</a:t>
-                      </a:r>
-                      <a:endParaRPr lang="en-US" sz="1700" dirty="0"/>
-                    </a:p>
-                  </a:txBody>
-                  <a:tcPr marL="127000" marR="127000" marT="88900" marB="88900" anchor="ctr">
-                    <a:lnL w="9525" cap="flat" cmpd="sng" algn="ctr">
-                      <a:solidFill>
-                        <a:srgbClr val="D5D8F4"/>
-                      </a:solidFill>
-                      <a:prstDash val="solid"/>
-                      <a:round/>
-                      <a:headEnd type="none" w="med" len="med"/>
-                      <a:tailEnd type="none" w="med" len="med"/>
-                    </a:lnL>
-                    <a:lnR w="9525" cap="flat" cmpd="sng" algn="ctr">
-                      <a:solidFill>
-                        <a:srgbClr val="D5D8F4"/>
-                      </a:solidFill>
-                      <a:prstDash val="solid"/>
-                      <a:round/>
-                      <a:headEnd type="none" w="med" len="med"/>
-                      <a:tailEnd type="none" w="med" len="med"/>
-                    </a:lnR>
-                    <a:lnT w="9525" cap="flat" cmpd="sng" algn="ctr">
-                      <a:solidFill>
-                        <a:srgbClr val="D5D8F4"/>
-                      </a:solidFill>
-                      <a:prstDash val="solid"/>
-                      <a:round/>
-                      <a:headEnd type="none" w="med" len="med"/>
-                      <a:tailEnd type="none" w="med" len="med"/>
-                    </a:lnT>
-                    <a:lnB w="9525" cap="flat" cmpd="sng" algn="ctr">
-                      <a:solidFill>
-                        <a:srgbClr val="D5D8F4"/>
-                      </a:solidFill>
-                      <a:prstDash val="solid"/>
-                      <a:round/>
-                      <a:headEnd type="none" w="med" len="med"/>
-                      <a:tailEnd type="none" w="med" len="med"/>
-                    </a:lnB>
-                    <a:solidFill>
-                      <a:srgbClr val="FFFFFF"/>
-                    </a:solidFill>
-                  </a:tcPr>
-                </a:tc>
-                <a:tc>
-                  <a:txBody>
-                    <a:bodyPr/>
-                    <a:lstStyle/>
-                    <a:p>
-                      <a:pPr indent="0" marL="0">
-                        <a:buNone/>
-                      </a:pPr>
-                      <a:r>
-                        <a:rPr lang="en-US" sz="1700" dirty="0">
-                          <a:solidFill>
-                            <a:srgbClr val="27303A"/>
-                          </a:solidFill>
-                        </a:rPr>
-                        <a:t>Nur Laptop und VMs sehen sich, kein Internet</a:t>
-                      </a:r>
-                      <a:endParaRPr lang="en-US" sz="1700" dirty="0"/>
-                    </a:p>
-                  </a:txBody>
-                  <a:tcPr marL="127000" marR="127000" marT="88900" marB="88900" anchor="ctr">
-                    <a:lnL w="9525" cap="flat" cmpd="sng" algn="ctr">
-                      <a:solidFill>
-                        <a:srgbClr val="D5D8F4"/>
-                      </a:solidFill>
-                      <a:prstDash val="solid"/>
-                      <a:round/>
-                      <a:headEnd type="none" w="med" len="med"/>
-                      <a:tailEnd type="none" w="med" len="med"/>
-                    </a:lnL>
-                    <a:lnR w="9525" cap="flat" cmpd="sng" algn="ctr">
-                      <a:solidFill>
-                        <a:srgbClr val="D5D8F4"/>
-                      </a:solidFill>
-                      <a:prstDash val="solid"/>
-                      <a:round/>
-                      <a:headEnd type="none" w="med" len="med"/>
-                      <a:tailEnd type="none" w="med" len="med"/>
-                    </a:lnR>
-                    <a:lnT w="9525" cap="flat" cmpd="sng" algn="ctr">
-                      <a:solidFill>
-                        <a:srgbClr val="D5D8F4"/>
-                      </a:solidFill>
-                      <a:prstDash val="solid"/>
-                      <a:round/>
-                      <a:headEnd type="none" w="med" len="med"/>
-                      <a:tailEnd type="none" w="med" len="med"/>
-                    </a:lnT>
-                    <a:lnB w="9525" cap="flat" cmpd="sng" algn="ctr">
-                      <a:solidFill>
-                        <a:srgbClr val="D5D8F4"/>
-                      </a:solidFill>
-                      <a:prstDash val="solid"/>
-                      <a:round/>
-                      <a:headEnd type="none" w="med" len="med"/>
-                      <a:tailEnd type="none" w="med" len="med"/>
-                    </a:lnB>
-                    <a:solidFill>
-                      <a:srgbClr val="FFFFFF"/>
-                    </a:solidFill>
-                  </a:tcPr>
-                </a:tc>
-                <a:tc>
-                  <a:txBody>
-                    <a:bodyPr/>
-                    <a:lstStyle/>
-                    <a:p>
-                      <a:pPr indent="0" marL="0">
-                        <a:buNone/>
-                      </a:pPr>
-                      <a:r>
-                        <a:rPr lang="en-US" sz="1700" dirty="0">
-                          <a:solidFill>
-                            <a:srgbClr val="27303A"/>
-                          </a:solidFill>
-                        </a:rPr>
-                        <a:t>isolierte Testnetze</a:t>
-                      </a:r>
-                      <a:endParaRPr lang="en-US" sz="1700" dirty="0"/>
-                    </a:p>
-                  </a:txBody>
-                  <a:tcPr marL="127000" marR="127000" marT="88900" marB="88900" anchor="ctr">
-                    <a:lnL w="9525" cap="flat" cmpd="sng" algn="ctr">
-                      <a:solidFill>
-                        <a:srgbClr val="D5D8F4"/>
-                      </a:solidFill>
-                      <a:prstDash val="solid"/>
-                      <a:round/>
-                      <a:headEnd type="none" w="med" len="med"/>
-                      <a:tailEnd type="none" w="med" len="med"/>
-                    </a:lnL>
-                    <a:lnR w="9525" cap="flat" cmpd="sng" algn="ctr">
-                      <a:solidFill>
-                        <a:srgbClr val="D5D8F4"/>
-                      </a:solidFill>
-                      <a:prstDash val="solid"/>
-                      <a:round/>
-                      <a:headEnd type="none" w="med" len="med"/>
-                      <a:tailEnd type="none" w="med" len="med"/>
-                    </a:lnR>
-                    <a:lnT w="9525" cap="flat" cmpd="sng" algn="ctr">
-                      <a:solidFill>
-                        <a:srgbClr val="D5D8F4"/>
-                      </a:solidFill>
-                      <a:prstDash val="solid"/>
-                      <a:round/>
-                      <a:headEnd type="none" w="med" len="med"/>
-                      <a:tailEnd type="none" w="med" len="med"/>
-                    </a:lnT>
-                    <a:lnB w="9525" cap="flat" cmpd="sng" algn="ctr">
-                      <a:solidFill>
-                        <a:srgbClr val="D5D8F4"/>
-                      </a:solidFill>
-                      <a:prstDash val="solid"/>
-                      <a:round/>
-                      <a:headEnd type="none" w="med" len="med"/>
-                      <a:tailEnd type="none" w="med" len="med"/>
-                    </a:lnB>
-                    <a:solidFill>
-                      <a:srgbClr val="FFFFFF"/>
-                    </a:solidFill>
-                  </a:tcPr>
-                </a:tc>
-              </a:tr>
-            </a:tbl>
-          </a:graphicData>
-        </a:graphic>
-      </p:graphicFrame>
-      <p:sp>
-        <p:nvSpPr>
-          <p:cNvPr id="4" name="Text 1"/>
+      <p:sp>
+        <p:nvSpPr>
+          <p:cNvPr id="3" name="code-box"/>
+          <p:cNvSpPr/>
+          <p:nvPr/>
+        </p:nvSpPr>
+        <p:spPr>
+          <a:xfrm>
+            <a:off x="548640" y="1325880"/>
+            <a:ext cx="6583680" cy="4709160"/>
+          </a:xfrm>
+          <a:prstGeom prst="roundRect">
+            <a:avLst>
+              <a:gd name="adj" fmla="val 1942"/>
+            </a:avLst>
+          </a:prstGeom>
+          <a:solidFill>
+            <a:srgbClr val="27303A"/>
+          </a:solidFill>
+          <a:ln w="12700">
+            <a:solidFill>
+              <a:srgbClr val="27303A"/>
+            </a:solidFill>
+            <a:prstDash val="solid"/>
+          </a:ln>
+        </p:spPr>
+      </p:sp>
+      <p:sp>
+        <p:nvSpPr>
+          <p:cNvPr id="4" name="Text 2"/>
           <p:cNvSpPr txBox="1"/>
           <p:nvPr/>
         </p:nvSpPr>
         <p:spPr>
           <a:xfrm>
-            <a:off x="548640" y="5623560"/>
-            <a:ext cx="11094415" cy="457200"/>
+            <a:off x="822960" y="1554480"/>
+            <a:ext cx="6035040" cy="4251960"/>
           </a:xfrm>
           <a:prstGeom prst="rect">
             <a:avLst/>
@@ -8651,21 +7506,309 @@
           <a:ln/>
         </p:spPr>
         <p:txBody>
-          <a:bodyPr wrap="square" lIns="0" tIns="0" rIns="0" bIns="0" rtlCol="0" anchor="ctr"/>
+          <a:bodyPr wrap="square" lIns="0" tIns="0" rIns="0" bIns="0" rtlCol="0" anchor="t"/>
           <a:lstStyle/>
           <a:p>
             <a:pPr indent="0" marL="0">
               <a:buNone/>
             </a:pPr>
             <a:r>
-              <a:rPr lang="en-US" sz="1500" b="1" dirty="0">
+              <a:rPr lang="en-US" sz="1800" dirty="0">
+                <a:solidFill>
+                  <a:srgbClr val="F7F7F7"/>
+                </a:solidFill>
+                <a:latin typeface="Courier New" pitchFamily="34" charset="0"/>
+                <a:ea typeface="Courier New" pitchFamily="34" charset="-122"/>
+                <a:cs typeface="Courier New" pitchFamily="34" charset="-120"/>
+              </a:rPr>
+              <a:t>multipass launch --name vm1</a:t>
+            </a:r>
+            <a:endParaRPr lang="en-US" sz="1800" dirty="0"/>
+          </a:p>
+          <a:p>
+            <a:pPr indent="0" marL="0">
+              <a:buNone/>
+            </a:pPr>
+            <a:r>
+              <a:rPr lang="en-US" sz="1800" dirty="0">
+                <a:solidFill>
+                  <a:srgbClr val="F7F7F7"/>
+                </a:solidFill>
+                <a:latin typeface="Courier New" pitchFamily="34" charset="0"/>
+                <a:ea typeface="Courier New" pitchFamily="34" charset="-122"/>
+                <a:cs typeface="Courier New" pitchFamily="34" charset="-120"/>
+              </a:rPr>
+              <a:t>multipass list</a:t>
+            </a:r>
+            <a:endParaRPr lang="en-US" sz="1800" dirty="0"/>
+          </a:p>
+          <a:p>
+            <a:pPr indent="0" marL="0">
+              <a:buNone/>
+            </a:pPr>
+            <a:r>
+              <a:rPr lang="en-US" sz="1800" dirty="0">
+                <a:solidFill>
+                  <a:srgbClr val="F7F7F7"/>
+                </a:solidFill>
+                <a:latin typeface="Courier New" pitchFamily="34" charset="0"/>
+                <a:ea typeface="Courier New" pitchFamily="34" charset="-122"/>
+                <a:cs typeface="Courier New" pitchFamily="34" charset="-120"/>
+              </a:rPr>
+              <a:t>multipass shell vm1</a:t>
+            </a:r>
+            <a:endParaRPr lang="en-US" sz="1800" dirty="0"/>
+          </a:p>
+          <a:p>
+            <a:pPr indent="0" marL="0">
+              <a:buNone/>
+            </a:pPr>
+            <a:r>
+              <a:rPr lang="en-US" sz="1800" dirty="0">
+                <a:solidFill>
+                  <a:srgbClr val="F7F7F7"/>
+                </a:solidFill>
+                <a:latin typeface="Courier New" pitchFamily="34" charset="0"/>
+                <a:ea typeface="Courier New" pitchFamily="34" charset="-122"/>
+                <a:cs typeface="Courier New" pitchFamily="34" charset="-120"/>
+              </a:rPr>
+              <a:t>multipass exec vm1 -- free -h</a:t>
+            </a:r>
+            <a:endParaRPr lang="en-US" sz="1800" dirty="0"/>
+          </a:p>
+          <a:p>
+            <a:pPr indent="0" marL="0">
+              <a:buNone/>
+            </a:pPr>
+            <a:r>
+              <a:rPr lang="en-US" sz="1800" dirty="0">
+                <a:solidFill>
+                  <a:srgbClr val="F7F7F7"/>
+                </a:solidFill>
+                <a:latin typeface="Courier New" pitchFamily="34" charset="0"/>
+                <a:ea typeface="Courier New" pitchFamily="34" charset="-122"/>
+                <a:cs typeface="Courier New" pitchFamily="34" charset="-120"/>
+              </a:rPr>
+              <a:t>multipass stop vm1</a:t>
+            </a:r>
+            <a:endParaRPr lang="en-US" sz="1800" dirty="0"/>
+          </a:p>
+          <a:p>
+            <a:pPr indent="0" marL="0">
+              <a:buNone/>
+            </a:pPr>
+            <a:r>
+              <a:rPr lang="en-US" sz="1800" dirty="0">
+                <a:solidFill>
+                  <a:srgbClr val="F7F7F7"/>
+                </a:solidFill>
+                <a:latin typeface="Courier New" pitchFamily="34" charset="0"/>
+                <a:ea typeface="Courier New" pitchFamily="34" charset="-122"/>
+                <a:cs typeface="Courier New" pitchFamily="34" charset="-120"/>
+              </a:rPr>
+              <a:t>multipass delete --purge vm1</a:t>
+            </a:r>
+            <a:endParaRPr lang="en-US" sz="1800" dirty="0"/>
+          </a:p>
+        </p:txBody>
+      </p:sp>
+      <p:sp>
+        <p:nvSpPr>
+          <p:cNvPr id="5" name="Text 3"/>
+          <p:cNvSpPr txBox="1"/>
+          <p:nvPr/>
+        </p:nvSpPr>
+        <p:spPr>
+          <a:xfrm>
+            <a:off x="7498080" y="1325880"/>
+            <a:ext cx="4144975" cy="1143000"/>
+          </a:xfrm>
+          <a:prstGeom prst="rect">
+            <a:avLst/>
+          </a:prstGeom>
+          <a:noFill/>
+          <a:ln/>
+        </p:spPr>
+        <p:txBody>
+          <a:bodyPr wrap="square" lIns="0" tIns="0" rIns="0" bIns="0" rtlCol="0" anchor="t"/>
+          <a:lstStyle/>
+          <a:p>
+            <a:pPr indent="0" marL="0">
+              <a:buNone/>
+            </a:pPr>
+            <a:r>
+              <a:rPr lang="en-US" sz="1700" b="1" dirty="0">
                 <a:solidFill>
                   <a:srgbClr val="006FAD"/>
                 </a:solidFill>
               </a:rPr>
-              <a:t>Die Portweiterleitung ist dieselbe Idee wie eine NSG-Regel in Azure (Tag 4).</a:t>
-            </a:r>
-            <a:endParaRPr lang="en-US" sz="1500" dirty="0"/>
+              <a:t>launch</a:t>
+            </a:r>
+            <a:endParaRPr lang="en-US" sz="1700" dirty="0"/>
+          </a:p>
+          <a:p>
+            <a:pPr indent="0" marL="0">
+              <a:buNone/>
+            </a:pPr>
+            <a:r>
+              <a:rPr lang="en-US" sz="1700" dirty="0">
+                <a:solidFill>
+                  <a:srgbClr val="27303A"/>
+                </a:solidFill>
+              </a:rPr>
+              <a:t>VM erstellen und starten</a:t>
+            </a:r>
+            <a:endParaRPr lang="en-US" sz="1700" dirty="0"/>
+          </a:p>
+        </p:txBody>
+      </p:sp>
+      <p:sp>
+        <p:nvSpPr>
+          <p:cNvPr id="6" name="Text 4"/>
+          <p:cNvSpPr txBox="1"/>
+          <p:nvPr/>
+        </p:nvSpPr>
+        <p:spPr>
+          <a:xfrm>
+            <a:off x="7498080" y="2468880"/>
+            <a:ext cx="4144975" cy="1143000"/>
+          </a:xfrm>
+          <a:prstGeom prst="rect">
+            <a:avLst/>
+          </a:prstGeom>
+          <a:noFill/>
+          <a:ln/>
+        </p:spPr>
+        <p:txBody>
+          <a:bodyPr wrap="square" lIns="0" tIns="0" rIns="0" bIns="0" rtlCol="0" anchor="t"/>
+          <a:lstStyle/>
+          <a:p>
+            <a:pPr indent="0" marL="0">
+              <a:buNone/>
+            </a:pPr>
+            <a:r>
+              <a:rPr lang="en-US" sz="1700" b="1" dirty="0">
+                <a:solidFill>
+                  <a:srgbClr val="006FAD"/>
+                </a:solidFill>
+              </a:rPr>
+              <a:t>list</a:t>
+            </a:r>
+            <a:endParaRPr lang="en-US" sz="1700" dirty="0"/>
+          </a:p>
+          <a:p>
+            <a:pPr indent="0" marL="0">
+              <a:buNone/>
+            </a:pPr>
+            <a:r>
+              <a:rPr lang="en-US" sz="1700" dirty="0">
+                <a:solidFill>
+                  <a:srgbClr val="27303A"/>
+                </a:solidFill>
+              </a:rPr>
+              <a:t>alle VMs anzeigen</a:t>
+            </a:r>
+            <a:endParaRPr lang="en-US" sz="1700" dirty="0"/>
+          </a:p>
+        </p:txBody>
+      </p:sp>
+      <p:sp>
+        <p:nvSpPr>
+          <p:cNvPr id="7" name="Text 5"/>
+          <p:cNvSpPr txBox="1"/>
+          <p:nvPr/>
+        </p:nvSpPr>
+        <p:spPr>
+          <a:xfrm>
+            <a:off x="7498080" y="3611880"/>
+            <a:ext cx="4144975" cy="1143000"/>
+          </a:xfrm>
+          <a:prstGeom prst="rect">
+            <a:avLst/>
+          </a:prstGeom>
+          <a:noFill/>
+          <a:ln/>
+        </p:spPr>
+        <p:txBody>
+          <a:bodyPr wrap="square" lIns="0" tIns="0" rIns="0" bIns="0" rtlCol="0" anchor="t"/>
+          <a:lstStyle/>
+          <a:p>
+            <a:pPr indent="0" marL="0">
+              <a:buNone/>
+            </a:pPr>
+            <a:r>
+              <a:rPr lang="en-US" sz="1700" b="1" dirty="0">
+                <a:solidFill>
+                  <a:srgbClr val="006FAD"/>
+                </a:solidFill>
+              </a:rPr>
+              <a:t>shell / exec</a:t>
+            </a:r>
+            <a:endParaRPr lang="en-US" sz="1700" dirty="0"/>
+          </a:p>
+          <a:p>
+            <a:pPr indent="0" marL="0">
+              <a:buNone/>
+            </a:pPr>
+            <a:r>
+              <a:rPr lang="en-US" sz="1700" dirty="0">
+                <a:solidFill>
+                  <a:srgbClr val="27303A"/>
+                </a:solidFill>
+              </a:rPr>
+              <a:t>in der VM arbeiten / einen Befehl ausführen</a:t>
+            </a:r>
+            <a:endParaRPr lang="en-US" sz="1700" dirty="0"/>
+          </a:p>
+        </p:txBody>
+      </p:sp>
+      <p:sp>
+        <p:nvSpPr>
+          <p:cNvPr id="8" name="Text 6"/>
+          <p:cNvSpPr txBox="1"/>
+          <p:nvPr/>
+        </p:nvSpPr>
+        <p:spPr>
+          <a:xfrm>
+            <a:off x="7498080" y="4754880"/>
+            <a:ext cx="4144975" cy="1143000"/>
+          </a:xfrm>
+          <a:prstGeom prst="rect">
+            <a:avLst/>
+          </a:prstGeom>
+          <a:noFill/>
+          <a:ln/>
+        </p:spPr>
+        <p:txBody>
+          <a:bodyPr wrap="square" lIns="0" tIns="0" rIns="0" bIns="0" rtlCol="0" anchor="t"/>
+          <a:lstStyle/>
+          <a:p>
+            <a:pPr indent="0" marL="0">
+              <a:buNone/>
+            </a:pPr>
+            <a:r>
+              <a:rPr lang="en-US" sz="1700" b="1" dirty="0">
+                <a:solidFill>
+                  <a:srgbClr val="006FAD"/>
+                </a:solidFill>
+              </a:rPr>
+              <a:t>stop / delete</a:t>
+            </a:r>
+            <a:endParaRPr lang="en-US" sz="1700" dirty="0"/>
+          </a:p>
+          <a:p>
+            <a:pPr indent="0" marL="0">
+              <a:buNone/>
+            </a:pPr>
+            <a:r>
+              <a:rPr lang="en-US" sz="1700" dirty="0">
+                <a:solidFill>
+                  <a:srgbClr val="27303A"/>
+                </a:solidFill>
+              </a:rPr>
+              <a:t>VM stoppen / endgültig löschen</a:t>
+            </a:r>
+            <a:endParaRPr lang="en-US" sz="1700" dirty="0"/>
           </a:p>
         </p:txBody>
       </p:sp>

</xml_diff>

<commit_message>
Update terminology and translations in diagrams and scripts for consistency
- Changed "Managed Disk" to "verwalteter Datenträger" in Speicher_TechnischeModelle.svg
- Updated "Blob Storage" to "Blob-Speicher" in Speicher_TechnischeModelle.svg and Speicher_Zugriffsklassen.svg
- Modified various terms in diagramme.py for clarity, including "Storage Account" to "Speicherkonto"
- Adjusted presentation content in präsentationen-inhalt.js to reflect updated terminology
- Added a new Python script (begriffe.py) to automate the addition of English terms in documentation
</commit_message>
<xml_diff>
--- a/praesentationen/input-01-virtualisierung.pptx
+++ b/praesentationen/input-01-virtualisierung.pptx
@@ -120,7 +120,7 @@
   <p:extLst>
     <p:ext uri="{521415D9-36F7-43E2-AB2F-B90AF26B5E84}">
       <p14:sectionLst xmlns:p14="http://schemas.microsoft.com/office/powerpoint/2010/main">
-        <p14:section name="Virtualisierung" id="{add753b8-0544-1c52-25dd-5d5600fd090d}">
+        <p14:section name="Virtualisierung" id="{94de42ac-cf2a-ca6f-e369-1502605bef21}">
           <p14:sldIdLst>
             <p14:sldId id="256"/>
             <p14:sldId id="257"/>
@@ -131,7 +131,7 @@
             <p14:sldId id="262"/>
           </p14:sldIdLst>
         </p14:section>
-        <p14:section name="Multipass und cloud-init" id="{61530268-62e9-8b90-8bde-2058214fd967}">
+        <p14:section name="Multipass und cloud-init" id="{5ef7897b-70c3-0d60-88da-8c6c0783a563}">
           <p14:sldIdLst>
             <p14:sldId id="263"/>
             <p14:sldId id="264"/>

</xml_diff>

<commit_message>
Update presentation files for Azure training course
</commit_message>
<xml_diff>
--- a/praesentationen/input-01-virtualisierung.pptx
+++ b/praesentationen/input-01-virtualisierung.pptx
@@ -120,7 +120,7 @@
   <p:extLst>
     <p:ext uri="{521415D9-36F7-43E2-AB2F-B90AF26B5E84}">
       <p14:sectionLst xmlns:p14="http://schemas.microsoft.com/office/powerpoint/2010/main">
-        <p14:section name="Virtualisierung" id="{94de42ac-cf2a-ca6f-e369-1502605bef21}">
+        <p14:section name="Virtualisierung" id="{41cd8610-f5f3-633a-acf2-b6c97474ba40}">
           <p14:sldIdLst>
             <p14:sldId id="256"/>
             <p14:sldId id="257"/>
@@ -131,7 +131,7 @@
             <p14:sldId id="262"/>
           </p14:sldIdLst>
         </p14:section>
-        <p14:section name="Multipass und cloud-init" id="{5ef7897b-70c3-0d60-88da-8c6c0783a563}">
+        <p14:section name="Multipass und cloud-init" id="{9fc0fef0-0e9e-ef58-7e7e-87416b717f66}">
           <p14:sldIdLst>
             <p14:sldId id="263"/>
             <p14:sldId id="264"/>
@@ -634,7 +634,7 @@
           <a:p>
             <a:r>
               <a:rPr lang="en-US" dirty="0"/>
-              <a:t>Live-Demo: multipass launch --name auto --cloud-init cloud-init-tag1.yaml. Betonen: läuft nur beim ersten Start. In Azure an Tag 5 genau gleich.</a:t>
+              <a:t>Nach Auftrag 1.4: Zeiten der Klasse abfragen, auf 10 Server hochrechnen. Live-Demo: multipass launch --name auto --cloud-init cloud-init-tag1.yaml. Betonen: läuft nur beim ersten Start. In Azure an Tag 5 genau gleich.</a:t>
             </a:r>
             <a:endParaRPr lang="en-US" dirty="0"/>
           </a:p>
@@ -722,7 +722,7 @@
           <a:p>
             <a:r>
               <a:rPr lang="en-US" dirty="0"/>
-              <a:t>Kurz vor Auftrag 1.5. Live: ssh-keygen -t ed25519.</a:t>
+              <a:t>Kurz vor Auftrag 1.6. Live: ssh-keygen -t ed25519.</a:t>
             </a:r>
             <a:endParaRPr lang="en-US" dirty="0"/>
           </a:p>
@@ -1514,7 +1514,7 @@
           <a:p>
             <a:r>
               <a:rPr lang="en-US" dirty="0"/>
-              <a:t>Container teilen den Kernel, VMs bringen ein ganzes Betriebssystem mit. Container sind optional (⭐ Auftrag 1.6).</a:t>
+              <a:t>Container teilen den Kernel, VMs bringen ein ganzes Betriebssystem mit. Container sind optional (⭐ Auftrag 1.7).</a:t>
             </a:r>
             <a:endParaRPr lang="en-US" dirty="0"/>
           </a:p>
@@ -1768,7 +1768,7 @@
     <p:bg>
       <p:bgPr>
         <a:solidFill>
-          <a:srgbClr val="27303A"/>
+          <a:srgbClr val="FFFFFF"/>
         </a:solidFill>
       </p:bgPr>
     </p:bg>
@@ -1788,7 +1788,7 @@
       </p:grpSpPr>
       <p:pic>
         <p:nvPicPr>
-          <p:cNvPr id="2" name="Image 0" descr="C:\Users\Thanam\AppData\Local\Temp\claude\c--Projekt-Trainings-azure-basics-training\a9e0bf4e-0d08-4082-a38a-5b8886538508\scratchpad\pptx\assets\logo-hell.png">    </p:cNvPr>
+          <p:cNvPr id="2" name="Image 0" descr="C:\Users\Thanam\AppData\Local\Temp\claude\c--Projekt-Trainings-azure-basics-training\a7a6b8eb-22f3-4b42-aecc-5af05d1502b1\scratchpad\folien\assets\logo-dunkel.png">    </p:cNvPr>
           <p:cNvPicPr>
             <a:picLocks noChangeAspect="1"/>
           </p:cNvPicPr>
@@ -1812,7 +1812,7 @@
       </p:pic>
       <p:pic>
         <p:nvPicPr>
-          <p:cNvPr id="3" name="Image 1" descr="C:\Users\Thanam\AppData\Local\Temp\claude\c--Projekt-Trainings-azure-basics-training\a9e0bf4e-0d08-4082-a38a-5b8886538508\scratchpad\pptx\assets\wolke.png">    </p:cNvPr>
+          <p:cNvPr id="3" name="Image 1" descr="C:\Users\Thanam\AppData\Local\Temp\claude\c--Projekt-Trainings-azure-basics-training\a7a6b8eb-22f3-4b42-aecc-5af05d1502b1\scratchpad\folien\assets\wolke.png">    </p:cNvPr>
           <p:cNvPicPr>
             <a:picLocks noChangeAspect="1"/>
           </p:cNvPicPr>
@@ -1860,7 +1860,7 @@
               <a:buNone/>
               <a:defRPr lang="en-US" sz="4400" b="1" dirty="0">
                 <a:solidFill>
-                  <a:srgbClr val="FFFFFF"/>
+                  <a:srgbClr val="27303A"/>
                 </a:solidFill>
               </a:defRPr>
             </a:lvl1pPr>
@@ -1899,7 +1899,7 @@
               <a:buNone/>
               <a:defRPr lang="en-US" sz="2000" dirty="0">
                 <a:solidFill>
-                  <a:srgbClr val="DEE2FB"/>
+                  <a:srgbClr val="006FAD"/>
                 </a:solidFill>
               </a:defRPr>
             </a:lvl1pPr>
@@ -1939,7 +1939,7 @@
             <a:r>
               <a:rPr lang="en-US" sz="1200" dirty="0">
                 <a:solidFill>
-                  <a:srgbClr val="DEE2FB"/>
+                  <a:srgbClr val="6F6F6F"/>
                 </a:solidFill>
               </a:rPr>
               <a:t>Kanton Zürich · ICT-Grundbildung · PAT Cloud Solutions</a:t>
@@ -1962,7 +1962,7 @@
     <p:bg>
       <p:bgPr>
         <a:solidFill>
-          <a:srgbClr val="006FAD"/>
+          <a:srgbClr val="F7F7F7"/>
         </a:solidFill>
       </p:bgPr>
     </p:bg>
@@ -1982,7 +1982,7 @@
       </p:grpSpPr>
       <p:pic>
         <p:nvPicPr>
-          <p:cNvPr id="2" name="Image 0" descr="C:\Users\Thanam\AppData\Local\Temp\claude\c--Projekt-Trainings-azure-basics-training\a9e0bf4e-0d08-4082-a38a-5b8886538508\scratchpad\pptx\assets\wolke.png">    </p:cNvPr>
+          <p:cNvPr id="2" name="Image 0" descr="C:\Users\Thanam\AppData\Local\Temp\claude\c--Projekt-Trainings-azure-basics-training\a7a6b8eb-22f3-4b42-aecc-5af05d1502b1\scratchpad\folien\assets\wolke.png">    </p:cNvPr>
           <p:cNvPicPr>
             <a:picLocks noChangeAspect="1"/>
           </p:cNvPicPr>
@@ -2006,7 +2006,7 @@
       </p:pic>
       <p:pic>
         <p:nvPicPr>
-          <p:cNvPr id="3" name="Image 1" descr="C:\Users\Thanam\AppData\Local\Temp\claude\c--Projekt-Trainings-azure-basics-training\a9e0bf4e-0d08-4082-a38a-5b8886538508\scratchpad\pptx\assets\logo-hell.png">    </p:cNvPr>
+          <p:cNvPr id="3" name="Image 1" descr="C:\Users\Thanam\AppData\Local\Temp\claude\c--Projekt-Trainings-azure-basics-training\a7a6b8eb-22f3-4b42-aecc-5af05d1502b1\scratchpad\folien\assets\logo-dunkel.png">    </p:cNvPr>
           <p:cNvPicPr>
             <a:picLocks noChangeAspect="1"/>
           </p:cNvPicPr>
@@ -2054,7 +2054,7 @@
               <a:buNone/>
               <a:defRPr lang="en-US" sz="4000" b="1" dirty="0">
                 <a:solidFill>
-                  <a:srgbClr val="FFFFFF"/>
+                  <a:srgbClr val="27303A"/>
                 </a:solidFill>
               </a:defRPr>
             </a:lvl1pPr>
@@ -2093,7 +2093,7 @@
               <a:buNone/>
               <a:defRPr lang="en-US" sz="2000" dirty="0">
                 <a:solidFill>
-                  <a:srgbClr val="DEE2FB"/>
+                  <a:srgbClr val="006FAD"/>
                 </a:solidFill>
               </a:defRPr>
             </a:lvl1pPr>
@@ -2140,7 +2140,7 @@
       </p:grpSpPr>
       <p:pic>
         <p:nvPicPr>
-          <p:cNvPr id="2" name="Image 0" descr="C:\Users\Thanam\AppData\Local\Temp\claude\c--Projekt-Trainings-azure-basics-training\a9e0bf4e-0d08-4082-a38a-5b8886538508\scratchpad\pptx\assets\logo-dunkel.png">    </p:cNvPr>
+          <p:cNvPr id="2" name="Image 0" descr="C:\Users\Thanam\AppData\Local\Temp\claude\c--Projekt-Trainings-azure-basics-training\a7a6b8eb-22f3-4b42-aecc-5af05d1502b1\scratchpad\folien\assets\logo-dunkel.png">    </p:cNvPr>
           <p:cNvPicPr>
             <a:picLocks noChangeAspect="1"/>
           </p:cNvPicPr>
@@ -2296,7 +2296,7 @@
     <p:bg>
       <p:bgPr>
         <a:solidFill>
-          <a:srgbClr val="27303A"/>
+          <a:srgbClr val="FFFFFF"/>
         </a:solidFill>
       </p:bgPr>
     </p:bg>
@@ -2316,7 +2316,7 @@
       </p:grpSpPr>
       <p:pic>
         <p:nvPicPr>
-          <p:cNvPr id="2" name="Image 0" descr="C:\Users\Thanam\AppData\Local\Temp\claude\c--Projekt-Trainings-azure-basics-training\a9e0bf4e-0d08-4082-a38a-5b8886538508\scratchpad\pptx\assets\logo-hell.png">    </p:cNvPr>
+          <p:cNvPr id="2" name="Image 0" descr="C:\Users\Thanam\AppData\Local\Temp\claude\c--Projekt-Trainings-azure-basics-training\a7a6b8eb-22f3-4b42-aecc-5af05d1502b1\scratchpad\folien\assets\logo-dunkel.png">    </p:cNvPr>
           <p:cNvPicPr>
             <a:picLocks noChangeAspect="1"/>
           </p:cNvPicPr>
@@ -2364,7 +2364,7 @@
               <a:buNone/>
               <a:defRPr lang="en-US" sz="4000" b="1" dirty="0">
                 <a:solidFill>
-                  <a:srgbClr val="FFFFFF"/>
+                  <a:srgbClr val="27303A"/>
                 </a:solidFill>
               </a:defRPr>
             </a:lvl1pPr>
@@ -2403,7 +2403,7 @@
               <a:buNone/>
               <a:defRPr lang="en-US" sz="2000" dirty="0">
                 <a:solidFill>
-                  <a:srgbClr val="DEE2FB"/>
+                  <a:srgbClr val="006FAD"/>
                 </a:solidFill>
               </a:defRPr>
             </a:lvl1pPr>
@@ -2796,7 +2796,7 @@
             <a:r>
               <a:rPr lang="en-US" sz="4400" b="1" dirty="0">
                 <a:solidFill>
-                  <a:srgbClr val="FFFFFF"/>
+                  <a:srgbClr val="27303A"/>
                 </a:solidFill>
               </a:rPr>
               <a:t>Virtualisierung</a:t>
@@ -2834,7 +2834,7 @@
             <a:r>
               <a:rPr lang="en-US" sz="2000" dirty="0">
                 <a:solidFill>
-                  <a:srgbClr val="DEE2FB"/>
+                  <a:srgbClr val="006FAD"/>
                 </a:solidFill>
               </a:rPr>
               <a:t>Inputs Tag 1</a:t>
@@ -3504,7 +3504,7 @@
       </p:sp>
       <p:pic>
         <p:nvPicPr>
-          <p:cNvPr id="5" name="icon-FaLock" descr="C:\Users\Thanam\AppData\Local\Temp\claude\c--Projekt-Trainings-azure-basics-training\a9e0bf4e-0d08-4082-a38a-5b8886538508\scratchpad\pptx\assets\icons\FaLock.png">    </p:cNvPr>
+          <p:cNvPr id="5" name="icon-FaLock" descr="C:\Users\Thanam\AppData\Local\Temp\claude\c--Projekt-Trainings-azure-basics-training\a7a6b8eb-22f3-4b42-aecc-5af05d1502b1\scratchpad\folien\assets\icons\FaLock.png">    </p:cNvPr>
           <p:cNvPicPr>
             <a:picLocks noChangeAspect="1"/>
           </p:cNvPicPr>
@@ -3692,7 +3692,7 @@
       </p:sp>
       <p:pic>
         <p:nvPicPr>
-          <p:cNvPr id="10" name="icon-FaKey" descr="C:\Users\Thanam\AppData\Local\Temp\claude\c--Projekt-Trainings-azure-basics-training\a9e0bf4e-0d08-4082-a38a-5b8886538508\scratchpad\pptx\assets\icons\FaKey.png">    </p:cNvPr>
+          <p:cNvPr id="10" name="icon-FaKey" descr="C:\Users\Thanam\AppData\Local\Temp\claude\c--Projekt-Trainings-azure-basics-training\a7a6b8eb-22f3-4b42-aecc-5af05d1502b1\scratchpad\folien\assets\icons\FaKey.png">    </p:cNvPr>
           <p:cNvPicPr>
             <a:picLocks noChangeAspect="1"/>
           </p:cNvPicPr>
@@ -4024,7 +4024,7 @@
       </p:sp>
       <p:pic>
         <p:nvPicPr>
-          <p:cNvPr id="6" name="icon-FaQuestionCircle" descr="C:\Users\Thanam\AppData\Local\Temp\claude\c--Projekt-Trainings-azure-basics-training\a9e0bf4e-0d08-4082-a38a-5b8886538508\scratchpad\pptx\assets\icons\FaQuestionCircle.png">    </p:cNvPr>
+          <p:cNvPr id="6" name="icon-FaQuestionCircle" descr="C:\Users\Thanam\AppData\Local\Temp\claude\c--Projekt-Trainings-azure-basics-training\a7a6b8eb-22f3-4b42-aecc-5af05d1502b1\scratchpad\folien\assets\icons\FaQuestionCircle.png">    </p:cNvPr>
           <p:cNvPicPr>
             <a:picLocks noChangeAspect="1"/>
           </p:cNvPicPr>
@@ -4177,7 +4177,7 @@
       </p:sp>
       <p:pic>
         <p:nvPicPr>
-          <p:cNvPr id="11" name="icon-FaQuestionCircle" descr="C:\Users\Thanam\AppData\Local\Temp\claude\c--Projekt-Trainings-azure-basics-training\a9e0bf4e-0d08-4082-a38a-5b8886538508\scratchpad\pptx\assets\icons\FaQuestionCircle.png">    </p:cNvPr>
+          <p:cNvPr id="11" name="icon-FaQuestionCircle" descr="C:\Users\Thanam\AppData\Local\Temp\claude\c--Projekt-Trainings-azure-basics-training\a7a6b8eb-22f3-4b42-aecc-5af05d1502b1\scratchpad\folien\assets\icons\FaQuestionCircle.png">    </p:cNvPr>
           <p:cNvPicPr>
             <a:picLocks noChangeAspect="1"/>
           </p:cNvPicPr>
@@ -4330,7 +4330,7 @@
       </p:sp>
       <p:pic>
         <p:nvPicPr>
-          <p:cNvPr id="16" name="icon-FaQuestionCircle" descr="C:\Users\Thanam\AppData\Local\Temp\claude\c--Projekt-Trainings-azure-basics-training\a9e0bf4e-0d08-4082-a38a-5b8886538508\scratchpad\pptx\assets\icons\FaQuestionCircle.png">    </p:cNvPr>
+          <p:cNvPr id="16" name="icon-FaQuestionCircle" descr="C:\Users\Thanam\AppData\Local\Temp\claude\c--Projekt-Trainings-azure-basics-training\a7a6b8eb-22f3-4b42-aecc-5af05d1502b1\scratchpad\folien\assets\icons\FaQuestionCircle.png">    </p:cNvPr>
           <p:cNvPicPr>
             <a:picLocks noChangeAspect="1"/>
           </p:cNvPicPr>
@@ -4564,7 +4564,7 @@
       </p:sp>
       <p:pic>
         <p:nvPicPr>
-          <p:cNvPr id="4" name="icon-FaBook" descr="C:\Users\Thanam\AppData\Local\Temp\claude\c--Projekt-Trainings-azure-basics-training\a9e0bf4e-0d08-4082-a38a-5b8886538508\scratchpad\pptx\assets\icons\FaBook.png">    </p:cNvPr>
+          <p:cNvPr id="4" name="icon-FaBook" descr="C:\Users\Thanam\AppData\Local\Temp\claude\c--Projekt-Trainings-azure-basics-training\a7a6b8eb-22f3-4b42-aecc-5af05d1502b1\scratchpad\folien\assets\icons\FaBook.png">    </p:cNvPr>
           <p:cNvPicPr>
             <a:picLocks noChangeAspect="1"/>
           </p:cNvPicPr>
@@ -4663,7 +4663,7 @@
       </p:sp>
       <p:pic>
         <p:nvPicPr>
-          <p:cNvPr id="7" name="icon-FaGraduationCap" descr="C:\Users\Thanam\AppData\Local\Temp\claude\c--Projekt-Trainings-azure-basics-training\a9e0bf4e-0d08-4082-a38a-5b8886538508\scratchpad\pptx\assets\icons\FaGraduationCap.png">    </p:cNvPr>
+          <p:cNvPr id="7" name="icon-FaGraduationCap" descr="C:\Users\Thanam\AppData\Local\Temp\claude\c--Projekt-Trainings-azure-basics-training\a7a6b8eb-22f3-4b42-aecc-5af05d1502b1\scratchpad\folien\assets\icons\FaGraduationCap.png">    </p:cNvPr>
           <p:cNvPicPr>
             <a:picLocks noChangeAspect="1"/>
           </p:cNvPicPr>
@@ -4762,7 +4762,7 @@
       </p:sp>
       <p:pic>
         <p:nvPicPr>
-          <p:cNvPr id="10" name="icon-FaBook" descr="C:\Users\Thanam\AppData\Local\Temp\claude\c--Projekt-Trainings-azure-basics-training\a9e0bf4e-0d08-4082-a38a-5b8886538508\scratchpad\pptx\assets\icons\FaBook.png">    </p:cNvPr>
+          <p:cNvPr id="10" name="icon-FaBook" descr="C:\Users\Thanam\AppData\Local\Temp\claude\c--Projekt-Trainings-azure-basics-training\a7a6b8eb-22f3-4b42-aecc-5af05d1502b1\scratchpad\folien\assets\icons\FaBook.png">    </p:cNvPr>
           <p:cNvPicPr>
             <a:picLocks noChangeAspect="1"/>
           </p:cNvPicPr>
@@ -4933,7 +4933,7 @@
             <a:r>
               <a:rPr lang="en-US" sz="4000" b="1" dirty="0">
                 <a:solidFill>
-                  <a:srgbClr val="FFFFFF"/>
+                  <a:srgbClr val="27303A"/>
                 </a:solidFill>
               </a:rPr>
               <a:t>Jetzt du</a:t>
@@ -4971,10 +4971,10 @@
             <a:r>
               <a:rPr lang="en-US" sz="2000" dirty="0">
                 <a:solidFill>
-                  <a:srgbClr val="DEE2FB"/>
-                </a:solidFill>
-              </a:rPr>
-              <a:t>Auftrag 1.1–1.5 · ⭐ 1.6</a:t>
+                  <a:srgbClr val="006FAD"/>
+                </a:solidFill>
+              </a:rPr>
+              <a:t>Auftrag 1.1–1.6 · ⭐ 1.7</a:t>
             </a:r>
             <a:endParaRPr lang="en-US" sz="2000" dirty="0"/>
           </a:p>
@@ -5097,7 +5097,7 @@
       </p:sp>
       <p:pic>
         <p:nvPicPr>
-          <p:cNvPr id="5" name="icon-FaLayerGroup" descr="C:\Users\Thanam\AppData\Local\Temp\claude\c--Projekt-Trainings-azure-basics-training\a9e0bf4e-0d08-4082-a38a-5b8886538508\scratchpad\pptx\assets\icons\FaLayerGroup.png">    </p:cNvPr>
+          <p:cNvPr id="5" name="icon-FaLayerGroup" descr="C:\Users\Thanam\AppData\Local\Temp\claude\c--Projekt-Trainings-azure-basics-training\a7a6b8eb-22f3-4b42-aecc-5af05d1502b1\scratchpad\folien\assets\icons\FaLayerGroup.png">    </p:cNvPr>
           <p:cNvPicPr>
             <a:picLocks noChangeAspect="1"/>
           </p:cNvPicPr>
@@ -5250,7 +5250,7 @@
       </p:sp>
       <p:pic>
         <p:nvPicPr>
-          <p:cNvPr id="10" name="icon-FaMemory" descr="C:\Users\Thanam\AppData\Local\Temp\claude\c--Projekt-Trainings-azure-basics-training\a9e0bf4e-0d08-4082-a38a-5b8886538508\scratchpad\pptx\assets\icons\FaMemory.png">    </p:cNvPr>
+          <p:cNvPr id="10" name="icon-FaMemory" descr="C:\Users\Thanam\AppData\Local\Temp\claude\c--Projekt-Trainings-azure-basics-training\a7a6b8eb-22f3-4b42-aecc-5af05d1502b1\scratchpad\folien\assets\icons\FaMemory.png">    </p:cNvPr>
           <p:cNvPicPr>
             <a:picLocks noChangeAspect="1"/>
           </p:cNvPicPr>
@@ -5403,7 +5403,7 @@
       </p:sp>
       <p:pic>
         <p:nvPicPr>
-          <p:cNvPr id="15" name="icon-FaRocket" descr="C:\Users\Thanam\AppData\Local\Temp\claude\c--Projekt-Trainings-azure-basics-training\a9e0bf4e-0d08-4082-a38a-5b8886538508\scratchpad\pptx\assets\icons\FaRocket.png">    </p:cNvPr>
+          <p:cNvPr id="15" name="icon-FaRocket" descr="C:\Users\Thanam\AppData\Local\Temp\claude\c--Projekt-Trainings-azure-basics-training\a7a6b8eb-22f3-4b42-aecc-5af05d1502b1\scratchpad\folien\assets\icons\FaRocket.png">    </p:cNvPr>
           <p:cNvPicPr>
             <a:picLocks noChangeAspect="1"/>
           </p:cNvPicPr>
@@ -5556,7 +5556,7 @@
       </p:sp>
       <p:pic>
         <p:nvPicPr>
-          <p:cNvPr id="20" name="icon-FaKey" descr="C:\Users\Thanam\AppData\Local\Temp\claude\c--Projekt-Trainings-azure-basics-training\a9e0bf4e-0d08-4082-a38a-5b8886538508\scratchpad\pptx\assets\icons\FaKey.png">    </p:cNvPr>
+          <p:cNvPr id="20" name="icon-FaKey" descr="C:\Users\Thanam\AppData\Local\Temp\claude\c--Projekt-Trainings-azure-basics-training\a7a6b8eb-22f3-4b42-aecc-5af05d1502b1\scratchpad\folien\assets\icons\FaKey.png">    </p:cNvPr>
           <p:cNvPicPr>
             <a:picLocks noChangeAspect="1"/>
           </p:cNvPicPr>
@@ -5817,7 +5817,7 @@
       </p:sp>
       <p:pic>
         <p:nvPicPr>
-          <p:cNvPr id="5" name="icon-FaBuilding" descr="C:\Users\Thanam\AppData\Local\Temp\claude\c--Projekt-Trainings-azure-basics-training\a9e0bf4e-0d08-4082-a38a-5b8886538508\scratchpad\pptx\assets\icons\FaBuilding.png">    </p:cNvPr>
+          <p:cNvPr id="5" name="icon-FaBuilding" descr="C:\Users\Thanam\AppData\Local\Temp\claude\c--Projekt-Trainings-azure-basics-training\a7a6b8eb-22f3-4b42-aecc-5af05d1502b1\scratchpad\folien\assets\icons\FaBuilding.png">    </p:cNvPr>
           <p:cNvPicPr>
             <a:picLocks noChangeAspect="1"/>
           </p:cNvPicPr>
@@ -6263,7 +6263,7 @@
       </p:sp>
       <p:pic>
         <p:nvPicPr>
-          <p:cNvPr id="5" name="icon-FaServer" descr="C:\Users\Thanam\AppData\Local\Temp\claude\c--Projekt-Trainings-azure-basics-training\a9e0bf4e-0d08-4082-a38a-5b8886538508\scratchpad\pptx\assets\icons\FaServer.png">    </p:cNvPr>
+          <p:cNvPr id="5" name="icon-FaServer" descr="C:\Users\Thanam\AppData\Local\Temp\claude\c--Projekt-Trainings-azure-basics-training\a7a6b8eb-22f3-4b42-aecc-5af05d1502b1\scratchpad\folien\assets\icons\FaServer.png">    </p:cNvPr>
           <p:cNvPicPr>
             <a:picLocks noChangeAspect="1"/>
           </p:cNvPicPr>
@@ -6469,7 +6469,7 @@
       </p:sp>
       <p:pic>
         <p:nvPicPr>
-          <p:cNvPr id="10" name="icon-FaLaptop" descr="C:\Users\Thanam\AppData\Local\Temp\claude\c--Projekt-Trainings-azure-basics-training\a9e0bf4e-0d08-4082-a38a-5b8886538508\scratchpad\pptx\assets\icons\FaLaptop.png">    </p:cNvPr>
+          <p:cNvPr id="10" name="icon-FaLaptop" descr="C:\Users\Thanam\AppData\Local\Temp\claude\c--Projekt-Trainings-azure-basics-training\a7a6b8eb-22f3-4b42-aecc-5af05d1502b1\scratchpad\folien\assets\icons\FaLaptop.png">    </p:cNvPr>
           <p:cNvPicPr>
             <a:picLocks noChangeAspect="1"/>
           </p:cNvPicPr>
@@ -7351,7 +7351,7 @@
             <a:r>
               <a:rPr lang="en-US" sz="4000" b="1" dirty="0">
                 <a:solidFill>
-                  <a:srgbClr val="FFFFFF"/>
+                  <a:srgbClr val="27303A"/>
                 </a:solidFill>
               </a:rPr>
               <a:t>Automatisch statt von Hand</a:t>
@@ -7389,7 +7389,7 @@
             <a:r>
               <a:rPr lang="en-US" sz="2000" dirty="0">
                 <a:solidFill>
-                  <a:srgbClr val="DEE2FB"/>
+                  <a:srgbClr val="006FAD"/>
                 </a:solidFill>
               </a:rPr>
               <a:t>Multipass und cloud-init</a:t>

</xml_diff>

<commit_message>
Update SSH key documentation and related resources
- Changed terminology from "SSH-Schlüsselpaar" to "Key Pair" in 1.6-ssh-schluessel.md for consistency.
- Added a link to the SSH key login theory section in 1.6-ssh-schluessel.md.
- Updated the date and reading time in 01-virtualisierung.md.
- Expanded the SSH key login section in 01-virtualisierung.md with detailed explanations and diagrams.
- Updated the Azure Compute theory document with the new date.
- Added SSH key login information in 04-azure-compute.md.
- Created a new SVG diagram for SSH key login process and added it to the theory section.
- Updated glossary terms in begriffe.py to include "Host Key" and "Fingerprint".
- Enhanced diagram generation script to include SSH key login SVG.
- Updated presentation content to reflect changes in SSH key usage and added relevant notes.
</commit_message>
<xml_diff>
--- a/praesentationen/input-01-virtualisierung.pptx
+++ b/praesentationen/input-01-virtualisierung.pptx
@@ -19,9 +19,10 @@
     <p:sldId id="267" r:id="rId13"/>
     <p:sldId id="268" r:id="rId14"/>
     <p:sldId id="269" r:id="rId15"/>
+    <p:sldId id="270" r:id="rId16"/>
   </p:sldIdLst>
   <p:notesMasterIdLst>
-    <p:notesMasterId r:id="rId16"/>
+    <p:notesMasterId r:id="rId17"/>
   </p:notesMasterIdLst>
   <p:sldSz cx="12192000" cy="6858000"/>
   <p:notesSz cx="6858000" cy="12192000"/>
@@ -120,7 +121,7 @@
   <p:extLst>
     <p:ext uri="{521415D9-36F7-43E2-AB2F-B90AF26B5E84}">
       <p14:sectionLst xmlns:p14="http://schemas.microsoft.com/office/powerpoint/2010/main">
-        <p14:section name="Virtualisierung" id="{41cd8610-f5f3-633a-acf2-b6c97474ba40}">
+        <p14:section name="Virtualisierung" id="{deda42e9-88c9-67a8-d2bf-8370181d76a8}">
           <p14:sldIdLst>
             <p14:sldId id="256"/>
             <p14:sldId id="257"/>
@@ -131,7 +132,7 @@
             <p14:sldId id="262"/>
           </p14:sldIdLst>
         </p14:section>
-        <p14:section name="Multipass und cloud-init" id="{9fc0fef0-0e9e-ef58-7e7e-87416b717f66}">
+        <p14:section name="Multipass und cloud-init" id="{8ce603e4-467d-6b0c-ac0a-a8b10f261e8a}">
           <p14:sldIdLst>
             <p14:sldId id="263"/>
             <p14:sldId id="264"/>
@@ -140,6 +141,7 @@
             <p14:sldId id="267"/>
             <p14:sldId id="268"/>
             <p14:sldId id="269"/>
+            <p14:sldId id="270"/>
           </p14:sldIdLst>
         </p14:section>
       </p14:sectionLst>
@@ -722,7 +724,7 @@
           <a:p>
             <a:r>
               <a:rPr lang="en-US" dirty="0"/>
-              <a:t>Kurz vor Auftrag 1.6. Live: ssh-keygen -t ed25519.</a:t>
+              <a:t>Kurz vor Auftrag 1.6. Beide Dateien entstehen zusammen mit ssh-keygen und passen nur zueinander. Aus dem Schloss lässt sich der Schlüssel nicht nachbauen. Live: ssh-keygen -t ed25519.</a:t>
             </a:r>
             <a:endParaRPr lang="en-US" dirty="0"/>
           </a:p>
@@ -810,7 +812,7 @@
           <a:p>
             <a:r>
               <a:rPr lang="en-US" dirty="0"/>
-              <a:t>VirtualBox Typ 2, Hyper-V Typ 1. Nur beim ersten Start. Nein, Container teilen den Kernel.</a:t>
+              <a:t>1 Einmal: öffentlichen Schlüssel in authorized_keys kopieren (Auftrag 1.6, Schritt 3a). 2 ssh ubuntu@&lt;IP&gt;. 3 Server schickt eine Prüfaufgabe mit Zufallszahl. 4 Laptop löst sie mit dem privaten Schlüssel, Server prüft mit dem öffentlichen. Betonen: Der private Schlüssel geht nie über das Netz. Die Frage «Are you sure…» beim ersten Verbinden: Der Server zeigt seinen eigenen Host-Schlüssel, mit yes landet er in known_hosts.</a:t>
             </a:r>
             <a:endParaRPr lang="en-US" dirty="0"/>
           </a:p>
@@ -898,7 +900,7 @@
           <a:p>
             <a:r>
               <a:rPr lang="en-US" dirty="0"/>
-              <a:t/>
+              <a:t>VirtualBox Typ 2, Hyper-V Typ 1. Nur beim ersten Start. Nein, Container teilen den Kernel.</a:t>
             </a:r>
             <a:endParaRPr lang="en-US" dirty="0"/>
           </a:p>
@@ -1010,6 +1012,94 @@
             <a:fld id="{F7021451-1387-4CA6-816F-3879F97B5CBC}" type="slidenum">
               <a:rPr lang="en-US"/>
               <a:t>14</a:t>
+            </a:fld>
+            <a:endParaRPr lang="en-US"/>
+          </a:p>
+        </p:txBody>
+      </p:sp>
+    </p:spTree>
+    <p:extLst>
+      <p:ext uri="{BB962C8B-B14F-4D97-AF65-F5344CB8AC3E}">
+        <p14:creationId xmlns:p14="http://schemas.microsoft.com/office/powerpoint/2010/main" val="1024086991"/>
+      </p:ext>
+    </p:extLst>
+  </p:cSld>
+  <p:clrMapOvr>
+    <a:masterClrMapping/>
+  </p:clrMapOvr>
+</p:notes>
+</file>
+
+<file path=ppt/notesSlides/notesSlide15.xml><?xml version="1.0" encoding="utf-8"?>
+<p:notes xmlns:a="http://schemas.openxmlformats.org/drawingml/2006/main" xmlns:r="http://schemas.openxmlformats.org/officeDocument/2006/relationships" xmlns:p="http://schemas.openxmlformats.org/presentationml/2006/main">
+  <p:cSld>
+    <p:spTree>
+      <p:nvGrpSpPr>
+        <p:cNvPr id="1" name=""/>
+        <p:cNvGrpSpPr/>
+        <p:nvPr/>
+      </p:nvGrpSpPr>
+      <p:grpSpPr>
+        <a:xfrm>
+          <a:off x="0" y="0"/>
+          <a:ext cx="0" cy="0"/>
+          <a:chOff x="0" y="0"/>
+          <a:chExt cx="0" cy="0"/>
+        </a:xfrm>
+      </p:grpSpPr>
+      <p:sp>
+        <p:nvSpPr>
+          <p:cNvPr id="2" name="Slide Image Placeholder 1"/>
+          <p:cNvSpPr>
+            <a:spLocks noGrp="1" noRot="1" noChangeAspect="1"/>
+          </p:cNvSpPr>
+          <p:nvPr>
+            <p:ph type="sldImg"/>
+          </p:nvPr>
+        </p:nvSpPr>
+        <p:spPr/>
+      </p:sp>
+      <p:sp>
+        <p:nvSpPr>
+          <p:cNvPr id="3" name="Notes Placeholder 2"/>
+          <p:cNvSpPr>
+            <a:spLocks noGrp="1"/>
+          </p:cNvSpPr>
+          <p:nvPr>
+            <p:ph type="body" idx="1"/>
+          </p:nvPr>
+        </p:nvSpPr>
+        <p:spPr/>
+        <p:txBody>
+          <a:bodyPr/>
+          <a:lstStyle/>
+          <a:p>
+            <a:r>
+              <a:rPr lang="en-US" dirty="0"/>
+              <a:t/>
+            </a:r>
+            <a:endParaRPr lang="en-US" dirty="0"/>
+          </a:p>
+        </p:txBody>
+      </p:sp>
+      <p:sp>
+        <p:nvSpPr>
+          <p:cNvPr id="4" name="Slide Number Placeholder 3"/>
+          <p:cNvSpPr>
+            <a:spLocks noGrp="1"/>
+          </p:cNvSpPr>
+          <p:nvPr>
+            <p:ph type="sldNum" sz="quarter" idx="10"/>
+          </p:nvPr>
+        </p:nvSpPr>
+        <p:spPr/>
+        <p:txBody>
+          <a:bodyPr/>
+          <a:lstStyle/>
+          <a:p>
+            <a:fld id="{F7021451-1387-4CA6-816F-3879F97B5CBC}" type="slidenum">
+              <a:rPr lang="en-US"/>
+              <a:t>15</a:t>
             </a:fld>
             <a:endParaRPr lang="en-US"/>
           </a:p>
@@ -1788,7 +1878,7 @@
       </p:grpSpPr>
       <p:pic>
         <p:nvPicPr>
-          <p:cNvPr id="2" name="Image 0" descr="C:\Users\Thanam\AppData\Local\Temp\claude\c--Projekt-Trainings-azure-basics-training\a7a6b8eb-22f3-4b42-aecc-5af05d1502b1\scratchpad\folien\assets\logo-dunkel.png">    </p:cNvPr>
+          <p:cNvPr id="2" name="Image 0" descr="C:\Users\Thanam\AppData\Local\Temp\claude\c--Projekt-Trainings-azure-basics-training\d01384da-f513-40b3-985e-441cf1c86f9e\scratchpad\arbeit\assets\logo-dunkel.png">    </p:cNvPr>
           <p:cNvPicPr>
             <a:picLocks noChangeAspect="1"/>
           </p:cNvPicPr>
@@ -1812,7 +1902,7 @@
       </p:pic>
       <p:pic>
         <p:nvPicPr>
-          <p:cNvPr id="3" name="Image 1" descr="C:\Users\Thanam\AppData\Local\Temp\claude\c--Projekt-Trainings-azure-basics-training\a7a6b8eb-22f3-4b42-aecc-5af05d1502b1\scratchpad\folien\assets\wolke.png">    </p:cNvPr>
+          <p:cNvPr id="3" name="Image 1" descr="C:\Users\Thanam\AppData\Local\Temp\claude\c--Projekt-Trainings-azure-basics-training\d01384da-f513-40b3-985e-441cf1c86f9e\scratchpad\arbeit\assets\wolke.png">    </p:cNvPr>
           <p:cNvPicPr>
             <a:picLocks noChangeAspect="1"/>
           </p:cNvPicPr>
@@ -1982,7 +2072,7 @@
       </p:grpSpPr>
       <p:pic>
         <p:nvPicPr>
-          <p:cNvPr id="2" name="Image 0" descr="C:\Users\Thanam\AppData\Local\Temp\claude\c--Projekt-Trainings-azure-basics-training\a7a6b8eb-22f3-4b42-aecc-5af05d1502b1\scratchpad\folien\assets\wolke.png">    </p:cNvPr>
+          <p:cNvPr id="2" name="Image 0" descr="C:\Users\Thanam\AppData\Local\Temp\claude\c--Projekt-Trainings-azure-basics-training\d01384da-f513-40b3-985e-441cf1c86f9e\scratchpad\arbeit\assets\wolke.png">    </p:cNvPr>
           <p:cNvPicPr>
             <a:picLocks noChangeAspect="1"/>
           </p:cNvPicPr>
@@ -2006,7 +2096,7 @@
       </p:pic>
       <p:pic>
         <p:nvPicPr>
-          <p:cNvPr id="3" name="Image 1" descr="C:\Users\Thanam\AppData\Local\Temp\claude\c--Projekt-Trainings-azure-basics-training\a7a6b8eb-22f3-4b42-aecc-5af05d1502b1\scratchpad\folien\assets\logo-dunkel.png">    </p:cNvPr>
+          <p:cNvPr id="3" name="Image 1" descr="C:\Users\Thanam\AppData\Local\Temp\claude\c--Projekt-Trainings-azure-basics-training\d01384da-f513-40b3-985e-441cf1c86f9e\scratchpad\arbeit\assets\logo-dunkel.png">    </p:cNvPr>
           <p:cNvPicPr>
             <a:picLocks noChangeAspect="1"/>
           </p:cNvPicPr>
@@ -2140,7 +2230,7 @@
       </p:grpSpPr>
       <p:pic>
         <p:nvPicPr>
-          <p:cNvPr id="2" name="Image 0" descr="C:\Users\Thanam\AppData\Local\Temp\claude\c--Projekt-Trainings-azure-basics-training\a7a6b8eb-22f3-4b42-aecc-5af05d1502b1\scratchpad\folien\assets\logo-dunkel.png">    </p:cNvPr>
+          <p:cNvPr id="2" name="Image 0" descr="C:\Users\Thanam\AppData\Local\Temp\claude\c--Projekt-Trainings-azure-basics-training\d01384da-f513-40b3-985e-441cf1c86f9e\scratchpad\arbeit\assets\logo-dunkel.png">    </p:cNvPr>
           <p:cNvPicPr>
             <a:picLocks noChangeAspect="1"/>
           </p:cNvPicPr>
@@ -2316,7 +2406,7 @@
       </p:grpSpPr>
       <p:pic>
         <p:nvPicPr>
-          <p:cNvPr id="2" name="Image 0" descr="C:\Users\Thanam\AppData\Local\Temp\claude\c--Projekt-Trainings-azure-basics-training\a7a6b8eb-22f3-4b42-aecc-5af05d1502b1\scratchpad\folien\assets\logo-dunkel.png">    </p:cNvPr>
+          <p:cNvPr id="2" name="Image 0" descr="C:\Users\Thanam\AppData\Local\Temp\claude\c--Projekt-Trainings-azure-basics-training\d01384da-f513-40b3-985e-441cf1c86f9e\scratchpad\arbeit\assets\logo-dunkel.png">    </p:cNvPr>
           <p:cNvPicPr>
             <a:picLocks noChangeAspect="1"/>
           </p:cNvPicPr>
@@ -3459,11 +3549,11 @@
         <p:spPr>
           <a:xfrm>
             <a:off x="548640" y="1325880"/>
-            <a:ext cx="5364328" cy="4709160"/>
+            <a:ext cx="5364328" cy="4160520"/>
           </a:xfrm>
           <a:prstGeom prst="roundRect">
             <a:avLst>
-              <a:gd name="adj" fmla="val 2330"/>
+              <a:gd name="adj" fmla="val 2637"/>
             </a:avLst>
           </a:prstGeom>
           <a:solidFill>
@@ -3504,7 +3594,7 @@
       </p:sp>
       <p:pic>
         <p:nvPicPr>
-          <p:cNvPr id="5" name="icon-FaLock" descr="C:\Users\Thanam\AppData\Local\Temp\claude\c--Projekt-Trainings-azure-basics-training\a7a6b8eb-22f3-4b42-aecc-5af05d1502b1\scratchpad\folien\assets\icons\FaLock.png">    </p:cNvPr>
+          <p:cNvPr id="5" name="icon-FaLock" descr="C:\Users\Thanam\AppData\Local\Temp\claude\c--Projekt-Trainings-azure-basics-training\d01384da-f513-40b3-985e-441cf1c86f9e\scratchpad\arbeit\assets\icons\FaLock.png">    </p:cNvPr>
           <p:cNvPicPr>
             <a:picLocks noChangeAspect="1"/>
           </p:cNvPicPr>
@@ -3571,7 +3661,7 @@
         <p:spPr>
           <a:xfrm>
             <a:off x="868680" y="2514600"/>
-            <a:ext cx="4724248" cy="3337560"/>
+            <a:ext cx="4724248" cy="2788920"/>
           </a:xfrm>
           <a:prstGeom prst="rect">
             <a:avLst/>
@@ -3647,11 +3737,11 @@
         <p:spPr>
           <a:xfrm>
             <a:off x="6278728" y="1325880"/>
-            <a:ext cx="5364328" cy="4709160"/>
+            <a:ext cx="5364328" cy="4160520"/>
           </a:xfrm>
           <a:prstGeom prst="roundRect">
             <a:avLst>
-              <a:gd name="adj" fmla="val 2330"/>
+              <a:gd name="adj" fmla="val 2637"/>
             </a:avLst>
           </a:prstGeom>
           <a:solidFill>
@@ -3692,7 +3782,7 @@
       </p:sp>
       <p:pic>
         <p:nvPicPr>
-          <p:cNvPr id="10" name="icon-FaKey" descr="C:\Users\Thanam\AppData\Local\Temp\claude\c--Projekt-Trainings-azure-basics-training\a7a6b8eb-22f3-4b42-aecc-5af05d1502b1\scratchpad\folien\assets\icons\FaKey.png">    </p:cNvPr>
+          <p:cNvPr id="10" name="icon-FaKey" descr="C:\Users\Thanam\AppData\Local\Temp\claude\c--Projekt-Trainings-azure-basics-training\d01384da-f513-40b3-985e-441cf1c86f9e\scratchpad\arbeit\assets\icons\FaKey.png">    </p:cNvPr>
           <p:cNvPicPr>
             <a:picLocks noChangeAspect="1"/>
           </p:cNvPicPr>
@@ -3759,7 +3849,7 @@
         <p:spPr>
           <a:xfrm>
             <a:off x="6598768" y="2514600"/>
-            <a:ext cx="4724248" cy="3337560"/>
+            <a:ext cx="4724248" cy="2788920"/>
           </a:xfrm>
           <a:prstGeom prst="rect">
             <a:avLst/>
@@ -3823,6 +3913,42 @@
               <a:t>bleibt auf deinem Laptop – nie weitergeben</a:t>
             </a:r>
             <a:endParaRPr lang="en-US" sz="1800" dirty="0"/>
+          </a:p>
+        </p:txBody>
+      </p:sp>
+      <p:sp>
+        <p:nvSpPr>
+          <p:cNvPr id="13" name="Text 9"/>
+          <p:cNvSpPr txBox="1"/>
+          <p:nvPr/>
+        </p:nvSpPr>
+        <p:spPr>
+          <a:xfrm>
+            <a:off x="548640" y="5623560"/>
+            <a:ext cx="11094415" cy="457200"/>
+          </a:xfrm>
+          <a:prstGeom prst="rect">
+            <a:avLst/>
+          </a:prstGeom>
+          <a:noFill/>
+          <a:ln/>
+        </p:spPr>
+        <p:txBody>
+          <a:bodyPr wrap="square" lIns="0" tIns="0" rIns="0" bIns="0" rtlCol="0" anchor="ctr"/>
+          <a:lstStyle/>
+          <a:p>
+            <a:pPr indent="0" marL="0">
+              <a:buNone/>
+            </a:pPr>
+            <a:r>
+              <a:rPr lang="en-US" sz="1500" b="1" dirty="0">
+                <a:solidFill>
+                  <a:srgbClr val="006FAD"/>
+                </a:solidFill>
+              </a:rPr>
+              <a:t>Warum kein Passwort? Bots probieren im Internet ständig Passwörter durch. Einen Schlüssel kann man nicht erraten.</a:t>
+            </a:r>
+            <a:endParaRPr lang="en-US" sz="1500" dirty="0"/>
           </a:p>
         </p:txBody>
       </p:sp>
@@ -3928,103 +4054,15 @@
                   <a:srgbClr val="27303A"/>
                 </a:solidFill>
               </a:rPr>
-              <a:t>Selbsttest</a:t>
+              <a:t>So läuft die Anmeldung ab</a:t>
             </a:r>
             <a:endParaRPr lang="en-US" sz="3400" dirty="0"/>
           </a:p>
         </p:txBody>
-      </p:sp>
-      <p:sp>
-        <p:nvSpPr>
-          <p:cNvPr id="3" name="Text 1"/>
-          <p:cNvSpPr txBox="1"/>
-          <p:nvPr/>
-        </p:nvSpPr>
-        <p:spPr>
-          <a:xfrm>
-            <a:off x="548640" y="1325880"/>
-            <a:ext cx="11094415" cy="457200"/>
-          </a:xfrm>
-          <a:prstGeom prst="rect">
-            <a:avLst/>
-          </a:prstGeom>
-          <a:noFill/>
-          <a:ln/>
-        </p:spPr>
-        <p:txBody>
-          <a:bodyPr wrap="square" lIns="0" tIns="0" rIns="0" bIns="0" rtlCol="0" anchor="ctr"/>
-          <a:lstStyle/>
-          <a:p>
-            <a:pPr indent="0" marL="0">
-              <a:buNone/>
-            </a:pPr>
-            <a:r>
-              <a:rPr lang="en-US" sz="1600" dirty="0">
-                <a:solidFill>
-                  <a:srgbClr val="6F6F6F"/>
-                </a:solidFill>
-              </a:rPr>
-              <a:t>Erst selbst überlegen, dann mit dem Nachbarn vergleichen.</a:t>
-            </a:r>
-            <a:endParaRPr lang="en-US" sz="1600" dirty="0"/>
-          </a:p>
-        </p:txBody>
-      </p:sp>
-      <p:sp>
-        <p:nvSpPr>
-          <p:cNvPr id="4" name="karte"/>
-          <p:cNvSpPr/>
-          <p:nvPr/>
-        </p:nvSpPr>
-        <p:spPr>
-          <a:xfrm>
-            <a:off x="548640" y="2743200"/>
-            <a:ext cx="3515258" cy="2468880"/>
-          </a:xfrm>
-          <a:prstGeom prst="roundRect">
-            <a:avLst>
-              <a:gd name="adj" fmla="val 4444"/>
-            </a:avLst>
-          </a:prstGeom>
-          <a:solidFill>
-            <a:srgbClr val="F7F7F7"/>
-          </a:solidFill>
-          <a:ln w="12700">
-            <a:solidFill>
-              <a:srgbClr val="F7F7F7"/>
-            </a:solidFill>
-            <a:prstDash val="solid"/>
-          </a:ln>
-        </p:spPr>
-      </p:sp>
-      <p:sp>
-        <p:nvSpPr>
-          <p:cNvPr id="5" name="icon-kreis-FaQuestionCircle"/>
-          <p:cNvSpPr/>
-          <p:nvPr/>
-        </p:nvSpPr>
-        <p:spPr>
-          <a:xfrm>
-            <a:off x="822960" y="3017520"/>
-            <a:ext cx="640080" cy="640080"/>
-          </a:xfrm>
-          <a:prstGeom prst="ellipse">
-            <a:avLst/>
-          </a:prstGeom>
-          <a:solidFill>
-            <a:srgbClr val="006FAD"/>
-          </a:solidFill>
-          <a:ln w="12700">
-            <a:solidFill>
-              <a:srgbClr val="006FAD"/>
-            </a:solidFill>
-            <a:prstDash val="solid"/>
-          </a:ln>
-        </p:spPr>
       </p:sp>
       <p:pic>
         <p:nvPicPr>
-          <p:cNvPr id="6" name="icon-FaQuestionCircle" descr="C:\Users\Thanam\AppData\Local\Temp\claude\c--Projekt-Trainings-azure-basics-training\a7a6b8eb-22f3-4b42-aecc-5af05d1502b1\scratchpad\folien\assets\icons\FaQuestionCircle.png">    </p:cNvPr>
+          <p:cNvPr id="3" name="diagramm" descr="So läuft die Anmeldung ab">    </p:cNvPr>
           <p:cNvPicPr>
             <a:picLocks noChangeAspect="1"/>
           </p:cNvPicPr>
@@ -4038,397 +4076,14 @@
         </p:blipFill>
         <p:spPr>
           <a:xfrm>
-            <a:off x="976579" y="3171139"/>
-            <a:ext cx="332842" cy="332842"/>
+            <a:off x="1367775" y="1325880"/>
+            <a:ext cx="9456145" cy="4709160"/>
           </a:xfrm>
           <a:prstGeom prst="rect">
             <a:avLst/>
           </a:prstGeom>
         </p:spPr>
       </p:pic>
-      <p:sp>
-        <p:nvSpPr>
-          <p:cNvPr id="7" name="Text 4"/>
-          <p:cNvSpPr txBox="1"/>
-          <p:nvPr/>
-        </p:nvSpPr>
-        <p:spPr>
-          <a:xfrm>
-            <a:off x="1645920" y="3017520"/>
-            <a:ext cx="2189378" cy="640080"/>
-          </a:xfrm>
-          <a:prstGeom prst="rect">
-            <a:avLst/>
-          </a:prstGeom>
-          <a:noFill/>
-          <a:ln/>
-        </p:spPr>
-        <p:txBody>
-          <a:bodyPr wrap="square" lIns="0" tIns="0" rIns="0" bIns="0" rtlCol="0" anchor="ctr">
-            <a:normAutofit/>
-          </a:bodyPr>
-          <a:lstStyle/>
-          <a:p>
-            <a:pPr indent="0" marL="0">
-              <a:buNone/>
-            </a:pPr>
-            <a:r>
-              <a:rPr lang="en-US" sz="2000" b="1" dirty="0">
-                <a:solidFill>
-                  <a:srgbClr val="27303A"/>
-                </a:solidFill>
-              </a:rPr>
-              <a:t>Hypervisor</a:t>
-            </a:r>
-            <a:endParaRPr lang="en-US" sz="2000" dirty="0"/>
-          </a:p>
-        </p:txBody>
-      </p:sp>
-      <p:sp>
-        <p:nvSpPr>
-          <p:cNvPr id="8" name="Text 5"/>
-          <p:cNvSpPr txBox="1"/>
-          <p:nvPr/>
-        </p:nvSpPr>
-        <p:spPr>
-          <a:xfrm>
-            <a:off x="822960" y="3840480"/>
-            <a:ext cx="2966618" cy="1234440"/>
-          </a:xfrm>
-          <a:prstGeom prst="rect">
-            <a:avLst/>
-          </a:prstGeom>
-          <a:noFill/>
-          <a:ln/>
-        </p:spPr>
-        <p:txBody>
-          <a:bodyPr wrap="square" lIns="0" tIns="0" rIns="0" bIns="0" rtlCol="0" anchor="t"/>
-          <a:lstStyle/>
-          <a:p>
-            <a:pPr indent="0" marL="0">
-              <a:spcAft>
-                <a:spcPts val="400"/>
-              </a:spcAft>
-              <a:buNone/>
-            </a:pPr>
-            <a:r>
-              <a:rPr lang="en-US" sz="1600" dirty="0">
-                <a:solidFill>
-                  <a:srgbClr val="27303A"/>
-                </a:solidFill>
-              </a:rPr>
-              <a:t>Typ 1 oder Typ 2: VirtualBox, Hyper-V?</a:t>
-            </a:r>
-            <a:endParaRPr lang="en-US" sz="1600" dirty="0"/>
-          </a:p>
-        </p:txBody>
-      </p:sp>
-      <p:sp>
-        <p:nvSpPr>
-          <p:cNvPr id="9" name="karte"/>
-          <p:cNvSpPr/>
-          <p:nvPr/>
-        </p:nvSpPr>
-        <p:spPr>
-          <a:xfrm>
-            <a:off x="4338218" y="2743200"/>
-            <a:ext cx="3515258" cy="2468880"/>
-          </a:xfrm>
-          <a:prstGeom prst="roundRect">
-            <a:avLst>
-              <a:gd name="adj" fmla="val 4444"/>
-            </a:avLst>
-          </a:prstGeom>
-          <a:solidFill>
-            <a:srgbClr val="F7F7F7"/>
-          </a:solidFill>
-          <a:ln w="12700">
-            <a:solidFill>
-              <a:srgbClr val="F7F7F7"/>
-            </a:solidFill>
-            <a:prstDash val="solid"/>
-          </a:ln>
-        </p:spPr>
-      </p:sp>
-      <p:sp>
-        <p:nvSpPr>
-          <p:cNvPr id="10" name="icon-kreis-FaQuestionCircle"/>
-          <p:cNvSpPr/>
-          <p:nvPr/>
-        </p:nvSpPr>
-        <p:spPr>
-          <a:xfrm>
-            <a:off x="4612538" y="3017520"/>
-            <a:ext cx="640080" cy="640080"/>
-          </a:xfrm>
-          <a:prstGeom prst="ellipse">
-            <a:avLst/>
-          </a:prstGeom>
-          <a:solidFill>
-            <a:srgbClr val="006FAD"/>
-          </a:solidFill>
-          <a:ln w="12700">
-            <a:solidFill>
-              <a:srgbClr val="006FAD"/>
-            </a:solidFill>
-            <a:prstDash val="solid"/>
-          </a:ln>
-        </p:spPr>
-      </p:sp>
-      <p:pic>
-        <p:nvPicPr>
-          <p:cNvPr id="11" name="icon-FaQuestionCircle" descr="C:\Users\Thanam\AppData\Local\Temp\claude\c--Projekt-Trainings-azure-basics-training\a7a6b8eb-22f3-4b42-aecc-5af05d1502b1\scratchpad\folien\assets\icons\FaQuestionCircle.png">    </p:cNvPr>
-          <p:cNvPicPr>
-            <a:picLocks noChangeAspect="1"/>
-          </p:cNvPicPr>
-          <p:nvPr/>
-        </p:nvPicPr>
-        <p:blipFill>
-          <a:blip r:embed="rId2"/>
-          <a:stretch>
-            <a:fillRect/>
-          </a:stretch>
-        </p:blipFill>
-        <p:spPr>
-          <a:xfrm>
-            <a:off x="4766158" y="3171139"/>
-            <a:ext cx="332842" cy="332842"/>
-          </a:xfrm>
-          <a:prstGeom prst="rect">
-            <a:avLst/>
-          </a:prstGeom>
-        </p:spPr>
-      </p:pic>
-      <p:sp>
-        <p:nvSpPr>
-          <p:cNvPr id="12" name="Text 8"/>
-          <p:cNvSpPr txBox="1"/>
-          <p:nvPr/>
-        </p:nvSpPr>
-        <p:spPr>
-          <a:xfrm>
-            <a:off x="5435498" y="3017520"/>
-            <a:ext cx="2189378" cy="640080"/>
-          </a:xfrm>
-          <a:prstGeom prst="rect">
-            <a:avLst/>
-          </a:prstGeom>
-          <a:noFill/>
-          <a:ln/>
-        </p:spPr>
-        <p:txBody>
-          <a:bodyPr wrap="square" lIns="0" tIns="0" rIns="0" bIns="0" rtlCol="0" anchor="ctr">
-            <a:normAutofit/>
-          </a:bodyPr>
-          <a:lstStyle/>
-          <a:p>
-            <a:pPr indent="0" marL="0">
-              <a:buNone/>
-            </a:pPr>
-            <a:r>
-              <a:rPr lang="en-US" sz="2000" b="1" dirty="0">
-                <a:solidFill>
-                  <a:srgbClr val="27303A"/>
-                </a:solidFill>
-              </a:rPr>
-              <a:t>cloud-init</a:t>
-            </a:r>
-            <a:endParaRPr lang="en-US" sz="2000" dirty="0"/>
-          </a:p>
-        </p:txBody>
-      </p:sp>
-      <p:sp>
-        <p:nvSpPr>
-          <p:cNvPr id="13" name="Text 9"/>
-          <p:cNvSpPr txBox="1"/>
-          <p:nvPr/>
-        </p:nvSpPr>
-        <p:spPr>
-          <a:xfrm>
-            <a:off x="4612538" y="3840480"/>
-            <a:ext cx="2966618" cy="1234440"/>
-          </a:xfrm>
-          <a:prstGeom prst="rect">
-            <a:avLst/>
-          </a:prstGeom>
-          <a:noFill/>
-          <a:ln/>
-        </p:spPr>
-        <p:txBody>
-          <a:bodyPr wrap="square" lIns="0" tIns="0" rIns="0" bIns="0" rtlCol="0" anchor="t"/>
-          <a:lstStyle/>
-          <a:p>
-            <a:pPr indent="0" marL="0">
-              <a:spcAft>
-                <a:spcPts val="400"/>
-              </a:spcAft>
-              <a:buNone/>
-            </a:pPr>
-            <a:r>
-              <a:rPr lang="en-US" sz="1600" dirty="0">
-                <a:solidFill>
-                  <a:srgbClr val="27303A"/>
-                </a:solidFill>
-              </a:rPr>
-              <a:t>Wann arbeitet cloud-init die Datei ab?</a:t>
-            </a:r>
-            <a:endParaRPr lang="en-US" sz="1600" dirty="0"/>
-          </a:p>
-        </p:txBody>
-      </p:sp>
-      <p:sp>
-        <p:nvSpPr>
-          <p:cNvPr id="14" name="karte"/>
-          <p:cNvSpPr/>
-          <p:nvPr/>
-        </p:nvSpPr>
-        <p:spPr>
-          <a:xfrm>
-            <a:off x="8127797" y="2743200"/>
-            <a:ext cx="3515258" cy="2468880"/>
-          </a:xfrm>
-          <a:prstGeom prst="roundRect">
-            <a:avLst>
-              <a:gd name="adj" fmla="val 4444"/>
-            </a:avLst>
-          </a:prstGeom>
-          <a:solidFill>
-            <a:srgbClr val="F7F7F7"/>
-          </a:solidFill>
-          <a:ln w="12700">
-            <a:solidFill>
-              <a:srgbClr val="F7F7F7"/>
-            </a:solidFill>
-            <a:prstDash val="solid"/>
-          </a:ln>
-        </p:spPr>
-      </p:sp>
-      <p:sp>
-        <p:nvSpPr>
-          <p:cNvPr id="15" name="icon-kreis-FaQuestionCircle"/>
-          <p:cNvSpPr/>
-          <p:nvPr/>
-        </p:nvSpPr>
-        <p:spPr>
-          <a:xfrm>
-            <a:off x="8402117" y="3017520"/>
-            <a:ext cx="640080" cy="640080"/>
-          </a:xfrm>
-          <a:prstGeom prst="ellipse">
-            <a:avLst/>
-          </a:prstGeom>
-          <a:solidFill>
-            <a:srgbClr val="006FAD"/>
-          </a:solidFill>
-          <a:ln w="12700">
-            <a:solidFill>
-              <a:srgbClr val="006FAD"/>
-            </a:solidFill>
-            <a:prstDash val="solid"/>
-          </a:ln>
-        </p:spPr>
-      </p:sp>
-      <p:pic>
-        <p:nvPicPr>
-          <p:cNvPr id="16" name="icon-FaQuestionCircle" descr="C:\Users\Thanam\AppData\Local\Temp\claude\c--Projekt-Trainings-azure-basics-training\a7a6b8eb-22f3-4b42-aecc-5af05d1502b1\scratchpad\folien\assets\icons\FaQuestionCircle.png">    </p:cNvPr>
-          <p:cNvPicPr>
-            <a:picLocks noChangeAspect="1"/>
-          </p:cNvPicPr>
-          <p:nvPr/>
-        </p:nvPicPr>
-        <p:blipFill>
-          <a:blip r:embed="rId3"/>
-          <a:stretch>
-            <a:fillRect/>
-          </a:stretch>
-        </p:blipFill>
-        <p:spPr>
-          <a:xfrm>
-            <a:off x="8555736" y="3171139"/>
-            <a:ext cx="332842" cy="332842"/>
-          </a:xfrm>
-          <a:prstGeom prst="rect">
-            <a:avLst/>
-          </a:prstGeom>
-        </p:spPr>
-      </p:pic>
-      <p:sp>
-        <p:nvSpPr>
-          <p:cNvPr id="17" name="Text 12"/>
-          <p:cNvSpPr txBox="1"/>
-          <p:nvPr/>
-        </p:nvSpPr>
-        <p:spPr>
-          <a:xfrm>
-            <a:off x="9225077" y="3017520"/>
-            <a:ext cx="2189378" cy="640080"/>
-          </a:xfrm>
-          <a:prstGeom prst="rect">
-            <a:avLst/>
-          </a:prstGeom>
-          <a:noFill/>
-          <a:ln/>
-        </p:spPr>
-        <p:txBody>
-          <a:bodyPr wrap="square" lIns="0" tIns="0" rIns="0" bIns="0" rtlCol="0" anchor="ctr">
-            <a:normAutofit/>
-          </a:bodyPr>
-          <a:lstStyle/>
-          <a:p>
-            <a:pPr indent="0" marL="0">
-              <a:buNone/>
-            </a:pPr>
-            <a:r>
-              <a:rPr lang="en-US" sz="2000" b="1" dirty="0">
-                <a:solidFill>
-                  <a:srgbClr val="27303A"/>
-                </a:solidFill>
-              </a:rPr>
-              <a:t>Docker</a:t>
-            </a:r>
-            <a:endParaRPr lang="en-US" sz="2000" dirty="0"/>
-          </a:p>
-        </p:txBody>
-      </p:sp>
-      <p:sp>
-        <p:nvSpPr>
-          <p:cNvPr id="18" name="Text 13"/>
-          <p:cNvSpPr txBox="1"/>
-          <p:nvPr/>
-        </p:nvSpPr>
-        <p:spPr>
-          <a:xfrm>
-            <a:off x="8402117" y="3840480"/>
-            <a:ext cx="2966618" cy="1234440"/>
-          </a:xfrm>
-          <a:prstGeom prst="rect">
-            <a:avLst/>
-          </a:prstGeom>
-          <a:noFill/>
-          <a:ln/>
-        </p:spPr>
-        <p:txBody>
-          <a:bodyPr wrap="square" lIns="0" tIns="0" rIns="0" bIns="0" rtlCol="0" anchor="t"/>
-          <a:lstStyle/>
-          <a:p>
-            <a:pPr indent="0" marL="0">
-              <a:spcAft>
-                <a:spcPts val="400"/>
-              </a:spcAft>
-              <a:buNone/>
-            </a:pPr>
-            <a:r>
-              <a:rPr lang="en-US" sz="1600" dirty="0">
-                <a:solidFill>
-                  <a:srgbClr val="27303A"/>
-                </a:solidFill>
-              </a:rPr>
-              <a:t>Ein Kollege sagt: «Docker ist auch ein Hypervisor.» Stimmt das?</a:t>
-            </a:r>
-            <a:endParaRPr lang="en-US" sz="1600" dirty="0"/>
-          </a:p>
-        </p:txBody>
-      </p:sp>
       <p:sp>
         <p:nvSpPr>
           <p:cNvPr id="25" name="Slide Number Placeholder 0"/>
@@ -4531,7 +4186,7 @@
                   <a:srgbClr val="27303A"/>
                 </a:solidFill>
               </a:rPr>
-              <a:t>Zum Nachlesen</a:t>
+              <a:t>Selbsttest</a:t>
             </a:r>
             <a:endParaRPr lang="en-US" sz="3400" dirty="0"/>
           </a:p>
@@ -4539,14 +4194,77 @@
       </p:sp>
       <p:sp>
         <p:nvSpPr>
-          <p:cNvPr id="3" name="icon-kreis-FaBook"/>
+          <p:cNvPr id="3" name="Text 1"/>
+          <p:cNvSpPr txBox="1"/>
+          <p:nvPr/>
+        </p:nvSpPr>
+        <p:spPr>
+          <a:xfrm>
+            <a:off x="548640" y="1325880"/>
+            <a:ext cx="11094415" cy="457200"/>
+          </a:xfrm>
+          <a:prstGeom prst="rect">
+            <a:avLst/>
+          </a:prstGeom>
+          <a:noFill/>
+          <a:ln/>
+        </p:spPr>
+        <p:txBody>
+          <a:bodyPr wrap="square" lIns="0" tIns="0" rIns="0" bIns="0" rtlCol="0" anchor="ctr"/>
+          <a:lstStyle/>
+          <a:p>
+            <a:pPr indent="0" marL="0">
+              <a:buNone/>
+            </a:pPr>
+            <a:r>
+              <a:rPr lang="en-US" sz="1600" dirty="0">
+                <a:solidFill>
+                  <a:srgbClr val="6F6F6F"/>
+                </a:solidFill>
+              </a:rPr>
+              <a:t>Erst selbst überlegen, dann mit dem Nachbarn vergleichen.</a:t>
+            </a:r>
+            <a:endParaRPr lang="en-US" sz="1600" dirty="0"/>
+          </a:p>
+        </p:txBody>
+      </p:sp>
+      <p:sp>
+        <p:nvSpPr>
+          <p:cNvPr id="4" name="karte"/>
           <p:cNvSpPr/>
           <p:nvPr/>
         </p:nvSpPr>
         <p:spPr>
           <a:xfrm>
-            <a:off x="548640" y="2446020"/>
-            <a:ext cx="548640" cy="548640"/>
+            <a:off x="548640" y="2743200"/>
+            <a:ext cx="3515258" cy="2468880"/>
+          </a:xfrm>
+          <a:prstGeom prst="roundRect">
+            <a:avLst>
+              <a:gd name="adj" fmla="val 4444"/>
+            </a:avLst>
+          </a:prstGeom>
+          <a:solidFill>
+            <a:srgbClr val="F7F7F7"/>
+          </a:solidFill>
+          <a:ln w="12700">
+            <a:solidFill>
+              <a:srgbClr val="F7F7F7"/>
+            </a:solidFill>
+            <a:prstDash val="solid"/>
+          </a:ln>
+        </p:spPr>
+      </p:sp>
+      <p:sp>
+        <p:nvSpPr>
+          <p:cNvPr id="5" name="icon-kreis-FaQuestionCircle"/>
+          <p:cNvSpPr/>
+          <p:nvPr/>
+        </p:nvSpPr>
+        <p:spPr>
+          <a:xfrm>
+            <a:off x="822960" y="3017520"/>
+            <a:ext cx="640080" cy="640080"/>
           </a:xfrm>
           <a:prstGeom prst="ellipse">
             <a:avLst/>
@@ -4564,7 +4282,7 @@
       </p:sp>
       <p:pic>
         <p:nvPicPr>
-          <p:cNvPr id="4" name="icon-FaBook" descr="C:\Users\Thanam\AppData\Local\Temp\claude\c--Projekt-Trainings-azure-basics-training\a7a6b8eb-22f3-4b42-aecc-5af05d1502b1\scratchpad\folien\assets\icons\FaBook.png">    </p:cNvPr>
+          <p:cNvPr id="6" name="icon-FaQuestionCircle" descr="C:\Users\Thanam\AppData\Local\Temp\claude\c--Projekt-Trainings-azure-basics-training\d01384da-f513-40b3-985e-441cf1c86f9e\scratchpad\arbeit\assets\icons\FaQuestionCircle.png">    </p:cNvPr>
           <p:cNvPicPr>
             <a:picLocks noChangeAspect="1"/>
           </p:cNvPicPr>
@@ -4578,8 +4296,8 @@
         </p:blipFill>
         <p:spPr>
           <a:xfrm>
-            <a:off x="680314" y="2577694"/>
-            <a:ext cx="285293" cy="285293"/>
+            <a:off x="976579" y="3171139"/>
+            <a:ext cx="332842" cy="332842"/>
           </a:xfrm>
           <a:prstGeom prst="rect">
             <a:avLst/>
@@ -4588,14 +4306,14 @@
       </p:pic>
       <p:sp>
         <p:nvSpPr>
-          <p:cNvPr id="5" name="Text 2"/>
+          <p:cNvPr id="7" name="Text 4"/>
           <p:cNvSpPr txBox="1"/>
           <p:nvPr/>
         </p:nvSpPr>
         <p:spPr>
           <a:xfrm>
-            <a:off x="1325880" y="2240280"/>
-            <a:ext cx="10317175" cy="960120"/>
+            <a:off x="1645920" y="3017520"/>
+            <a:ext cx="2189378" cy="640080"/>
           </a:xfrm>
           <a:prstGeom prst="rect">
             <a:avLst/>
@@ -4604,48 +4322,102 @@
           <a:ln/>
         </p:spPr>
         <p:txBody>
-          <a:bodyPr wrap="square" lIns="0" tIns="0" rIns="0" bIns="0" rtlCol="0" anchor="ctr"/>
+          <a:bodyPr wrap="square" lIns="0" tIns="0" rIns="0" bIns="0" rtlCol="0" anchor="ctr">
+            <a:normAutofit/>
+          </a:bodyPr>
           <a:lstStyle/>
           <a:p>
             <a:pPr indent="0" marL="0">
               <a:buNone/>
             </a:pPr>
             <a:r>
-              <a:rPr lang="en-US" sz="1800" b="1" dirty="0">
+              <a:rPr lang="en-US" sz="2000" b="1" dirty="0">
                 <a:solidFill>
                   <a:srgbClr val="27303A"/>
                 </a:solidFill>
               </a:rPr>
-              <a:t>Theorie</a:t>
-            </a:r>
-            <a:endParaRPr lang="en-US" sz="1800" dirty="0"/>
-          </a:p>
+              <a:t>Hypervisor</a:t>
+            </a:r>
+            <a:endParaRPr lang="en-US" sz="2000" dirty="0"/>
+          </a:p>
+        </p:txBody>
+      </p:sp>
+      <p:sp>
+        <p:nvSpPr>
+          <p:cNvPr id="8" name="Text 5"/>
+          <p:cNvSpPr txBox="1"/>
+          <p:nvPr/>
+        </p:nvSpPr>
+        <p:spPr>
+          <a:xfrm>
+            <a:off x="822960" y="3840480"/>
+            <a:ext cx="2966618" cy="1234440"/>
+          </a:xfrm>
+          <a:prstGeom prst="rect">
+            <a:avLst/>
+          </a:prstGeom>
+          <a:noFill/>
+          <a:ln/>
+        </p:spPr>
+        <p:txBody>
+          <a:bodyPr wrap="square" lIns="0" tIns="0" rIns="0" bIns="0" rtlCol="0" anchor="t"/>
+          <a:lstStyle/>
           <a:p>
             <a:pPr indent="0" marL="0">
-              <a:buNone/>
-            </a:pPr>
-            <a:r>
-              <a:rPr lang="en-US" sz="1800" dirty="0">
-                <a:solidFill>
-                  <a:srgbClr val="6F6F6F"/>
-                </a:solidFill>
-              </a:rPr>
-              <a:t>theorie/01-virtualisierung.md</a:t>
-            </a:r>
-            <a:endParaRPr lang="en-US" sz="1800" dirty="0"/>
-          </a:p>
-        </p:txBody>
-      </p:sp>
-      <p:sp>
-        <p:nvSpPr>
-          <p:cNvPr id="6" name="icon-kreis-FaGraduationCap"/>
+              <a:spcAft>
+                <a:spcPts val="400"/>
+              </a:spcAft>
+              <a:buNone/>
+            </a:pPr>
+            <a:r>
+              <a:rPr lang="en-US" sz="1600" dirty="0">
+                <a:solidFill>
+                  <a:srgbClr val="27303A"/>
+                </a:solidFill>
+              </a:rPr>
+              <a:t>Typ 1 oder Typ 2: VirtualBox, Hyper-V?</a:t>
+            </a:r>
+            <a:endParaRPr lang="en-US" sz="1600" dirty="0"/>
+          </a:p>
+        </p:txBody>
+      </p:sp>
+      <p:sp>
+        <p:nvSpPr>
+          <p:cNvPr id="9" name="karte"/>
           <p:cNvSpPr/>
           <p:nvPr/>
         </p:nvSpPr>
         <p:spPr>
           <a:xfrm>
-            <a:off x="548640" y="3406140"/>
-            <a:ext cx="548640" cy="548640"/>
+            <a:off x="4338218" y="2743200"/>
+            <a:ext cx="3515258" cy="2468880"/>
+          </a:xfrm>
+          <a:prstGeom prst="roundRect">
+            <a:avLst>
+              <a:gd name="adj" fmla="val 4444"/>
+            </a:avLst>
+          </a:prstGeom>
+          <a:solidFill>
+            <a:srgbClr val="F7F7F7"/>
+          </a:solidFill>
+          <a:ln w="12700">
+            <a:solidFill>
+              <a:srgbClr val="F7F7F7"/>
+            </a:solidFill>
+            <a:prstDash val="solid"/>
+          </a:ln>
+        </p:spPr>
+      </p:sp>
+      <p:sp>
+        <p:nvSpPr>
+          <p:cNvPr id="10" name="icon-kreis-FaQuestionCircle"/>
+          <p:cNvSpPr/>
+          <p:nvPr/>
+        </p:nvSpPr>
+        <p:spPr>
+          <a:xfrm>
+            <a:off x="4612538" y="3017520"/>
+            <a:ext cx="640080" cy="640080"/>
           </a:xfrm>
           <a:prstGeom prst="ellipse">
             <a:avLst/>
@@ -4663,7 +4435,7 @@
       </p:sp>
       <p:pic>
         <p:nvPicPr>
-          <p:cNvPr id="7" name="icon-FaGraduationCap" descr="C:\Users\Thanam\AppData\Local\Temp\claude\c--Projekt-Trainings-azure-basics-training\a7a6b8eb-22f3-4b42-aecc-5af05d1502b1\scratchpad\folien\assets\icons\FaGraduationCap.png">    </p:cNvPr>
+          <p:cNvPr id="11" name="icon-FaQuestionCircle" descr="C:\Users\Thanam\AppData\Local\Temp\claude\c--Projekt-Trainings-azure-basics-training\d01384da-f513-40b3-985e-441cf1c86f9e\scratchpad\arbeit\assets\icons\FaQuestionCircle.png">    </p:cNvPr>
           <p:cNvPicPr>
             <a:picLocks noChangeAspect="1"/>
           </p:cNvPicPr>
@@ -4677,8 +4449,8 @@
         </p:blipFill>
         <p:spPr>
           <a:xfrm>
-            <a:off x="680314" y="3537814"/>
-            <a:ext cx="285293" cy="285293"/>
+            <a:off x="4766158" y="3171139"/>
+            <a:ext cx="332842" cy="332842"/>
           </a:xfrm>
           <a:prstGeom prst="rect">
             <a:avLst/>
@@ -4687,14 +4459,14 @@
       </p:pic>
       <p:sp>
         <p:nvSpPr>
-          <p:cNvPr id="8" name="Text 4"/>
+          <p:cNvPr id="12" name="Text 8"/>
           <p:cNvSpPr txBox="1"/>
           <p:nvPr/>
         </p:nvSpPr>
         <p:spPr>
           <a:xfrm>
-            <a:off x="1325880" y="3200400"/>
-            <a:ext cx="10317175" cy="960120"/>
+            <a:off x="5435498" y="3017520"/>
+            <a:ext cx="2189378" cy="640080"/>
           </a:xfrm>
           <a:prstGeom prst="rect">
             <a:avLst/>
@@ -4703,48 +4475,102 @@
           <a:ln/>
         </p:spPr>
         <p:txBody>
-          <a:bodyPr wrap="square" lIns="0" tIns="0" rIns="0" bIns="0" rtlCol="0" anchor="ctr"/>
+          <a:bodyPr wrap="square" lIns="0" tIns="0" rIns="0" bIns="0" rtlCol="0" anchor="ctr">
+            <a:normAutofit/>
+          </a:bodyPr>
           <a:lstStyle/>
           <a:p>
             <a:pPr indent="0" marL="0">
               <a:buNone/>
             </a:pPr>
             <a:r>
-              <a:rPr lang="en-US" sz="1800" b="1" dirty="0">
+              <a:rPr lang="en-US" sz="2000" b="1" dirty="0">
                 <a:solidFill>
                   <a:srgbClr val="27303A"/>
                 </a:solidFill>
               </a:rPr>
-              <a:t>Microsoft und Canonical</a:t>
-            </a:r>
-            <a:endParaRPr lang="en-US" sz="1800" dirty="0"/>
-          </a:p>
+              <a:t>cloud-init</a:t>
+            </a:r>
+            <a:endParaRPr lang="en-US" sz="2000" dirty="0"/>
+          </a:p>
+        </p:txBody>
+      </p:sp>
+      <p:sp>
+        <p:nvSpPr>
+          <p:cNvPr id="13" name="Text 9"/>
+          <p:cNvSpPr txBox="1"/>
+          <p:nvPr/>
+        </p:nvSpPr>
+        <p:spPr>
+          <a:xfrm>
+            <a:off x="4612538" y="3840480"/>
+            <a:ext cx="2966618" cy="1234440"/>
+          </a:xfrm>
+          <a:prstGeom prst="rect">
+            <a:avLst/>
+          </a:prstGeom>
+          <a:noFill/>
+          <a:ln/>
+        </p:spPr>
+        <p:txBody>
+          <a:bodyPr wrap="square" lIns="0" tIns="0" rIns="0" bIns="0" rtlCol="0" anchor="t"/>
+          <a:lstStyle/>
           <a:p>
             <a:pPr indent="0" marL="0">
-              <a:buNone/>
-            </a:pPr>
-            <a:r>
-              <a:rPr lang="en-US" sz="1800" dirty="0">
-                <a:solidFill>
-                  <a:srgbClr val="6F6F6F"/>
-                </a:solidFill>
-              </a:rPr>
-              <a:t>Was ist Virtualisierung? · Multipass-Dokumentation</a:t>
-            </a:r>
-            <a:endParaRPr lang="en-US" sz="1800" dirty="0"/>
-          </a:p>
-        </p:txBody>
-      </p:sp>
-      <p:sp>
-        <p:nvSpPr>
-          <p:cNvPr id="9" name="icon-kreis-FaBook"/>
+              <a:spcAft>
+                <a:spcPts val="400"/>
+              </a:spcAft>
+              <a:buNone/>
+            </a:pPr>
+            <a:r>
+              <a:rPr lang="en-US" sz="1600" dirty="0">
+                <a:solidFill>
+                  <a:srgbClr val="27303A"/>
+                </a:solidFill>
+              </a:rPr>
+              <a:t>Wann arbeitet cloud-init die Datei ab?</a:t>
+            </a:r>
+            <a:endParaRPr lang="en-US" sz="1600" dirty="0"/>
+          </a:p>
+        </p:txBody>
+      </p:sp>
+      <p:sp>
+        <p:nvSpPr>
+          <p:cNvPr id="14" name="karte"/>
           <p:cNvSpPr/>
           <p:nvPr/>
         </p:nvSpPr>
         <p:spPr>
           <a:xfrm>
-            <a:off x="548640" y="4366260"/>
-            <a:ext cx="548640" cy="548640"/>
+            <a:off x="8127797" y="2743200"/>
+            <a:ext cx="3515258" cy="2468880"/>
+          </a:xfrm>
+          <a:prstGeom prst="roundRect">
+            <a:avLst>
+              <a:gd name="adj" fmla="val 4444"/>
+            </a:avLst>
+          </a:prstGeom>
+          <a:solidFill>
+            <a:srgbClr val="F7F7F7"/>
+          </a:solidFill>
+          <a:ln w="12700">
+            <a:solidFill>
+              <a:srgbClr val="F7F7F7"/>
+            </a:solidFill>
+            <a:prstDash val="solid"/>
+          </a:ln>
+        </p:spPr>
+      </p:sp>
+      <p:sp>
+        <p:nvSpPr>
+          <p:cNvPr id="15" name="icon-kreis-FaQuestionCircle"/>
+          <p:cNvSpPr/>
+          <p:nvPr/>
+        </p:nvSpPr>
+        <p:spPr>
+          <a:xfrm>
+            <a:off x="8402117" y="3017520"/>
+            <a:ext cx="640080" cy="640080"/>
           </a:xfrm>
           <a:prstGeom prst="ellipse">
             <a:avLst/>
@@ -4762,7 +4588,7 @@
       </p:sp>
       <p:pic>
         <p:nvPicPr>
-          <p:cNvPr id="10" name="icon-FaBook" descr="C:\Users\Thanam\AppData\Local\Temp\claude\c--Projekt-Trainings-azure-basics-training\a7a6b8eb-22f3-4b42-aecc-5af05d1502b1\scratchpad\folien\assets\icons\FaBook.png">    </p:cNvPr>
+          <p:cNvPr id="16" name="icon-FaQuestionCircle" descr="C:\Users\Thanam\AppData\Local\Temp\claude\c--Projekt-Trainings-azure-basics-training\d01384da-f513-40b3-985e-441cf1c86f9e\scratchpad\arbeit\assets\icons\FaQuestionCircle.png">    </p:cNvPr>
           <p:cNvPicPr>
             <a:picLocks noChangeAspect="1"/>
           </p:cNvPicPr>
@@ -4776,8 +4602,8 @@
         </p:blipFill>
         <p:spPr>
           <a:xfrm>
-            <a:off x="680314" y="4497934"/>
-            <a:ext cx="285293" cy="285293"/>
+            <a:off x="8555736" y="3171139"/>
+            <a:ext cx="332842" cy="332842"/>
           </a:xfrm>
           <a:prstGeom prst="rect">
             <a:avLst/>
@@ -4786,14 +4612,14 @@
       </p:pic>
       <p:sp>
         <p:nvSpPr>
-          <p:cNvPr id="11" name="Text 6"/>
+          <p:cNvPr id="17" name="Text 12"/>
           <p:cNvSpPr txBox="1"/>
           <p:nvPr/>
         </p:nvSpPr>
         <p:spPr>
           <a:xfrm>
-            <a:off x="1325880" y="4160520"/>
-            <a:ext cx="10317175" cy="960120"/>
+            <a:off x="9225077" y="3017520"/>
+            <a:ext cx="2189378" cy="640080"/>
           </a:xfrm>
           <a:prstGeom prst="rect">
             <a:avLst/>
@@ -4802,35 +4628,62 @@
           <a:ln/>
         </p:spPr>
         <p:txBody>
-          <a:bodyPr wrap="square" lIns="0" tIns="0" rIns="0" bIns="0" rtlCol="0" anchor="ctr"/>
+          <a:bodyPr wrap="square" lIns="0" tIns="0" rIns="0" bIns="0" rtlCol="0" anchor="ctr">
+            <a:normAutofit/>
+          </a:bodyPr>
           <a:lstStyle/>
           <a:p>
             <a:pPr indent="0" marL="0">
               <a:buNone/>
             </a:pPr>
             <a:r>
-              <a:rPr lang="en-US" sz="1800" b="1" dirty="0">
+              <a:rPr lang="en-US" sz="2000" b="1" dirty="0">
                 <a:solidFill>
                   <a:srgbClr val="27303A"/>
                 </a:solidFill>
               </a:rPr>
-              <a:t>TBZ M346</a:t>
-            </a:r>
-            <a:endParaRPr lang="en-US" sz="1800" dirty="0"/>
-          </a:p>
+              <a:t>Docker</a:t>
+            </a:r>
+            <a:endParaRPr lang="en-US" sz="2000" dirty="0"/>
+          </a:p>
+        </p:txBody>
+      </p:sp>
+      <p:sp>
+        <p:nvSpPr>
+          <p:cNvPr id="18" name="Text 13"/>
+          <p:cNvSpPr txBox="1"/>
+          <p:nvPr/>
+        </p:nvSpPr>
+        <p:spPr>
+          <a:xfrm>
+            <a:off x="8402117" y="3840480"/>
+            <a:ext cx="2966618" cy="1234440"/>
+          </a:xfrm>
+          <a:prstGeom prst="rect">
+            <a:avLst/>
+          </a:prstGeom>
+          <a:noFill/>
+          <a:ln/>
+        </p:spPr>
+        <p:txBody>
+          <a:bodyPr wrap="square" lIns="0" tIns="0" rIns="0" bIns="0" rtlCol="0" anchor="t"/>
+          <a:lstStyle/>
           <a:p>
             <a:pPr indent="0" marL="0">
-              <a:buNone/>
-            </a:pPr>
-            <a:r>
-              <a:rPr lang="en-US" sz="1800" dirty="0">
-                <a:solidFill>
-                  <a:srgbClr val="6F6F6F"/>
-                </a:solidFill>
-              </a:rPr>
-              <a:t>Virtualisierung, Multipass, KN01 (übernommen und vereinfacht)</a:t>
-            </a:r>
-            <a:endParaRPr lang="en-US" sz="1800" dirty="0"/>
+              <a:spcAft>
+                <a:spcPts val="400"/>
+              </a:spcAft>
+              <a:buNone/>
+            </a:pPr>
+            <a:r>
+              <a:rPr lang="en-US" sz="1600" dirty="0">
+                <a:solidFill>
+                  <a:srgbClr val="27303A"/>
+                </a:solidFill>
+              </a:rPr>
+              <a:t>Ein Kollege sagt: «Docker ist auch ein Hypervisor.» Stimmt das?</a:t>
+            </a:r>
+            <a:endParaRPr lang="en-US" sz="1600" dirty="0"/>
           </a:p>
         </p:txBody>
       </p:sp>
@@ -4906,6 +4759,411 @@
       </p:grpSpPr>
       <p:sp>
         <p:nvSpPr>
+          <p:cNvPr id="2" name="Text 1"/>
+          <p:cNvSpPr/>
+          <p:nvPr>
+            <p:ph idx="102" type="title" hasCustomPrompt="1"/>
+          </p:nvPr>
+        </p:nvSpPr>
+        <p:spPr>
+          <a:xfrm>
+            <a:off x="548640" y="320040"/>
+            <a:ext cx="11094415" cy="822960"/>
+          </a:xfrm>
+          <a:prstGeom prst="rect">
+            <a:avLst/>
+          </a:prstGeom>
+          <a:noFill/>
+          <a:ln/>
+        </p:spPr>
+        <p:txBody>
+          <a:bodyPr wrap="square" lIns="0" tIns="0" rIns="0" bIns="0" rtlCol="0" anchor="ctr"/>
+          <a:lstStyle/>
+          <a:p>
+            <a:pPr algn="l" indent="0" marL="0">
+              <a:buNone/>
+            </a:pPr>
+            <a:r>
+              <a:rPr lang="en-US" sz="3400" b="1" dirty="0">
+                <a:solidFill>
+                  <a:srgbClr val="27303A"/>
+                </a:solidFill>
+              </a:rPr>
+              <a:t>Zum Nachlesen</a:t>
+            </a:r>
+            <a:endParaRPr lang="en-US" sz="3400" dirty="0"/>
+          </a:p>
+        </p:txBody>
+      </p:sp>
+      <p:sp>
+        <p:nvSpPr>
+          <p:cNvPr id="3" name="icon-kreis-FaBook"/>
+          <p:cNvSpPr/>
+          <p:nvPr/>
+        </p:nvSpPr>
+        <p:spPr>
+          <a:xfrm>
+            <a:off x="548640" y="2446020"/>
+            <a:ext cx="548640" cy="548640"/>
+          </a:xfrm>
+          <a:prstGeom prst="ellipse">
+            <a:avLst/>
+          </a:prstGeom>
+          <a:solidFill>
+            <a:srgbClr val="006FAD"/>
+          </a:solidFill>
+          <a:ln w="12700">
+            <a:solidFill>
+              <a:srgbClr val="006FAD"/>
+            </a:solidFill>
+            <a:prstDash val="solid"/>
+          </a:ln>
+        </p:spPr>
+      </p:sp>
+      <p:pic>
+        <p:nvPicPr>
+          <p:cNvPr id="4" name="icon-FaBook" descr="C:\Users\Thanam\AppData\Local\Temp\claude\c--Projekt-Trainings-azure-basics-training\d01384da-f513-40b3-985e-441cf1c86f9e\scratchpad\arbeit\assets\icons\FaBook.png">    </p:cNvPr>
+          <p:cNvPicPr>
+            <a:picLocks noChangeAspect="1"/>
+          </p:cNvPicPr>
+          <p:nvPr/>
+        </p:nvPicPr>
+        <p:blipFill>
+          <a:blip r:embed="rId1"/>
+          <a:stretch>
+            <a:fillRect/>
+          </a:stretch>
+        </p:blipFill>
+        <p:spPr>
+          <a:xfrm>
+            <a:off x="680314" y="2577694"/>
+            <a:ext cx="285293" cy="285293"/>
+          </a:xfrm>
+          <a:prstGeom prst="rect">
+            <a:avLst/>
+          </a:prstGeom>
+        </p:spPr>
+      </p:pic>
+      <p:sp>
+        <p:nvSpPr>
+          <p:cNvPr id="5" name="Text 2"/>
+          <p:cNvSpPr txBox="1"/>
+          <p:nvPr/>
+        </p:nvSpPr>
+        <p:spPr>
+          <a:xfrm>
+            <a:off x="1325880" y="2240280"/>
+            <a:ext cx="10317175" cy="960120"/>
+          </a:xfrm>
+          <a:prstGeom prst="rect">
+            <a:avLst/>
+          </a:prstGeom>
+          <a:noFill/>
+          <a:ln/>
+        </p:spPr>
+        <p:txBody>
+          <a:bodyPr wrap="square" lIns="0" tIns="0" rIns="0" bIns="0" rtlCol="0" anchor="ctr"/>
+          <a:lstStyle/>
+          <a:p>
+            <a:pPr indent="0" marL="0">
+              <a:buNone/>
+            </a:pPr>
+            <a:r>
+              <a:rPr lang="en-US" sz="1800" b="1" dirty="0">
+                <a:solidFill>
+                  <a:srgbClr val="27303A"/>
+                </a:solidFill>
+              </a:rPr>
+              <a:t>Theorie</a:t>
+            </a:r>
+            <a:endParaRPr lang="en-US" sz="1800" dirty="0"/>
+          </a:p>
+          <a:p>
+            <a:pPr indent="0" marL="0">
+              <a:buNone/>
+            </a:pPr>
+            <a:r>
+              <a:rPr lang="en-US" sz="1800" dirty="0">
+                <a:solidFill>
+                  <a:srgbClr val="6F6F6F"/>
+                </a:solidFill>
+              </a:rPr>
+              <a:t>theorie/01-virtualisierung.md</a:t>
+            </a:r>
+            <a:endParaRPr lang="en-US" sz="1800" dirty="0"/>
+          </a:p>
+        </p:txBody>
+      </p:sp>
+      <p:sp>
+        <p:nvSpPr>
+          <p:cNvPr id="6" name="icon-kreis-FaGraduationCap"/>
+          <p:cNvSpPr/>
+          <p:nvPr/>
+        </p:nvSpPr>
+        <p:spPr>
+          <a:xfrm>
+            <a:off x="548640" y="3406140"/>
+            <a:ext cx="548640" cy="548640"/>
+          </a:xfrm>
+          <a:prstGeom prst="ellipse">
+            <a:avLst/>
+          </a:prstGeom>
+          <a:solidFill>
+            <a:srgbClr val="006FAD"/>
+          </a:solidFill>
+          <a:ln w="12700">
+            <a:solidFill>
+              <a:srgbClr val="006FAD"/>
+            </a:solidFill>
+            <a:prstDash val="solid"/>
+          </a:ln>
+        </p:spPr>
+      </p:sp>
+      <p:pic>
+        <p:nvPicPr>
+          <p:cNvPr id="7" name="icon-FaGraduationCap" descr="C:\Users\Thanam\AppData\Local\Temp\claude\c--Projekt-Trainings-azure-basics-training\d01384da-f513-40b3-985e-441cf1c86f9e\scratchpad\arbeit\assets\icons\FaGraduationCap.png">    </p:cNvPr>
+          <p:cNvPicPr>
+            <a:picLocks noChangeAspect="1"/>
+          </p:cNvPicPr>
+          <p:nvPr/>
+        </p:nvPicPr>
+        <p:blipFill>
+          <a:blip r:embed="rId2"/>
+          <a:stretch>
+            <a:fillRect/>
+          </a:stretch>
+        </p:blipFill>
+        <p:spPr>
+          <a:xfrm>
+            <a:off x="680314" y="3537814"/>
+            <a:ext cx="285293" cy="285293"/>
+          </a:xfrm>
+          <a:prstGeom prst="rect">
+            <a:avLst/>
+          </a:prstGeom>
+        </p:spPr>
+      </p:pic>
+      <p:sp>
+        <p:nvSpPr>
+          <p:cNvPr id="8" name="Text 4"/>
+          <p:cNvSpPr txBox="1"/>
+          <p:nvPr/>
+        </p:nvSpPr>
+        <p:spPr>
+          <a:xfrm>
+            <a:off x="1325880" y="3200400"/>
+            <a:ext cx="10317175" cy="960120"/>
+          </a:xfrm>
+          <a:prstGeom prst="rect">
+            <a:avLst/>
+          </a:prstGeom>
+          <a:noFill/>
+          <a:ln/>
+        </p:spPr>
+        <p:txBody>
+          <a:bodyPr wrap="square" lIns="0" tIns="0" rIns="0" bIns="0" rtlCol="0" anchor="ctr"/>
+          <a:lstStyle/>
+          <a:p>
+            <a:pPr indent="0" marL="0">
+              <a:buNone/>
+            </a:pPr>
+            <a:r>
+              <a:rPr lang="en-US" sz="1800" b="1" dirty="0">
+                <a:solidFill>
+                  <a:srgbClr val="27303A"/>
+                </a:solidFill>
+              </a:rPr>
+              <a:t>Microsoft und Canonical</a:t>
+            </a:r>
+            <a:endParaRPr lang="en-US" sz="1800" dirty="0"/>
+          </a:p>
+          <a:p>
+            <a:pPr indent="0" marL="0">
+              <a:buNone/>
+            </a:pPr>
+            <a:r>
+              <a:rPr lang="en-US" sz="1800" dirty="0">
+                <a:solidFill>
+                  <a:srgbClr val="6F6F6F"/>
+                </a:solidFill>
+              </a:rPr>
+              <a:t>Was ist Virtualisierung? · Multipass-Dokumentation</a:t>
+            </a:r>
+            <a:endParaRPr lang="en-US" sz="1800" dirty="0"/>
+          </a:p>
+        </p:txBody>
+      </p:sp>
+      <p:sp>
+        <p:nvSpPr>
+          <p:cNvPr id="9" name="icon-kreis-FaBook"/>
+          <p:cNvSpPr/>
+          <p:nvPr/>
+        </p:nvSpPr>
+        <p:spPr>
+          <a:xfrm>
+            <a:off x="548640" y="4366260"/>
+            <a:ext cx="548640" cy="548640"/>
+          </a:xfrm>
+          <a:prstGeom prst="ellipse">
+            <a:avLst/>
+          </a:prstGeom>
+          <a:solidFill>
+            <a:srgbClr val="006FAD"/>
+          </a:solidFill>
+          <a:ln w="12700">
+            <a:solidFill>
+              <a:srgbClr val="006FAD"/>
+            </a:solidFill>
+            <a:prstDash val="solid"/>
+          </a:ln>
+        </p:spPr>
+      </p:sp>
+      <p:pic>
+        <p:nvPicPr>
+          <p:cNvPr id="10" name="icon-FaBook" descr="C:\Users\Thanam\AppData\Local\Temp\claude\c--Projekt-Trainings-azure-basics-training\d01384da-f513-40b3-985e-441cf1c86f9e\scratchpad\arbeit\assets\icons\FaBook.png">    </p:cNvPr>
+          <p:cNvPicPr>
+            <a:picLocks noChangeAspect="1"/>
+          </p:cNvPicPr>
+          <p:nvPr/>
+        </p:nvPicPr>
+        <p:blipFill>
+          <a:blip r:embed="rId3"/>
+          <a:stretch>
+            <a:fillRect/>
+          </a:stretch>
+        </p:blipFill>
+        <p:spPr>
+          <a:xfrm>
+            <a:off x="680314" y="4497934"/>
+            <a:ext cx="285293" cy="285293"/>
+          </a:xfrm>
+          <a:prstGeom prst="rect">
+            <a:avLst/>
+          </a:prstGeom>
+        </p:spPr>
+      </p:pic>
+      <p:sp>
+        <p:nvSpPr>
+          <p:cNvPr id="11" name="Text 6"/>
+          <p:cNvSpPr txBox="1"/>
+          <p:nvPr/>
+        </p:nvSpPr>
+        <p:spPr>
+          <a:xfrm>
+            <a:off x="1325880" y="4160520"/>
+            <a:ext cx="10317175" cy="960120"/>
+          </a:xfrm>
+          <a:prstGeom prst="rect">
+            <a:avLst/>
+          </a:prstGeom>
+          <a:noFill/>
+          <a:ln/>
+        </p:spPr>
+        <p:txBody>
+          <a:bodyPr wrap="square" lIns="0" tIns="0" rIns="0" bIns="0" rtlCol="0" anchor="ctr"/>
+          <a:lstStyle/>
+          <a:p>
+            <a:pPr indent="0" marL="0">
+              <a:buNone/>
+            </a:pPr>
+            <a:r>
+              <a:rPr lang="en-US" sz="1800" b="1" dirty="0">
+                <a:solidFill>
+                  <a:srgbClr val="27303A"/>
+                </a:solidFill>
+              </a:rPr>
+              <a:t>TBZ M346</a:t>
+            </a:r>
+            <a:endParaRPr lang="en-US" sz="1800" dirty="0"/>
+          </a:p>
+          <a:p>
+            <a:pPr indent="0" marL="0">
+              <a:buNone/>
+            </a:pPr>
+            <a:r>
+              <a:rPr lang="en-US" sz="1800" dirty="0">
+                <a:solidFill>
+                  <a:srgbClr val="6F6F6F"/>
+                </a:solidFill>
+              </a:rPr>
+              <a:t>Virtualisierung, Multipass, SSH, KN01 (übernommen und vereinfacht)</a:t>
+            </a:r>
+            <a:endParaRPr lang="en-US" sz="1800" dirty="0"/>
+          </a:p>
+        </p:txBody>
+      </p:sp>
+      <p:sp>
+        <p:nvSpPr>
+          <p:cNvPr id="25" name="Slide Number Placeholder 0"/>
+          <p:cNvSpPr>
+            <a:spLocks noGrp="1"/>
+          </p:cNvSpPr>
+          <p:nvPr>
+            <p:ph type="sldNum" sz="quarter" idx="4294967295"/>
+          </p:nvPr>
+        </p:nvSpPr>
+        <p:spPr>
+          <a:xfrm>
+            <a:off x="11183112" y="6336792"/>
+            <a:ext cx="457200" cy="365760"/>
+          </a:xfrm>
+          <a:prstGeom prst="rect">
+            <a:avLst/>
+          </a:prstGeom>
+          <a:extLst>
+            <a:ext uri="{C572A759-6A51-4108-AA02-DFA0A04FC94B}">
+              <ma14:wrappingTextBoxFlag xmlns:ma14="http://schemas.microsoft.com/office/mac/drawingml/2011/main" val="0"/>
+            </a:ext>
+          </a:extLst>
+        </p:spPr>
+        <p:txBody>
+          <a:bodyPr/>
+          <a:lstStyle>
+            <a:lvl1pPr>
+              <a:defRPr sz="1000">
+                <a:solidFill>
+                  <a:srgbClr val="6F6F6F"/>
+                </a:solidFill>
+              </a:defRPr>
+            </a:lvl1pPr>
+          </a:lstStyle>
+          <a:p>
+            <a:pPr algn="r"/>
+            <a:fld id="{F7021451-1387-4CA6-816F-3879F97B5CBC}" type="slidenum">
+              <a:rPr b="0" lang="en-US"/>
+              <a:t>14</a:t>
+            </a:fld>
+            <a:endParaRPr lang="en-US"/>
+          </a:p>
+        </p:txBody>
+      </p:sp>
+    </p:spTree>
+  </p:cSld>
+  <p:clrMapOvr>
+    <a:masterClrMapping/>
+  </p:clrMapOvr>
+</p:sld>
+</file>
+
+<file path=ppt/slides/slide15.xml><?xml version="1.0" encoding="utf-8"?>
+<p:sld xmlns:a="http://schemas.openxmlformats.org/drawingml/2006/main" xmlns:r="http://schemas.openxmlformats.org/officeDocument/2006/relationships" xmlns:p="http://schemas.openxmlformats.org/presentationml/2006/main">
+  <p:cSld name="Slide 15">
+    <p:spTree>
+      <p:nvGrpSpPr>
+        <p:cNvPr id="1" name=""/>
+        <p:cNvGrpSpPr/>
+        <p:nvPr/>
+      </p:nvGrpSpPr>
+      <p:grpSpPr>
+        <a:xfrm>
+          <a:off x="0" y="0"/>
+          <a:ext cx="0" cy="0"/>
+          <a:chOff x="0" y="0"/>
+          <a:chExt cx="0" cy="0"/>
+        </a:xfrm>
+      </p:grpSpPr>
+      <p:sp>
+        <p:nvSpPr>
           <p:cNvPr id="2" name="Text 0"/>
           <p:cNvSpPr/>
           <p:nvPr>
@@ -5097,7 +5355,7 @@
       </p:sp>
       <p:pic>
         <p:nvPicPr>
-          <p:cNvPr id="5" name="icon-FaLayerGroup" descr="C:\Users\Thanam\AppData\Local\Temp\claude\c--Projekt-Trainings-azure-basics-training\a7a6b8eb-22f3-4b42-aecc-5af05d1502b1\scratchpad\folien\assets\icons\FaLayerGroup.png">    </p:cNvPr>
+          <p:cNvPr id="5" name="icon-FaLayerGroup" descr="C:\Users\Thanam\AppData\Local\Temp\claude\c--Projekt-Trainings-azure-basics-training\d01384da-f513-40b3-985e-441cf1c86f9e\scratchpad\arbeit\assets\icons\FaLayerGroup.png">    </p:cNvPr>
           <p:cNvPicPr>
             <a:picLocks noChangeAspect="1"/>
           </p:cNvPicPr>
@@ -5250,7 +5508,7 @@
       </p:sp>
       <p:pic>
         <p:nvPicPr>
-          <p:cNvPr id="10" name="icon-FaMemory" descr="C:\Users\Thanam\AppData\Local\Temp\claude\c--Projekt-Trainings-azure-basics-training\a7a6b8eb-22f3-4b42-aecc-5af05d1502b1\scratchpad\folien\assets\icons\FaMemory.png">    </p:cNvPr>
+          <p:cNvPr id="10" name="icon-FaMemory" descr="C:\Users\Thanam\AppData\Local\Temp\claude\c--Projekt-Trainings-azure-basics-training\d01384da-f513-40b3-985e-441cf1c86f9e\scratchpad\arbeit\assets\icons\FaMemory.png">    </p:cNvPr>
           <p:cNvPicPr>
             <a:picLocks noChangeAspect="1"/>
           </p:cNvPicPr>
@@ -5403,7 +5661,7 @@
       </p:sp>
       <p:pic>
         <p:nvPicPr>
-          <p:cNvPr id="15" name="icon-FaRocket" descr="C:\Users\Thanam\AppData\Local\Temp\claude\c--Projekt-Trainings-azure-basics-training\a7a6b8eb-22f3-4b42-aecc-5af05d1502b1\scratchpad\folien\assets\icons\FaRocket.png">    </p:cNvPr>
+          <p:cNvPr id="15" name="icon-FaRocket" descr="C:\Users\Thanam\AppData\Local\Temp\claude\c--Projekt-Trainings-azure-basics-training\d01384da-f513-40b3-985e-441cf1c86f9e\scratchpad\arbeit\assets\icons\FaRocket.png">    </p:cNvPr>
           <p:cNvPicPr>
             <a:picLocks noChangeAspect="1"/>
           </p:cNvPicPr>
@@ -5556,7 +5814,7 @@
       </p:sp>
       <p:pic>
         <p:nvPicPr>
-          <p:cNvPr id="20" name="icon-FaKey" descr="C:\Users\Thanam\AppData\Local\Temp\claude\c--Projekt-Trainings-azure-basics-training\a7a6b8eb-22f3-4b42-aecc-5af05d1502b1\scratchpad\folien\assets\icons\FaKey.png">    </p:cNvPr>
+          <p:cNvPr id="20" name="icon-FaKey" descr="C:\Users\Thanam\AppData\Local\Temp\claude\c--Projekt-Trainings-azure-basics-training\d01384da-f513-40b3-985e-441cf1c86f9e\scratchpad\arbeit\assets\icons\FaKey.png">    </p:cNvPr>
           <p:cNvPicPr>
             <a:picLocks noChangeAspect="1"/>
           </p:cNvPicPr>
@@ -5817,7 +6075,7 @@
       </p:sp>
       <p:pic>
         <p:nvPicPr>
-          <p:cNvPr id="5" name="icon-FaBuilding" descr="C:\Users\Thanam\AppData\Local\Temp\claude\c--Projekt-Trainings-azure-basics-training\a7a6b8eb-22f3-4b42-aecc-5af05d1502b1\scratchpad\folien\assets\icons\FaBuilding.png">    </p:cNvPr>
+          <p:cNvPr id="5" name="icon-FaBuilding" descr="C:\Users\Thanam\AppData\Local\Temp\claude\c--Projekt-Trainings-azure-basics-training\d01384da-f513-40b3-985e-441cf1c86f9e\scratchpad\arbeit\assets\icons\FaBuilding.png">    </p:cNvPr>
           <p:cNvPicPr>
             <a:picLocks noChangeAspect="1"/>
           </p:cNvPicPr>
@@ -6263,7 +6521,7 @@
       </p:sp>
       <p:pic>
         <p:nvPicPr>
-          <p:cNvPr id="5" name="icon-FaServer" descr="C:\Users\Thanam\AppData\Local\Temp\claude\c--Projekt-Trainings-azure-basics-training\a7a6b8eb-22f3-4b42-aecc-5af05d1502b1\scratchpad\folien\assets\icons\FaServer.png">    </p:cNvPr>
+          <p:cNvPr id="5" name="icon-FaServer" descr="C:\Users\Thanam\AppData\Local\Temp\claude\c--Projekt-Trainings-azure-basics-training\d01384da-f513-40b3-985e-441cf1c86f9e\scratchpad\arbeit\assets\icons\FaServer.png">    </p:cNvPr>
           <p:cNvPicPr>
             <a:picLocks noChangeAspect="1"/>
           </p:cNvPicPr>
@@ -6469,7 +6727,7 @@
       </p:sp>
       <p:pic>
         <p:nvPicPr>
-          <p:cNvPr id="10" name="icon-FaLaptop" descr="C:\Users\Thanam\AppData\Local\Temp\claude\c--Projekt-Trainings-azure-basics-training\a7a6b8eb-22f3-4b42-aecc-5af05d1502b1\scratchpad\folien\assets\icons\FaLaptop.png">    </p:cNvPr>
+          <p:cNvPr id="10" name="icon-FaLaptop" descr="C:\Users\Thanam\AppData\Local\Temp\claude\c--Projekt-Trainings-azure-basics-training\d01384da-f513-40b3-985e-441cf1c86f9e\scratchpad\arbeit\assets\icons\FaLaptop.png">    </p:cNvPr>
           <p:cNvPicPr>
             <a:picLocks noChangeAspect="1"/>
           </p:cNvPicPr>

</xml_diff>